<commit_message>
Add worked-examples slide: how each monthly pair is judged
Five cell-by-cell examples (including the teacher-only-in-month-1 case)
showing that the verdict is strictly month m vs month m+12, never any-of-
the-first-four vs any-of-the-last-four.

Co-Authored-By: Claude Fable 5 <noreply@anthropic.com>
Claude-Session: https://claude.ai/code/session_01DNzQPDcr3zfLTraMHUHqUn
</commit_message>
<xml_diff>
--- a/report/figures_deck/tech_slides_v3.pptx
+++ b/report/figures_deck/tech_slides_v3.pptx
@@ -11,9 +11,10 @@
     <p:sldId id="259" r:id="rId5"/>
     <p:sldId id="260" r:id="rId6"/>
     <p:sldId id="261" r:id="rId7"/>
+    <p:sldId id="262" r:id="rId8"/>
   </p:sldIdLst>
   <p:notesMasterIdLst>
-    <p:notesMasterId r:id="rId8"/>
+    <p:notesMasterId r:id="rId9"/>
   </p:notesMasterIdLst>
   <p:sldSz cx="12192000" cy="6858000"/>
   <p:notesSz cx="6858000" cy="12192000"/>
@@ -971,6 +972,94 @@
             <a:fld id="{F7021451-1387-4CA6-816F-3879F97B5CBC}" type="slidenum">
               <a:rPr lang="en-US"/>
               <a:t>6</a:t>
+            </a:fld>
+            <a:endParaRPr lang="en-US"/>
+          </a:p>
+        </p:txBody>
+      </p:sp>
+    </p:spTree>
+    <p:extLst>
+      <p:ext uri="{BB962C8B-B14F-4D97-AF65-F5344CB8AC3E}">
+        <p14:creationId xmlns:p14="http://schemas.microsoft.com/office/powerpoint/2010/main" val="1024086991"/>
+      </p:ext>
+    </p:extLst>
+  </p:cSld>
+  <p:clrMapOvr>
+    <a:masterClrMapping/>
+  </p:clrMapOvr>
+</p:notes>
+</file>
+
+<file path=ppt/notesSlides/notesSlide7.xml><?xml version="1.0" encoding="utf-8"?>
+<p:notes xmlns:a="http://schemas.openxmlformats.org/drawingml/2006/main" xmlns:r="http://schemas.openxmlformats.org/officeDocument/2006/relationships" xmlns:p="http://schemas.openxmlformats.org/presentationml/2006/main">
+  <p:cSld>
+    <p:spTree>
+      <p:nvGrpSpPr>
+        <p:cNvPr id="1" name=""/>
+        <p:cNvGrpSpPr/>
+        <p:nvPr/>
+      </p:nvGrpSpPr>
+      <p:grpSpPr>
+        <a:xfrm>
+          <a:off x="0" y="0"/>
+          <a:ext cx="0" cy="0"/>
+          <a:chOff x="0" y="0"/>
+          <a:chExt cx="0" cy="0"/>
+        </a:xfrm>
+      </p:grpSpPr>
+      <p:sp>
+        <p:nvSpPr>
+          <p:cNvPr id="2" name="Slide Image Placeholder 1"/>
+          <p:cNvSpPr>
+            <a:spLocks noGrp="1" noRot="1" noChangeAspect="1"/>
+          </p:cNvSpPr>
+          <p:nvPr>
+            <p:ph type="sldImg"/>
+          </p:nvPr>
+        </p:nvSpPr>
+        <p:spPr/>
+      </p:sp>
+      <p:sp>
+        <p:nvSpPr>
+          <p:cNvPr id="3" name="Notes Placeholder 2"/>
+          <p:cNvSpPr>
+            <a:spLocks noGrp="1"/>
+          </p:cNvSpPr>
+          <p:nvPr>
+            <p:ph type="body" idx="1"/>
+          </p:nvPr>
+        </p:nvSpPr>
+        <p:spPr/>
+        <p:txBody>
+          <a:bodyPr/>
+          <a:lstStyle/>
+          <a:p>
+            <a:r>
+              <a:rPr lang="en-US" dirty="0"/>
+              <a:t/>
+            </a:r>
+            <a:endParaRPr lang="en-US" dirty="0"/>
+          </a:p>
+        </p:txBody>
+      </p:sp>
+      <p:sp>
+        <p:nvSpPr>
+          <p:cNvPr id="4" name="Slide Number Placeholder 3"/>
+          <p:cNvSpPr>
+            <a:spLocks noGrp="1"/>
+          </p:cNvSpPr>
+          <p:nvPr>
+            <p:ph type="sldNum" sz="quarter" idx="10"/>
+          </p:nvPr>
+        </p:nvSpPr>
+        <p:spPr/>
+        <p:txBody>
+          <a:bodyPr/>
+          <a:lstStyle/>
+          <a:p>
+            <a:fld id="{F7021451-1387-4CA6-816F-3879F97B5CBC}" type="slidenum">
+              <a:rPr lang="en-US"/>
+              <a:t>7</a:t>
             </a:fld>
             <a:endParaRPr lang="en-US"/>
           </a:p>
@@ -4071,7 +4160,7 @@
       </p:grpSpPr>
       <p:pic>
         <p:nvPicPr>
-          <p:cNvPr id="2" name="Image 0" descr="/tmp/claude-0/-home-user-Alternative-Pathways----Quant/37b5ad96-b2b0-50d1-9e4b-6301ff28b789/scratchpad/u4_twodefs.png">    </p:cNvPr>
+          <p:cNvPr id="2" name="Image 0" descr="/tmp/claude-0/-home-user-Alternative-Pathways----Quant/37b5ad96-b2b0-50d1-9e4b-6301ff28b789/scratchpad/u3b_examples.png">    </p:cNvPr>
           <p:cNvPicPr>
             <a:picLocks noChangeAspect="1"/>
           </p:cNvPicPr>
@@ -4127,7 +4216,7 @@
       </p:grpSpPr>
       <p:pic>
         <p:nvPicPr>
-          <p:cNvPr id="2" name="Image 0" descr="/tmp/claude-0/-home-user-Alternative-Pathways----Quant/37b5ad96-b2b0-50d1-9e4b-6301ff28b789/scratchpad/u5_bridge.png">    </p:cNvPr>
+          <p:cNvPr id="2" name="Image 0" descr="/tmp/claude-0/-home-user-Alternative-Pathways----Quant/37b5ad96-b2b0-50d1-9e4b-6301ff28b789/scratchpad/u4_twodefs.png">    </p:cNvPr>
           <p:cNvPicPr>
             <a:picLocks noChangeAspect="1"/>
           </p:cNvPicPr>
@@ -4160,6 +4249,62 @@
 <file path=ppt/slides/slide6.xml><?xml version="1.0" encoding="utf-8"?>
 <p:sld xmlns:a="http://schemas.openxmlformats.org/drawingml/2006/main" xmlns:r="http://schemas.openxmlformats.org/officeDocument/2006/relationships" xmlns:p="http://schemas.openxmlformats.org/presentationml/2006/main">
   <p:cSld name="Slide 6">
+    <p:bg>
+      <p:bgPr>
+        <a:solidFill>
+          <a:srgbClr val="FFFFFF"/>
+        </a:solidFill>
+      </p:bgPr>
+    </p:bg>
+    <p:spTree>
+      <p:nvGrpSpPr>
+        <p:cNvPr id="1" name=""/>
+        <p:cNvGrpSpPr/>
+        <p:nvPr/>
+      </p:nvGrpSpPr>
+      <p:grpSpPr>
+        <a:xfrm>
+          <a:off x="0" y="0"/>
+          <a:ext cx="0" cy="0"/>
+          <a:chOff x="0" y="0"/>
+          <a:chExt cx="0" cy="0"/>
+        </a:xfrm>
+      </p:grpSpPr>
+      <p:pic>
+        <p:nvPicPr>
+          <p:cNvPr id="2" name="Image 0" descr="/tmp/claude-0/-home-user-Alternative-Pathways----Quant/37b5ad96-b2b0-50d1-9e4b-6301ff28b789/scratchpad/u5_bridge.png">    </p:cNvPr>
+          <p:cNvPicPr>
+            <a:picLocks noChangeAspect="1"/>
+          </p:cNvPicPr>
+          <p:nvPr/>
+        </p:nvPicPr>
+        <p:blipFill>
+          <a:blip r:embed="rId1"/>
+          <a:stretch>
+            <a:fillRect/>
+          </a:stretch>
+        </p:blipFill>
+        <p:spPr>
+          <a:xfrm>
+            <a:off x="0" y="0"/>
+            <a:ext cx="12188952" cy="6858000"/>
+          </a:xfrm>
+          <a:prstGeom prst="rect">
+            <a:avLst/>
+          </a:prstGeom>
+        </p:spPr>
+      </p:pic>
+    </p:spTree>
+  </p:cSld>
+  <p:clrMapOvr>
+    <a:masterClrMapping/>
+  </p:clrMapOvr>
+</p:sld>
+</file>
+
+<file path=ppt/slides/slide7.xml><?xml version="1.0" encoding="utf-8"?>
+<p:sld xmlns:a="http://schemas.openxmlformats.org/drawingml/2006/main" xmlns:r="http://schemas.openxmlformats.org/officeDocument/2006/relationships" xmlns:p="http://schemas.openxmlformats.org/presentationml/2006/main">
+  <p:cSld name="Slide 7">
     <p:bg>
       <p:bgPr>
         <a:solidFill>

</xml_diff>

<commit_message>
Add pairs-to-rate slide: what the linked-panel leaving rate estimates
Co-Authored-By: Claude Fable 5 <noreply@anthropic.com>
Claude-Session: https://claude.ai/code/session_01DNzQPDcr3zfLTraMHUHqUn
</commit_message>
<xml_diff>
--- a/report/figures_deck/tech_slides_v3.pptx
+++ b/report/figures_deck/tech_slides_v3.pptx
@@ -12,9 +12,10 @@
     <p:sldId id="260" r:id="rId6"/>
     <p:sldId id="261" r:id="rId7"/>
     <p:sldId id="262" r:id="rId8"/>
+    <p:sldId id="263" r:id="rId9"/>
   </p:sldIdLst>
   <p:notesMasterIdLst>
-    <p:notesMasterId r:id="rId9"/>
+    <p:notesMasterId r:id="rId10"/>
   </p:notesMasterIdLst>
   <p:sldSz cx="12192000" cy="6858000"/>
   <p:notesSz cx="6858000" cy="12192000"/>
@@ -1060,6 +1061,94 @@
             <a:fld id="{F7021451-1387-4CA6-816F-3879F97B5CBC}" type="slidenum">
               <a:rPr lang="en-US"/>
               <a:t>7</a:t>
+            </a:fld>
+            <a:endParaRPr lang="en-US"/>
+          </a:p>
+        </p:txBody>
+      </p:sp>
+    </p:spTree>
+    <p:extLst>
+      <p:ext uri="{BB962C8B-B14F-4D97-AF65-F5344CB8AC3E}">
+        <p14:creationId xmlns:p14="http://schemas.microsoft.com/office/powerpoint/2010/main" val="1024086991"/>
+      </p:ext>
+    </p:extLst>
+  </p:cSld>
+  <p:clrMapOvr>
+    <a:masterClrMapping/>
+  </p:clrMapOvr>
+</p:notes>
+</file>
+
+<file path=ppt/notesSlides/notesSlide8.xml><?xml version="1.0" encoding="utf-8"?>
+<p:notes xmlns:a="http://schemas.openxmlformats.org/drawingml/2006/main" xmlns:r="http://schemas.openxmlformats.org/officeDocument/2006/relationships" xmlns:p="http://schemas.openxmlformats.org/presentationml/2006/main">
+  <p:cSld>
+    <p:spTree>
+      <p:nvGrpSpPr>
+        <p:cNvPr id="1" name=""/>
+        <p:cNvGrpSpPr/>
+        <p:nvPr/>
+      </p:nvGrpSpPr>
+      <p:grpSpPr>
+        <a:xfrm>
+          <a:off x="0" y="0"/>
+          <a:ext cx="0" cy="0"/>
+          <a:chOff x="0" y="0"/>
+          <a:chExt cx="0" cy="0"/>
+        </a:xfrm>
+      </p:grpSpPr>
+      <p:sp>
+        <p:nvSpPr>
+          <p:cNvPr id="2" name="Slide Image Placeholder 1"/>
+          <p:cNvSpPr>
+            <a:spLocks noGrp="1" noRot="1" noChangeAspect="1"/>
+          </p:cNvSpPr>
+          <p:nvPr>
+            <p:ph type="sldImg"/>
+          </p:nvPr>
+        </p:nvSpPr>
+        <p:spPr/>
+      </p:sp>
+      <p:sp>
+        <p:nvSpPr>
+          <p:cNvPr id="3" name="Notes Placeholder 2"/>
+          <p:cNvSpPr>
+            <a:spLocks noGrp="1"/>
+          </p:cNvSpPr>
+          <p:nvPr>
+            <p:ph type="body" idx="1"/>
+          </p:nvPr>
+        </p:nvSpPr>
+        <p:spPr/>
+        <p:txBody>
+          <a:bodyPr/>
+          <a:lstStyle/>
+          <a:p>
+            <a:r>
+              <a:rPr lang="en-US" dirty="0"/>
+              <a:t/>
+            </a:r>
+            <a:endParaRPr lang="en-US" dirty="0"/>
+          </a:p>
+        </p:txBody>
+      </p:sp>
+      <p:sp>
+        <p:nvSpPr>
+          <p:cNvPr id="4" name="Slide Number Placeholder 3"/>
+          <p:cNvSpPr>
+            <a:spLocks noGrp="1"/>
+          </p:cNvSpPr>
+          <p:nvPr>
+            <p:ph type="sldNum" sz="quarter" idx="10"/>
+          </p:nvPr>
+        </p:nvSpPr>
+        <p:spPr/>
+        <p:txBody>
+          <a:bodyPr/>
+          <a:lstStyle/>
+          <a:p>
+            <a:fld id="{F7021451-1387-4CA6-816F-3879F97B5CBC}" type="slidenum">
+              <a:rPr lang="en-US"/>
+              <a:t>8</a:t>
             </a:fld>
             <a:endParaRPr lang="en-US"/>
           </a:p>
@@ -4216,7 +4305,7 @@
       </p:grpSpPr>
       <p:pic>
         <p:nvPicPr>
-          <p:cNvPr id="2" name="Image 0" descr="/tmp/claude-0/-home-user-Alternative-Pathways----Quant/37b5ad96-b2b0-50d1-9e4b-6301ff28b789/scratchpad/u4_twodefs.png">    </p:cNvPr>
+          <p:cNvPr id="2" name="Image 0" descr="/tmp/claude-0/-home-user-Alternative-Pathways----Quant/37b5ad96-b2b0-50d1-9e4b-6301ff28b789/scratchpad/u3c_pairs.png">    </p:cNvPr>
           <p:cNvPicPr>
             <a:picLocks noChangeAspect="1"/>
           </p:cNvPicPr>
@@ -4272,7 +4361,7 @@
       </p:grpSpPr>
       <p:pic>
         <p:nvPicPr>
-          <p:cNvPr id="2" name="Image 0" descr="/tmp/claude-0/-home-user-Alternative-Pathways----Quant/37b5ad96-b2b0-50d1-9e4b-6301ff28b789/scratchpad/u5_bridge.png">    </p:cNvPr>
+          <p:cNvPr id="2" name="Image 0" descr="/tmp/claude-0/-home-user-Alternative-Pathways----Quant/37b5ad96-b2b0-50d1-9e4b-6301ff28b789/scratchpad/u4_twodefs.png">    </p:cNvPr>
           <p:cNvPicPr>
             <a:picLocks noChangeAspect="1"/>
           </p:cNvPicPr>
@@ -4305,6 +4394,62 @@
 <file path=ppt/slides/slide7.xml><?xml version="1.0" encoding="utf-8"?>
 <p:sld xmlns:a="http://schemas.openxmlformats.org/drawingml/2006/main" xmlns:r="http://schemas.openxmlformats.org/officeDocument/2006/relationships" xmlns:p="http://schemas.openxmlformats.org/presentationml/2006/main">
   <p:cSld name="Slide 7">
+    <p:bg>
+      <p:bgPr>
+        <a:solidFill>
+          <a:srgbClr val="FFFFFF"/>
+        </a:solidFill>
+      </p:bgPr>
+    </p:bg>
+    <p:spTree>
+      <p:nvGrpSpPr>
+        <p:cNvPr id="1" name=""/>
+        <p:cNvGrpSpPr/>
+        <p:nvPr/>
+      </p:nvGrpSpPr>
+      <p:grpSpPr>
+        <a:xfrm>
+          <a:off x="0" y="0"/>
+          <a:ext cx="0" cy="0"/>
+          <a:chOff x="0" y="0"/>
+          <a:chExt cx="0" cy="0"/>
+        </a:xfrm>
+      </p:grpSpPr>
+      <p:pic>
+        <p:nvPicPr>
+          <p:cNvPr id="2" name="Image 0" descr="/tmp/claude-0/-home-user-Alternative-Pathways----Quant/37b5ad96-b2b0-50d1-9e4b-6301ff28b789/scratchpad/u5_bridge.png">    </p:cNvPr>
+          <p:cNvPicPr>
+            <a:picLocks noChangeAspect="1"/>
+          </p:cNvPicPr>
+          <p:nvPr/>
+        </p:nvPicPr>
+        <p:blipFill>
+          <a:blip r:embed="rId1"/>
+          <a:stretch>
+            <a:fillRect/>
+          </a:stretch>
+        </p:blipFill>
+        <p:spPr>
+          <a:xfrm>
+            <a:off x="0" y="0"/>
+            <a:ext cx="12188952" cy="6858000"/>
+          </a:xfrm>
+          <a:prstGeom prst="rect">
+            <a:avLst/>
+          </a:prstGeom>
+        </p:spPr>
+      </p:pic>
+    </p:spTree>
+  </p:cSld>
+  <p:clrMapOvr>
+    <a:masterClrMapping/>
+  </p:clrMapOvr>
+</p:sld>
+</file>
+
+<file path=ppt/slides/slide8.xml><?xml version="1.0" encoding="utf-8"?>
+<p:sld xmlns:a="http://schemas.openxmlformats.org/drawingml/2006/main" xmlns:r="http://schemas.openxmlformats.org/officeDocument/2006/relationships" xmlns:p="http://schemas.openxmlformats.org/presentationml/2006/main">
+  <p:cSld name="Slide 8">
     <p:bg>
       <p:bgPr>
         <a:solidFill>

</xml_diff>

<commit_message>
Professional restyle: STIX serif typography, two-ink palette
Monochrome codes crosswalk (blue codes on light gray), single coral accent
reserved for the leaver concept, sober ink labels everywhere.

Co-Authored-By: Claude Fable 5 <noreply@anthropic.com>
Claude-Session: https://claude.ai/code/session_01DNzQPDcr3zfLTraMHUHqUn
</commit_message>
<xml_diff>
--- a/report/figures_deck/tech_slides_v3.pptx
+++ b/report/figures_deck/tech_slides_v3.pptx
@@ -1837,7 +1837,7 @@
             <a:r>
               <a:rPr lang="en-US" sz="1100" b="1" dirty="0">
                 <a:solidFill>
-                  <a:srgbClr val="C08A17"/>
+                  <a:srgbClr val="1A2430"/>
                 </a:solidFill>
                 <a:latin typeface="Garamond" pitchFamily="34" charset="0"/>
                 <a:ea typeface="Garamond" pitchFamily="34" charset="-122"/>
@@ -1854,7 +1854,7 @@
             <a:r>
               <a:rPr lang="en-US" sz="1100" b="1" dirty="0">
                 <a:solidFill>
-                  <a:srgbClr val="C08A17"/>
+                  <a:srgbClr val="1A2430"/>
                 </a:solidFill>
                 <a:latin typeface="Garamond" pitchFamily="34" charset="0"/>
                 <a:ea typeface="Garamond" pitchFamily="34" charset="-122"/>
@@ -1883,11 +1883,11 @@
             </a:avLst>
           </a:prstGeom>
           <a:solidFill>
-            <a:srgbClr val="FCF6E8"/>
+            <a:srgbClr val="F7F8FA"/>
           </a:solidFill>
-          <a:ln w="12700">
+          <a:ln w="9525">
             <a:solidFill>
-              <a:srgbClr val="C08A17"/>
+              <a:srgbClr val="C9CFD6"/>
             </a:solidFill>
             <a:prstDash val="solid"/>
           </a:ln>
@@ -1920,7 +1920,7 @@
             <a:r>
               <a:rPr lang="en-US" sz="1500" b="1" dirty="0">
                 <a:solidFill>
-                  <a:srgbClr val="C08A17"/>
+                  <a:srgbClr val="00549F"/>
                 </a:solidFill>
                 <a:latin typeface="Garamond" pitchFamily="34" charset="0"/>
                 <a:ea typeface="Garamond" pitchFamily="34" charset="-122"/>
@@ -1986,9 +1986,9 @@
             <a:avLst/>
           </a:prstGeom>
           <a:noFill/>
-          <a:ln w="12700">
+          <a:ln w="9525">
             <a:solidFill>
-              <a:srgbClr val="C08A17"/>
+              <a:srgbClr val="C9CFD6"/>
             </a:solidFill>
             <a:prstDash val="solid"/>
           </a:ln>
@@ -2011,11 +2011,11 @@
             </a:avLst>
           </a:prstGeom>
           <a:solidFill>
-            <a:srgbClr val="FCF6E8"/>
+            <a:srgbClr val="F7F8FA"/>
           </a:solidFill>
-          <a:ln w="12700">
+          <a:ln w="9525">
             <a:solidFill>
-              <a:srgbClr val="C08A17"/>
+              <a:srgbClr val="C9CFD6"/>
             </a:solidFill>
             <a:prstDash val="solid"/>
           </a:ln>
@@ -2048,7 +2048,7 @@
             <a:r>
               <a:rPr lang="en-US" sz="1500" b="1" dirty="0">
                 <a:solidFill>
-                  <a:srgbClr val="C08A17"/>
+                  <a:srgbClr val="00549F"/>
                 </a:solidFill>
                 <a:latin typeface="Garamond" pitchFamily="34" charset="0"/>
                 <a:ea typeface="Garamond" pitchFamily="34" charset="-122"/>
@@ -2114,9 +2114,9 @@
             <a:avLst/>
           </a:prstGeom>
           <a:noFill/>
-          <a:ln w="12700">
+          <a:ln w="9525">
             <a:solidFill>
-              <a:srgbClr val="C08A17"/>
+              <a:srgbClr val="C9CFD6"/>
             </a:solidFill>
             <a:prstDash val="solid"/>
           </a:ln>
@@ -2139,11 +2139,11 @@
             </a:avLst>
           </a:prstGeom>
           <a:solidFill>
-            <a:srgbClr val="FCF6E8"/>
+            <a:srgbClr val="F7F8FA"/>
           </a:solidFill>
-          <a:ln w="12700">
+          <a:ln w="9525">
             <a:solidFill>
-              <a:srgbClr val="C08A17"/>
+              <a:srgbClr val="C9CFD6"/>
             </a:solidFill>
             <a:prstDash val="solid"/>
           </a:ln>
@@ -2176,7 +2176,7 @@
             <a:r>
               <a:rPr lang="en-US" sz="1500" b="1" dirty="0">
                 <a:solidFill>
-                  <a:srgbClr val="C08A17"/>
+                  <a:srgbClr val="00549F"/>
                 </a:solidFill>
                 <a:latin typeface="Garamond" pitchFamily="34" charset="0"/>
                 <a:ea typeface="Garamond" pitchFamily="34" charset="-122"/>
@@ -2254,7 +2254,7 @@
             <a:r>
               <a:rPr lang="en-US" sz="1100" b="1" dirty="0">
                 <a:solidFill>
-                  <a:srgbClr val="00549F"/>
+                  <a:srgbClr val="1A2430"/>
                 </a:solidFill>
                 <a:latin typeface="Garamond" pitchFamily="34" charset="0"/>
                 <a:ea typeface="Garamond" pitchFamily="34" charset="-122"/>
@@ -2271,7 +2271,7 @@
             <a:r>
               <a:rPr lang="en-US" sz="1100" b="1" dirty="0">
                 <a:solidFill>
-                  <a:srgbClr val="00549F"/>
+                  <a:srgbClr val="1A2430"/>
                 </a:solidFill>
                 <a:latin typeface="Garamond" pitchFamily="34" charset="0"/>
                 <a:ea typeface="Garamond" pitchFamily="34" charset="-122"/>
@@ -2300,11 +2300,11 @@
             </a:avLst>
           </a:prstGeom>
           <a:solidFill>
-            <a:srgbClr val="EBF1F7"/>
+            <a:srgbClr val="F7F8FA"/>
           </a:solidFill>
-          <a:ln w="12700">
+          <a:ln w="9525">
             <a:solidFill>
-              <a:srgbClr val="00549F"/>
+              <a:srgbClr val="C9CFD6"/>
             </a:solidFill>
             <a:prstDash val="solid"/>
           </a:ln>
@@ -2403,9 +2403,9 @@
             <a:avLst/>
           </a:prstGeom>
           <a:noFill/>
-          <a:ln w="12700">
+          <a:ln w="9525">
             <a:solidFill>
-              <a:srgbClr val="00549F"/>
+              <a:srgbClr val="C9CFD6"/>
             </a:solidFill>
             <a:prstDash val="solid"/>
           </a:ln>
@@ -2428,11 +2428,11 @@
             </a:avLst>
           </a:prstGeom>
           <a:solidFill>
-            <a:srgbClr val="EBF1F7"/>
+            <a:srgbClr val="F7F8FA"/>
           </a:solidFill>
-          <a:ln w="12700">
+          <a:ln w="9525">
             <a:solidFill>
-              <a:srgbClr val="00549F"/>
+              <a:srgbClr val="C9CFD6"/>
             </a:solidFill>
             <a:prstDash val="solid"/>
           </a:ln>
@@ -2531,9 +2531,9 @@
             <a:avLst/>
           </a:prstGeom>
           <a:noFill/>
-          <a:ln w="12700">
+          <a:ln w="9525">
             <a:solidFill>
-              <a:srgbClr val="00549F"/>
+              <a:srgbClr val="C9CFD6"/>
             </a:solidFill>
             <a:prstDash val="solid"/>
           </a:ln>
@@ -2556,11 +2556,11 @@
             </a:avLst>
           </a:prstGeom>
           <a:solidFill>
-            <a:srgbClr val="EBF1F7"/>
+            <a:srgbClr val="F7F8FA"/>
           </a:solidFill>
-          <a:ln w="12700">
+          <a:ln w="9525">
             <a:solidFill>
-              <a:srgbClr val="00549F"/>
+              <a:srgbClr val="C9CFD6"/>
             </a:solidFill>
             <a:prstDash val="solid"/>
           </a:ln>
@@ -2671,7 +2671,7 @@
             <a:r>
               <a:rPr lang="en-US" sz="1100" b="1" dirty="0">
                 <a:solidFill>
-                  <a:srgbClr val="3A8A62"/>
+                  <a:srgbClr val="1A2430"/>
                 </a:solidFill>
                 <a:latin typeface="Garamond" pitchFamily="34" charset="0"/>
                 <a:ea typeface="Garamond" pitchFamily="34" charset="-122"/>
@@ -2700,11 +2700,11 @@
             </a:avLst>
           </a:prstGeom>
           <a:solidFill>
-            <a:srgbClr val="ECF4F0"/>
+            <a:srgbClr val="F7F8FA"/>
           </a:solidFill>
-          <a:ln w="12700">
+          <a:ln w="9525">
             <a:solidFill>
-              <a:srgbClr val="3A8A62"/>
+              <a:srgbClr val="C9CFD6"/>
             </a:solidFill>
             <a:prstDash val="solid"/>
           </a:ln>
@@ -2737,7 +2737,7 @@
             <a:r>
               <a:rPr lang="en-US" sz="1500" b="1" dirty="0">
                 <a:solidFill>
-                  <a:srgbClr val="3A8A62"/>
+                  <a:srgbClr val="00549F"/>
                 </a:solidFill>
                 <a:latin typeface="Garamond" pitchFamily="34" charset="0"/>
                 <a:ea typeface="Garamond" pitchFamily="34" charset="-122"/>
@@ -2803,9 +2803,9 @@
             <a:avLst/>
           </a:prstGeom>
           <a:noFill/>
-          <a:ln w="12700">
+          <a:ln w="9525">
             <a:solidFill>
-              <a:srgbClr val="3A8A62"/>
+              <a:srgbClr val="C9CFD6"/>
             </a:solidFill>
             <a:prstDash val="solid"/>
           </a:ln>
@@ -2828,11 +2828,11 @@
             </a:avLst>
           </a:prstGeom>
           <a:solidFill>
-            <a:srgbClr val="ECF4F0"/>
+            <a:srgbClr val="F7F8FA"/>
           </a:solidFill>
-          <a:ln w="12700">
+          <a:ln w="9525">
             <a:solidFill>
-              <a:srgbClr val="3A8A62"/>
+              <a:srgbClr val="C9CFD6"/>
             </a:solidFill>
             <a:prstDash val="solid"/>
           </a:ln>
@@ -2865,7 +2865,7 @@
             <a:r>
               <a:rPr lang="en-US" sz="1500" b="1" dirty="0">
                 <a:solidFill>
-                  <a:srgbClr val="3A8A62"/>
+                  <a:srgbClr val="00549F"/>
                 </a:solidFill>
                 <a:latin typeface="Garamond" pitchFamily="34" charset="0"/>
                 <a:ea typeface="Garamond" pitchFamily="34" charset="-122"/>
@@ -2931,9 +2931,9 @@
             <a:avLst/>
           </a:prstGeom>
           <a:noFill/>
-          <a:ln w="12700">
+          <a:ln w="9525">
             <a:solidFill>
-              <a:srgbClr val="3A8A62"/>
+              <a:srgbClr val="C9CFD6"/>
             </a:solidFill>
             <a:prstDash val="solid"/>
           </a:ln>
@@ -2956,11 +2956,11 @@
             </a:avLst>
           </a:prstGeom>
           <a:solidFill>
-            <a:srgbClr val="ECF4F0"/>
+            <a:srgbClr val="F7F8FA"/>
           </a:solidFill>
-          <a:ln w="12700">
+          <a:ln w="9525">
             <a:solidFill>
-              <a:srgbClr val="3A8A62"/>
+              <a:srgbClr val="C9CFD6"/>
             </a:solidFill>
             <a:prstDash val="solid"/>
           </a:ln>
@@ -2993,7 +2993,7 @@
             <a:r>
               <a:rPr lang="en-US" sz="1500" b="1" dirty="0">
                 <a:solidFill>
-                  <a:srgbClr val="3A8A62"/>
+                  <a:srgbClr val="00549F"/>
                 </a:solidFill>
                 <a:latin typeface="Garamond" pitchFamily="34" charset="0"/>
                 <a:ea typeface="Garamond" pitchFamily="34" charset="-122"/>
@@ -3071,7 +3071,7 @@
             <a:r>
               <a:rPr lang="en-US" sz="1100" b="1" dirty="0">
                 <a:solidFill>
-                  <a:srgbClr val="B5443C"/>
+                  <a:srgbClr val="1A2430"/>
                 </a:solidFill>
                 <a:latin typeface="Garamond" pitchFamily="34" charset="0"/>
                 <a:ea typeface="Garamond" pitchFamily="34" charset="-122"/>
@@ -3088,7 +3088,7 @@
             <a:r>
               <a:rPr lang="en-US" sz="1100" b="1" dirty="0">
                 <a:solidFill>
-                  <a:srgbClr val="B5443C"/>
+                  <a:srgbClr val="1A2430"/>
                 </a:solidFill>
                 <a:latin typeface="Garamond" pitchFamily="34" charset="0"/>
                 <a:ea typeface="Garamond" pitchFamily="34" charset="-122"/>
@@ -3117,11 +3117,11 @@
             </a:avLst>
           </a:prstGeom>
           <a:solidFill>
-            <a:srgbClr val="F8EEED"/>
+            <a:srgbClr val="F7F8FA"/>
           </a:solidFill>
-          <a:ln w="12700">
+          <a:ln w="9525">
             <a:solidFill>
-              <a:srgbClr val="B5443C"/>
+              <a:srgbClr val="C9CFD6"/>
             </a:solidFill>
             <a:prstDash val="solid"/>
           </a:ln>
@@ -3154,7 +3154,7 @@
             <a:r>
               <a:rPr lang="en-US" sz="1500" b="1" dirty="0">
                 <a:solidFill>
-                  <a:srgbClr val="B5443C"/>
+                  <a:srgbClr val="00549F"/>
                 </a:solidFill>
                 <a:latin typeface="Garamond" pitchFamily="34" charset="0"/>
                 <a:ea typeface="Garamond" pitchFamily="34" charset="-122"/>
@@ -3220,9 +3220,9 @@
             <a:avLst/>
           </a:prstGeom>
           <a:noFill/>
-          <a:ln w="12700">
+          <a:ln w="9525">
             <a:solidFill>
-              <a:srgbClr val="B5443C"/>
+              <a:srgbClr val="C9CFD6"/>
             </a:solidFill>
             <a:prstDash val="solid"/>
           </a:ln>
@@ -3245,11 +3245,11 @@
             </a:avLst>
           </a:prstGeom>
           <a:solidFill>
-            <a:srgbClr val="F8EEED"/>
+            <a:srgbClr val="F7F8FA"/>
           </a:solidFill>
-          <a:ln w="12700">
+          <a:ln w="9525">
             <a:solidFill>
-              <a:srgbClr val="B5443C"/>
+              <a:srgbClr val="C9CFD6"/>
             </a:solidFill>
             <a:prstDash val="solid"/>
           </a:ln>
@@ -3282,7 +3282,7 @@
             <a:r>
               <a:rPr lang="en-US" sz="1500" b="1" dirty="0">
                 <a:solidFill>
-                  <a:srgbClr val="B5443C"/>
+                  <a:srgbClr val="00549F"/>
                 </a:solidFill>
                 <a:latin typeface="Garamond" pitchFamily="34" charset="0"/>
                 <a:ea typeface="Garamond" pitchFamily="34" charset="-122"/>
@@ -3348,9 +3348,9 @@
             <a:avLst/>
           </a:prstGeom>
           <a:noFill/>
-          <a:ln w="12700">
+          <a:ln w="9525">
             <a:solidFill>
-              <a:srgbClr val="B5443C"/>
+              <a:srgbClr val="C9CFD6"/>
             </a:solidFill>
             <a:prstDash val="solid"/>
           </a:ln>
@@ -3373,11 +3373,11 @@
             </a:avLst>
           </a:prstGeom>
           <a:solidFill>
-            <a:srgbClr val="F8EEED"/>
+            <a:srgbClr val="F7F8FA"/>
           </a:solidFill>
-          <a:ln w="12700">
+          <a:ln w="9525">
             <a:solidFill>
-              <a:srgbClr val="B5443C"/>
+              <a:srgbClr val="C9CFD6"/>
             </a:solidFill>
             <a:prstDash val="solid"/>
           </a:ln>
@@ -3410,7 +3410,7 @@
             <a:r>
               <a:rPr lang="en-US" sz="1500" b="1" dirty="0">
                 <a:solidFill>
-                  <a:srgbClr val="B5443C"/>
+                  <a:srgbClr val="00549F"/>
                 </a:solidFill>
                 <a:latin typeface="Garamond" pitchFamily="34" charset="0"/>
                 <a:ea typeface="Garamond" pitchFamily="34" charset="-122"/>
@@ -3488,7 +3488,7 @@
             <a:r>
               <a:rPr lang="en-US" sz="1100" b="1" dirty="0">
                 <a:solidFill>
-                  <a:srgbClr val="5E6672"/>
+                  <a:srgbClr val="1A2430"/>
                 </a:solidFill>
                 <a:latin typeface="Garamond" pitchFamily="34" charset="0"/>
                 <a:ea typeface="Garamond" pitchFamily="34" charset="-122"/>
@@ -3505,7 +3505,7 @@
             <a:r>
               <a:rPr lang="en-US" sz="1100" b="1" dirty="0">
                 <a:solidFill>
-                  <a:srgbClr val="5E6672"/>
+                  <a:srgbClr val="1A2430"/>
                 </a:solidFill>
                 <a:latin typeface="Garamond" pitchFamily="34" charset="0"/>
                 <a:ea typeface="Garamond" pitchFamily="34" charset="-122"/>
@@ -3534,11 +3534,11 @@
             </a:avLst>
           </a:prstGeom>
           <a:solidFill>
-            <a:srgbClr val="EFF0F2"/>
+            <a:srgbClr val="F7F8FA"/>
           </a:solidFill>
-          <a:ln w="12700">
+          <a:ln w="9525">
             <a:solidFill>
-              <a:srgbClr val="5E6672"/>
+              <a:srgbClr val="C9CFD6"/>
             </a:solidFill>
             <a:prstDash val="solid"/>
           </a:ln>
@@ -3571,7 +3571,7 @@
             <a:r>
               <a:rPr lang="en-US" sz="1500" b="1" dirty="0">
                 <a:solidFill>
-                  <a:srgbClr val="5E6672"/>
+                  <a:srgbClr val="00549F"/>
                 </a:solidFill>
                 <a:latin typeface="Garamond" pitchFamily="34" charset="0"/>
                 <a:ea typeface="Garamond" pitchFamily="34" charset="-122"/>
@@ -3637,9 +3637,9 @@
             <a:avLst/>
           </a:prstGeom>
           <a:noFill/>
-          <a:ln w="12700">
+          <a:ln w="9525">
             <a:solidFill>
-              <a:srgbClr val="5E6672"/>
+              <a:srgbClr val="C9CFD6"/>
             </a:solidFill>
             <a:prstDash val="solid"/>
           </a:ln>
@@ -3662,11 +3662,11 @@
             </a:avLst>
           </a:prstGeom>
           <a:solidFill>
-            <a:srgbClr val="EFF0F2"/>
+            <a:srgbClr val="F7F8FA"/>
           </a:solidFill>
-          <a:ln w="12700">
+          <a:ln w="9525">
             <a:solidFill>
-              <a:srgbClr val="5E6672"/>
+              <a:srgbClr val="C9CFD6"/>
             </a:solidFill>
             <a:prstDash val="solid"/>
           </a:ln>
@@ -3699,7 +3699,7 @@
             <a:r>
               <a:rPr lang="en-US" sz="1500" b="1" dirty="0">
                 <a:solidFill>
-                  <a:srgbClr val="5E6672"/>
+                  <a:srgbClr val="00549F"/>
                 </a:solidFill>
                 <a:latin typeface="Garamond" pitchFamily="34" charset="0"/>
                 <a:ea typeface="Garamond" pitchFamily="34" charset="-122"/>
@@ -3765,9 +3765,9 @@
             <a:avLst/>
           </a:prstGeom>
           <a:noFill/>
-          <a:ln w="12700">
+          <a:ln w="9525">
             <a:solidFill>
-              <a:srgbClr val="5E6672"/>
+              <a:srgbClr val="C9CFD6"/>
             </a:solidFill>
             <a:prstDash val="solid"/>
           </a:ln>
@@ -3790,11 +3790,11 @@
             </a:avLst>
           </a:prstGeom>
           <a:solidFill>
-            <a:srgbClr val="EFF0F2"/>
+            <a:srgbClr val="F7F8FA"/>
           </a:solidFill>
-          <a:ln w="12700">
+          <a:ln w="9525">
             <a:solidFill>
-              <a:srgbClr val="5E6672"/>
+              <a:srgbClr val="C9CFD6"/>
             </a:solidFill>
             <a:prstDash val="solid"/>
           </a:ln>
@@ -3827,7 +3827,7 @@
             <a:r>
               <a:rPr lang="en-US" sz="1500" b="1" dirty="0">
                 <a:solidFill>
-                  <a:srgbClr val="5E6672"/>
+                  <a:srgbClr val="00549F"/>
                 </a:solidFill>
                 <a:latin typeface="Garamond" pitchFamily="34" charset="0"/>
                 <a:ea typeface="Garamond" pitchFamily="34" charset="-122"/>
@@ -4063,7 +4063,7 @@
             <a:r>
               <a:rPr lang="en-US" sz="950" b="1" dirty="0">
                 <a:solidFill>
-                  <a:srgbClr val="B5443C"/>
+                  <a:srgbClr val="6B7480"/>
                 </a:solidFill>
                 <a:latin typeface="Garamond" pitchFamily="34" charset="0"/>
                 <a:ea typeface="Garamond" pitchFamily="34" charset="-122"/>

</xml_diff>

<commit_message>
Five-slide tech set: plain identifier names, colored definition restored, balanced codes layout
Co-Authored-By: Claude Fable 5 <noreply@anthropic.com>
Claude-Session: https://claude.ai/code/session_01DNzQPDcr3zfLTraMHUHqUn
</commit_message>
<xml_diff>
--- a/report/figures_deck/tech_slides_v3.pptx
+++ b/report/figures_deck/tech_slides_v3.pptx
@@ -10,12 +10,9 @@
     <p:sldId id="258" r:id="rId4"/>
     <p:sldId id="259" r:id="rId5"/>
     <p:sldId id="260" r:id="rId6"/>
-    <p:sldId id="261" r:id="rId7"/>
-    <p:sldId id="262" r:id="rId8"/>
-    <p:sldId id="263" r:id="rId9"/>
   </p:sldIdLst>
   <p:notesMasterIdLst>
-    <p:notesMasterId r:id="rId10"/>
+    <p:notesMasterId r:id="rId7"/>
   </p:notesMasterIdLst>
   <p:sldSz cx="12192000" cy="6858000"/>
   <p:notesSz cx="6858000" cy="12192000"/>
@@ -885,270 +882,6 @@
             <a:fld id="{F7021451-1387-4CA6-816F-3879F97B5CBC}" type="slidenum">
               <a:rPr lang="en-US"/>
               <a:t>5</a:t>
-            </a:fld>
-            <a:endParaRPr lang="en-US"/>
-          </a:p>
-        </p:txBody>
-      </p:sp>
-    </p:spTree>
-    <p:extLst>
-      <p:ext uri="{BB962C8B-B14F-4D97-AF65-F5344CB8AC3E}">
-        <p14:creationId xmlns:p14="http://schemas.microsoft.com/office/powerpoint/2010/main" val="1024086991"/>
-      </p:ext>
-    </p:extLst>
-  </p:cSld>
-  <p:clrMapOvr>
-    <a:masterClrMapping/>
-  </p:clrMapOvr>
-</p:notes>
-</file>
-
-<file path=ppt/notesSlides/notesSlide6.xml><?xml version="1.0" encoding="utf-8"?>
-<p:notes xmlns:a="http://schemas.openxmlformats.org/drawingml/2006/main" xmlns:r="http://schemas.openxmlformats.org/officeDocument/2006/relationships" xmlns:p="http://schemas.openxmlformats.org/presentationml/2006/main">
-  <p:cSld>
-    <p:spTree>
-      <p:nvGrpSpPr>
-        <p:cNvPr id="1" name=""/>
-        <p:cNvGrpSpPr/>
-        <p:nvPr/>
-      </p:nvGrpSpPr>
-      <p:grpSpPr>
-        <a:xfrm>
-          <a:off x="0" y="0"/>
-          <a:ext cx="0" cy="0"/>
-          <a:chOff x="0" y="0"/>
-          <a:chExt cx="0" cy="0"/>
-        </a:xfrm>
-      </p:grpSpPr>
-      <p:sp>
-        <p:nvSpPr>
-          <p:cNvPr id="2" name="Slide Image Placeholder 1"/>
-          <p:cNvSpPr>
-            <a:spLocks noGrp="1" noRot="1" noChangeAspect="1"/>
-          </p:cNvSpPr>
-          <p:nvPr>
-            <p:ph type="sldImg"/>
-          </p:nvPr>
-        </p:nvSpPr>
-        <p:spPr/>
-      </p:sp>
-      <p:sp>
-        <p:nvSpPr>
-          <p:cNvPr id="3" name="Notes Placeholder 2"/>
-          <p:cNvSpPr>
-            <a:spLocks noGrp="1"/>
-          </p:cNvSpPr>
-          <p:nvPr>
-            <p:ph type="body" idx="1"/>
-          </p:nvPr>
-        </p:nvSpPr>
-        <p:spPr/>
-        <p:txBody>
-          <a:bodyPr/>
-          <a:lstStyle/>
-          <a:p>
-            <a:r>
-              <a:rPr lang="en-US" dirty="0"/>
-              <a:t/>
-            </a:r>
-            <a:endParaRPr lang="en-US" dirty="0"/>
-          </a:p>
-        </p:txBody>
-      </p:sp>
-      <p:sp>
-        <p:nvSpPr>
-          <p:cNvPr id="4" name="Slide Number Placeholder 3"/>
-          <p:cNvSpPr>
-            <a:spLocks noGrp="1"/>
-          </p:cNvSpPr>
-          <p:nvPr>
-            <p:ph type="sldNum" sz="quarter" idx="10"/>
-          </p:nvPr>
-        </p:nvSpPr>
-        <p:spPr/>
-        <p:txBody>
-          <a:bodyPr/>
-          <a:lstStyle/>
-          <a:p>
-            <a:fld id="{F7021451-1387-4CA6-816F-3879F97B5CBC}" type="slidenum">
-              <a:rPr lang="en-US"/>
-              <a:t>6</a:t>
-            </a:fld>
-            <a:endParaRPr lang="en-US"/>
-          </a:p>
-        </p:txBody>
-      </p:sp>
-    </p:spTree>
-    <p:extLst>
-      <p:ext uri="{BB962C8B-B14F-4D97-AF65-F5344CB8AC3E}">
-        <p14:creationId xmlns:p14="http://schemas.microsoft.com/office/powerpoint/2010/main" val="1024086991"/>
-      </p:ext>
-    </p:extLst>
-  </p:cSld>
-  <p:clrMapOvr>
-    <a:masterClrMapping/>
-  </p:clrMapOvr>
-</p:notes>
-</file>
-
-<file path=ppt/notesSlides/notesSlide7.xml><?xml version="1.0" encoding="utf-8"?>
-<p:notes xmlns:a="http://schemas.openxmlformats.org/drawingml/2006/main" xmlns:r="http://schemas.openxmlformats.org/officeDocument/2006/relationships" xmlns:p="http://schemas.openxmlformats.org/presentationml/2006/main">
-  <p:cSld>
-    <p:spTree>
-      <p:nvGrpSpPr>
-        <p:cNvPr id="1" name=""/>
-        <p:cNvGrpSpPr/>
-        <p:nvPr/>
-      </p:nvGrpSpPr>
-      <p:grpSpPr>
-        <a:xfrm>
-          <a:off x="0" y="0"/>
-          <a:ext cx="0" cy="0"/>
-          <a:chOff x="0" y="0"/>
-          <a:chExt cx="0" cy="0"/>
-        </a:xfrm>
-      </p:grpSpPr>
-      <p:sp>
-        <p:nvSpPr>
-          <p:cNvPr id="2" name="Slide Image Placeholder 1"/>
-          <p:cNvSpPr>
-            <a:spLocks noGrp="1" noRot="1" noChangeAspect="1"/>
-          </p:cNvSpPr>
-          <p:nvPr>
-            <p:ph type="sldImg"/>
-          </p:nvPr>
-        </p:nvSpPr>
-        <p:spPr/>
-      </p:sp>
-      <p:sp>
-        <p:nvSpPr>
-          <p:cNvPr id="3" name="Notes Placeholder 2"/>
-          <p:cNvSpPr>
-            <a:spLocks noGrp="1"/>
-          </p:cNvSpPr>
-          <p:nvPr>
-            <p:ph type="body" idx="1"/>
-          </p:nvPr>
-        </p:nvSpPr>
-        <p:spPr/>
-        <p:txBody>
-          <a:bodyPr/>
-          <a:lstStyle/>
-          <a:p>
-            <a:r>
-              <a:rPr lang="en-US" dirty="0"/>
-              <a:t/>
-            </a:r>
-            <a:endParaRPr lang="en-US" dirty="0"/>
-          </a:p>
-        </p:txBody>
-      </p:sp>
-      <p:sp>
-        <p:nvSpPr>
-          <p:cNvPr id="4" name="Slide Number Placeholder 3"/>
-          <p:cNvSpPr>
-            <a:spLocks noGrp="1"/>
-          </p:cNvSpPr>
-          <p:nvPr>
-            <p:ph type="sldNum" sz="quarter" idx="10"/>
-          </p:nvPr>
-        </p:nvSpPr>
-        <p:spPr/>
-        <p:txBody>
-          <a:bodyPr/>
-          <a:lstStyle/>
-          <a:p>
-            <a:fld id="{F7021451-1387-4CA6-816F-3879F97B5CBC}" type="slidenum">
-              <a:rPr lang="en-US"/>
-              <a:t>7</a:t>
-            </a:fld>
-            <a:endParaRPr lang="en-US"/>
-          </a:p>
-        </p:txBody>
-      </p:sp>
-    </p:spTree>
-    <p:extLst>
-      <p:ext uri="{BB962C8B-B14F-4D97-AF65-F5344CB8AC3E}">
-        <p14:creationId xmlns:p14="http://schemas.microsoft.com/office/powerpoint/2010/main" val="1024086991"/>
-      </p:ext>
-    </p:extLst>
-  </p:cSld>
-  <p:clrMapOvr>
-    <a:masterClrMapping/>
-  </p:clrMapOvr>
-</p:notes>
-</file>
-
-<file path=ppt/notesSlides/notesSlide8.xml><?xml version="1.0" encoding="utf-8"?>
-<p:notes xmlns:a="http://schemas.openxmlformats.org/drawingml/2006/main" xmlns:r="http://schemas.openxmlformats.org/officeDocument/2006/relationships" xmlns:p="http://schemas.openxmlformats.org/presentationml/2006/main">
-  <p:cSld>
-    <p:spTree>
-      <p:nvGrpSpPr>
-        <p:cNvPr id="1" name=""/>
-        <p:cNvGrpSpPr/>
-        <p:nvPr/>
-      </p:nvGrpSpPr>
-      <p:grpSpPr>
-        <a:xfrm>
-          <a:off x="0" y="0"/>
-          <a:ext cx="0" cy="0"/>
-          <a:chOff x="0" y="0"/>
-          <a:chExt cx="0" cy="0"/>
-        </a:xfrm>
-      </p:grpSpPr>
-      <p:sp>
-        <p:nvSpPr>
-          <p:cNvPr id="2" name="Slide Image Placeholder 1"/>
-          <p:cNvSpPr>
-            <a:spLocks noGrp="1" noRot="1" noChangeAspect="1"/>
-          </p:cNvSpPr>
-          <p:nvPr>
-            <p:ph type="sldImg"/>
-          </p:nvPr>
-        </p:nvSpPr>
-        <p:spPr/>
-      </p:sp>
-      <p:sp>
-        <p:nvSpPr>
-          <p:cNvPr id="3" name="Notes Placeholder 2"/>
-          <p:cNvSpPr>
-            <a:spLocks noGrp="1"/>
-          </p:cNvSpPr>
-          <p:nvPr>
-            <p:ph type="body" idx="1"/>
-          </p:nvPr>
-        </p:nvSpPr>
-        <p:spPr/>
-        <p:txBody>
-          <a:bodyPr/>
-          <a:lstStyle/>
-          <a:p>
-            <a:r>
-              <a:rPr lang="en-US" dirty="0"/>
-              <a:t/>
-            </a:r>
-            <a:endParaRPr lang="en-US" dirty="0"/>
-          </a:p>
-        </p:txBody>
-      </p:sp>
-      <p:sp>
-        <p:nvSpPr>
-          <p:cNvPr id="4" name="Slide Number Placeholder 3"/>
-          <p:cNvSpPr>
-            <a:spLocks noGrp="1"/>
-          </p:cNvSpPr>
-          <p:nvPr>
-            <p:ph type="sldNum" sz="quarter" idx="10"/>
-          </p:nvPr>
-        </p:nvSpPr>
-        <p:spPr/>
-        <p:txBody>
-          <a:bodyPr/>
-          <a:lstStyle/>
-          <a:p>
-            <a:fld id="{F7021451-1387-4CA6-816F-3879F97B5CBC}" type="slidenum">
-              <a:rPr lang="en-US"/>
-              <a:t>8</a:t>
             </a:fld>
             <a:endParaRPr lang="en-US"/>
           </a:p>
@@ -1584,7 +1317,7 @@
         </p:nvSpPr>
         <p:spPr>
           <a:xfrm>
-            <a:off x="1965960" y="1298448"/>
+            <a:off x="1691640" y="1298448"/>
             <a:ext cx="3246120" cy="274320"/>
           </a:xfrm>
           <a:prstGeom prst="rect">
@@ -1609,7 +1342,7 @@
                 <a:ea typeface="Garamond" pitchFamily="34" charset="-122"/>
                 <a:cs typeface="Garamond" pitchFamily="34" charset="-120"/>
               </a:rPr>
-              <a:t>SURVEYS 1998–2002</a:t>
+              <a:t>Surveys 1998–2002</a:t>
             </a:r>
             <a:endParaRPr lang="en-US" sz="1300" dirty="0"/>
           </a:p>
@@ -1623,7 +1356,7 @@
         </p:nvSpPr>
         <p:spPr>
           <a:xfrm>
-            <a:off x="1965960" y="1554480"/>
+            <a:off x="1691640" y="1554480"/>
             <a:ext cx="3246120" cy="274320"/>
           </a:xfrm>
           <a:prstGeom prst="rect">
@@ -1662,7 +1395,7 @@
         </p:nvSpPr>
         <p:spPr>
           <a:xfrm>
-            <a:off x="5440680" y="1298448"/>
+            <a:off x="5193792" y="1298448"/>
             <a:ext cx="3246120" cy="274320"/>
           </a:xfrm>
           <a:prstGeom prst="rect">
@@ -1687,7 +1420,7 @@
                 <a:ea typeface="Garamond" pitchFamily="34" charset="-122"/>
                 <a:cs typeface="Garamond" pitchFamily="34" charset="-120"/>
               </a:rPr>
-              <a:t>SURVEYS 2003–2019</a:t>
+              <a:t>Surveys 2003–2019</a:t>
             </a:r>
             <a:endParaRPr lang="en-US" sz="1300" dirty="0"/>
           </a:p>
@@ -1701,7 +1434,7 @@
         </p:nvSpPr>
         <p:spPr>
           <a:xfrm>
-            <a:off x="5440680" y="1554480"/>
+            <a:off x="5193792" y="1554480"/>
             <a:ext cx="3246120" cy="274320"/>
           </a:xfrm>
           <a:prstGeom prst="rect">
@@ -1740,7 +1473,7 @@
         </p:nvSpPr>
         <p:spPr>
           <a:xfrm>
-            <a:off x="8915400" y="1298448"/>
+            <a:off x="8695944" y="1298448"/>
             <a:ext cx="3246120" cy="274320"/>
           </a:xfrm>
           <a:prstGeom prst="rect">
@@ -1765,7 +1498,7 @@
                 <a:ea typeface="Garamond" pitchFamily="34" charset="-122"/>
                 <a:cs typeface="Garamond" pitchFamily="34" charset="-120"/>
               </a:rPr>
-              <a:t>SURVEYS 2020–2025</a:t>
+              <a:t>Surveys 2020–2025</a:t>
             </a:r>
             <a:endParaRPr lang="en-US" sz="1300" dirty="0"/>
           </a:p>
@@ -1779,7 +1512,7 @@
         </p:nvSpPr>
         <p:spPr>
           <a:xfrm>
-            <a:off x="8915400" y="1554480"/>
+            <a:off x="8695944" y="1554480"/>
             <a:ext cx="3246120" cy="274320"/>
           </a:xfrm>
           <a:prstGeom prst="rect">
@@ -1818,8 +1551,8 @@
         </p:nvSpPr>
         <p:spPr>
           <a:xfrm>
-            <a:off x="320040" y="1920240"/>
-            <a:ext cx="1508760" cy="658368"/>
+            <a:off x="228600" y="1920240"/>
+            <a:ext cx="1325880" cy="658368"/>
           </a:xfrm>
           <a:prstGeom prst="rect">
             <a:avLst/>
@@ -1837,7 +1570,7 @@
             <a:r>
               <a:rPr lang="en-US" sz="1100" b="1" dirty="0">
                 <a:solidFill>
-                  <a:srgbClr val="1A2430"/>
+                  <a:srgbClr val="C08A17"/>
                 </a:solidFill>
                 <a:latin typeface="Garamond" pitchFamily="34" charset="0"/>
                 <a:ea typeface="Garamond" pitchFamily="34" charset="-122"/>
@@ -1854,7 +1587,7 @@
             <a:r>
               <a:rPr lang="en-US" sz="1100" b="1" dirty="0">
                 <a:solidFill>
-                  <a:srgbClr val="1A2430"/>
+                  <a:srgbClr val="C08A17"/>
                 </a:solidFill>
                 <a:latin typeface="Garamond" pitchFamily="34" charset="0"/>
                 <a:ea typeface="Garamond" pitchFamily="34" charset="-122"/>
@@ -1874,7 +1607,7 @@
         </p:nvSpPr>
         <p:spPr>
           <a:xfrm>
-            <a:off x="1965960" y="1920240"/>
+            <a:off x="1691640" y="1920240"/>
             <a:ext cx="3246120" cy="658368"/>
           </a:xfrm>
           <a:prstGeom prst="roundRect">
@@ -1883,7 +1616,7 @@
             </a:avLst>
           </a:prstGeom>
           <a:solidFill>
-            <a:srgbClr val="F7F8FA"/>
+            <a:srgbClr val="FBFBF8"/>
           </a:solidFill>
           <a:ln w="9525">
             <a:solidFill>
@@ -1901,7 +1634,7 @@
         </p:nvSpPr>
         <p:spPr>
           <a:xfrm>
-            <a:off x="2075688" y="1920240"/>
+            <a:off x="1801368" y="1920240"/>
             <a:ext cx="685800" cy="658368"/>
           </a:xfrm>
           <a:prstGeom prst="rect">
@@ -1920,7 +1653,7 @@
             <a:r>
               <a:rPr lang="en-US" sz="1500" b="1" dirty="0">
                 <a:solidFill>
-                  <a:srgbClr val="00549F"/>
+                  <a:srgbClr val="C08A17"/>
                 </a:solidFill>
                 <a:latin typeface="Garamond" pitchFamily="34" charset="0"/>
                 <a:ea typeface="Garamond" pitchFamily="34" charset="-122"/>
@@ -1940,7 +1673,7 @@
         </p:nvSpPr>
         <p:spPr>
           <a:xfrm>
-            <a:off x="2807208" y="1920240"/>
+            <a:off x="2532888" y="1920240"/>
             <a:ext cx="2286000" cy="658368"/>
           </a:xfrm>
           <a:prstGeom prst="rect">
@@ -1979,8 +1712,8 @@
         </p:nvSpPr>
         <p:spPr>
           <a:xfrm>
-            <a:off x="5212080" y="2249424"/>
-            <a:ext cx="228600" cy="0"/>
+            <a:off x="4937760" y="2249424"/>
+            <a:ext cx="256032" cy="0"/>
           </a:xfrm>
           <a:prstGeom prst="line">
             <a:avLst/>
@@ -2002,7 +1735,7 @@
         </p:nvSpPr>
         <p:spPr>
           <a:xfrm>
-            <a:off x="5440680" y="1920240"/>
+            <a:off x="5193792" y="1920240"/>
             <a:ext cx="3246120" cy="658368"/>
           </a:xfrm>
           <a:prstGeom prst="roundRect">
@@ -2011,7 +1744,7 @@
             </a:avLst>
           </a:prstGeom>
           <a:solidFill>
-            <a:srgbClr val="F7F8FA"/>
+            <a:srgbClr val="FBFBF8"/>
           </a:solidFill>
           <a:ln w="9525">
             <a:solidFill>
@@ -2029,7 +1762,7 @@
         </p:nvSpPr>
         <p:spPr>
           <a:xfrm>
-            <a:off x="5550408" y="1920240"/>
+            <a:off x="5303520" y="1920240"/>
             <a:ext cx="685800" cy="658368"/>
           </a:xfrm>
           <a:prstGeom prst="rect">
@@ -2048,7 +1781,7 @@
             <a:r>
               <a:rPr lang="en-US" sz="1500" b="1" dirty="0">
                 <a:solidFill>
-                  <a:srgbClr val="00549F"/>
+                  <a:srgbClr val="C08A17"/>
                 </a:solidFill>
                 <a:latin typeface="Garamond" pitchFamily="34" charset="0"/>
                 <a:ea typeface="Garamond" pitchFamily="34" charset="-122"/>
@@ -2068,7 +1801,7 @@
         </p:nvSpPr>
         <p:spPr>
           <a:xfrm>
-            <a:off x="6281928" y="1920240"/>
+            <a:off x="6035040" y="1920240"/>
             <a:ext cx="2286000" cy="658368"/>
           </a:xfrm>
           <a:prstGeom prst="rect">
@@ -2107,8 +1840,8 @@
         </p:nvSpPr>
         <p:spPr>
           <a:xfrm>
-            <a:off x="8686800" y="2249424"/>
-            <a:ext cx="228600" cy="0"/>
+            <a:off x="8439912" y="2249424"/>
+            <a:ext cx="256032" cy="0"/>
           </a:xfrm>
           <a:prstGeom prst="line">
             <a:avLst/>
@@ -2130,7 +1863,7 @@
         </p:nvSpPr>
         <p:spPr>
           <a:xfrm>
-            <a:off x="8915400" y="1920240"/>
+            <a:off x="8695944" y="1920240"/>
             <a:ext cx="3246120" cy="658368"/>
           </a:xfrm>
           <a:prstGeom prst="roundRect">
@@ -2139,7 +1872,7 @@
             </a:avLst>
           </a:prstGeom>
           <a:solidFill>
-            <a:srgbClr val="F7F8FA"/>
+            <a:srgbClr val="FBFBF8"/>
           </a:solidFill>
           <a:ln w="9525">
             <a:solidFill>
@@ -2157,7 +1890,7 @@
         </p:nvSpPr>
         <p:spPr>
           <a:xfrm>
-            <a:off x="9025128" y="1920240"/>
+            <a:off x="8805672" y="1920240"/>
             <a:ext cx="685800" cy="658368"/>
           </a:xfrm>
           <a:prstGeom prst="rect">
@@ -2176,77 +1909,94 @@
             <a:r>
               <a:rPr lang="en-US" sz="1500" b="1" dirty="0">
                 <a:solidFill>
+                  <a:srgbClr val="C08A17"/>
+                </a:solidFill>
+                <a:latin typeface="Garamond" pitchFamily="34" charset="0"/>
+                <a:ea typeface="Garamond" pitchFamily="34" charset="-122"/>
+                <a:cs typeface="Garamond" pitchFamily="34" charset="-120"/>
+              </a:rPr>
+              <a:t>2300</a:t>
+            </a:r>
+            <a:endParaRPr lang="en-US" sz="1500" dirty="0"/>
+          </a:p>
+        </p:txBody>
+      </p:sp>
+      <p:sp>
+        <p:nvSpPr>
+          <p:cNvPr id="21" name="Text 19"/>
+          <p:cNvSpPr/>
+          <p:nvPr/>
+        </p:nvSpPr>
+        <p:spPr>
+          <a:xfrm>
+            <a:off x="9537192" y="1920240"/>
+            <a:ext cx="2286000" cy="658368"/>
+          </a:xfrm>
+          <a:prstGeom prst="rect">
+            <a:avLst/>
+          </a:prstGeom>
+          <a:noFill/>
+          <a:ln/>
+        </p:spPr>
+        <p:txBody>
+          <a:bodyPr wrap="square" lIns="0" tIns="0" rIns="0" bIns="0" rtlCol="0" anchor="ctr"/>
+          <a:lstStyle/>
+          <a:p>
+            <a:pPr indent="0" marL="0">
+              <a:buNone/>
+            </a:pPr>
+            <a:r>
+              <a:rPr lang="en-US" sz="950" dirty="0">
+                <a:solidFill>
+                  <a:srgbClr val="1A2430"/>
+                </a:solidFill>
+                <a:latin typeface="Garamond" pitchFamily="34" charset="0"/>
+                <a:ea typeface="Garamond" pitchFamily="34" charset="-122"/>
+                <a:cs typeface="Garamond" pitchFamily="34" charset="-120"/>
+              </a:rPr>
+              <a:t>Preschool and kindergarten teachers</a:t>
+            </a:r>
+            <a:endParaRPr lang="en-US" sz="950" dirty="0"/>
+          </a:p>
+        </p:txBody>
+      </p:sp>
+      <p:sp>
+        <p:nvSpPr>
+          <p:cNvPr id="22" name="Text 20"/>
+          <p:cNvSpPr/>
+          <p:nvPr/>
+        </p:nvSpPr>
+        <p:spPr>
+          <a:xfrm>
+            <a:off x="228600" y="2715768"/>
+            <a:ext cx="1325880" cy="658368"/>
+          </a:xfrm>
+          <a:prstGeom prst="rect">
+            <a:avLst/>
+          </a:prstGeom>
+          <a:noFill/>
+          <a:ln/>
+        </p:spPr>
+        <p:txBody>
+          <a:bodyPr wrap="square" lIns="0" tIns="0" rIns="0" bIns="0" rtlCol="0" anchor="ctr"/>
+          <a:lstStyle/>
+          <a:p>
+            <a:pPr algn="r" indent="0" marL="0">
+              <a:buNone/>
+            </a:pPr>
+            <a:r>
+              <a:rPr lang="en-US" sz="1100" b="1" dirty="0">
+                <a:solidFill>
                   <a:srgbClr val="00549F"/>
                 </a:solidFill>
                 <a:latin typeface="Garamond" pitchFamily="34" charset="0"/>
                 <a:ea typeface="Garamond" pitchFamily="34" charset="-122"/>
                 <a:cs typeface="Garamond" pitchFamily="34" charset="-120"/>
               </a:rPr>
-              <a:t>2300</a:t>
-            </a:r>
-            <a:endParaRPr lang="en-US" sz="1500" dirty="0"/>
-          </a:p>
-        </p:txBody>
-      </p:sp>
-      <p:sp>
-        <p:nvSpPr>
-          <p:cNvPr id="21" name="Text 19"/>
-          <p:cNvSpPr/>
-          <p:nvPr/>
-        </p:nvSpPr>
-        <p:spPr>
-          <a:xfrm>
-            <a:off x="9756648" y="1920240"/>
-            <a:ext cx="2286000" cy="658368"/>
-          </a:xfrm>
-          <a:prstGeom prst="rect">
-            <a:avLst/>
-          </a:prstGeom>
-          <a:noFill/>
-          <a:ln/>
-        </p:spPr>
-        <p:txBody>
-          <a:bodyPr wrap="square" lIns="0" tIns="0" rIns="0" bIns="0" rtlCol="0" anchor="ctr"/>
-          <a:lstStyle/>
-          <a:p>
-            <a:pPr indent="0" marL="0">
-              <a:buNone/>
-            </a:pPr>
-            <a:r>
-              <a:rPr lang="en-US" sz="950" dirty="0">
-                <a:solidFill>
-                  <a:srgbClr val="1A2430"/>
-                </a:solidFill>
-                <a:latin typeface="Garamond" pitchFamily="34" charset="0"/>
-                <a:ea typeface="Garamond" pitchFamily="34" charset="-122"/>
-                <a:cs typeface="Garamond" pitchFamily="34" charset="-120"/>
-              </a:rPr>
-              <a:t>Preschool and kindergarten teachers</a:t>
-            </a:r>
-            <a:endParaRPr lang="en-US" sz="950" dirty="0"/>
-          </a:p>
-        </p:txBody>
-      </p:sp>
-      <p:sp>
-        <p:nvSpPr>
-          <p:cNvPr id="22" name="Text 20"/>
-          <p:cNvSpPr/>
-          <p:nvPr/>
-        </p:nvSpPr>
-        <p:spPr>
-          <a:xfrm>
-            <a:off x="320040" y="2715768"/>
-            <a:ext cx="1508760" cy="658368"/>
-          </a:xfrm>
-          <a:prstGeom prst="rect">
-            <a:avLst/>
-          </a:prstGeom>
-          <a:noFill/>
-          <a:ln/>
-        </p:spPr>
-        <p:txBody>
-          <a:bodyPr wrap="square" lIns="0" tIns="0" rIns="0" bIns="0" rtlCol="0" anchor="ctr"/>
-          <a:lstStyle/>
+              <a:t>Elementary</a:t>
+            </a:r>
+            <a:endParaRPr lang="en-US" sz="1100" dirty="0"/>
+          </a:p>
           <a:p>
             <a:pPr algn="r" indent="0" marL="0">
               <a:buNone/>
@@ -2254,33 +2004,16 @@
             <a:r>
               <a:rPr lang="en-US" sz="1100" b="1" dirty="0">
                 <a:solidFill>
-                  <a:srgbClr val="1A2430"/>
-                </a:solidFill>
-                <a:latin typeface="Garamond" pitchFamily="34" charset="0"/>
-                <a:ea typeface="Garamond" pitchFamily="34" charset="-122"/>
-                <a:cs typeface="Garamond" pitchFamily="34" charset="-120"/>
-              </a:rPr>
-              <a:t>Elementary</a:t>
+                  <a:srgbClr val="00549F"/>
+                </a:solidFill>
+                <a:latin typeface="Garamond" pitchFamily="34" charset="0"/>
+                <a:ea typeface="Garamond" pitchFamily="34" charset="-122"/>
+                <a:cs typeface="Garamond" pitchFamily="34" charset="-120"/>
+              </a:rPr>
+              <a:t>&amp; middle †</a:t>
             </a:r>
             <a:endParaRPr lang="en-US" sz="1100" dirty="0"/>
           </a:p>
-          <a:p>
-            <a:pPr algn="r" indent="0" marL="0">
-              <a:buNone/>
-            </a:pPr>
-            <a:r>
-              <a:rPr lang="en-US" sz="1100" b="1" dirty="0">
-                <a:solidFill>
-                  <a:srgbClr val="1A2430"/>
-                </a:solidFill>
-                <a:latin typeface="Garamond" pitchFamily="34" charset="0"/>
-                <a:ea typeface="Garamond" pitchFamily="34" charset="-122"/>
-                <a:cs typeface="Garamond" pitchFamily="34" charset="-120"/>
-              </a:rPr>
-              <a:t>&amp; middle †</a:t>
-            </a:r>
-            <a:endParaRPr lang="en-US" sz="1100" dirty="0"/>
-          </a:p>
         </p:txBody>
       </p:sp>
       <p:sp>
@@ -2291,7 +2024,7 @@
         </p:nvSpPr>
         <p:spPr>
           <a:xfrm>
-            <a:off x="1965960" y="2715768"/>
+            <a:off x="1691640" y="2715768"/>
             <a:ext cx="3246120" cy="658368"/>
           </a:xfrm>
           <a:prstGeom prst="roundRect">
@@ -2300,7 +2033,7 @@
             </a:avLst>
           </a:prstGeom>
           <a:solidFill>
-            <a:srgbClr val="F7F8FA"/>
+            <a:srgbClr val="F8FAFC"/>
           </a:solidFill>
           <a:ln w="9525">
             <a:solidFill>
@@ -2318,7 +2051,7 @@
         </p:nvSpPr>
         <p:spPr>
           <a:xfrm>
-            <a:off x="2075688" y="2715768"/>
+            <a:off x="1801368" y="2715768"/>
             <a:ext cx="685800" cy="658368"/>
           </a:xfrm>
           <a:prstGeom prst="rect">
@@ -2357,7 +2090,7 @@
         </p:nvSpPr>
         <p:spPr>
           <a:xfrm>
-            <a:off x="2807208" y="2715768"/>
+            <a:off x="2532888" y="2715768"/>
             <a:ext cx="2286000" cy="658368"/>
           </a:xfrm>
           <a:prstGeom prst="rect">
@@ -2396,8 +2129,8 @@
         </p:nvSpPr>
         <p:spPr>
           <a:xfrm>
-            <a:off x="5212080" y="3044952"/>
-            <a:ext cx="228600" cy="0"/>
+            <a:off x="4937760" y="3044952"/>
+            <a:ext cx="256032" cy="0"/>
           </a:xfrm>
           <a:prstGeom prst="line">
             <a:avLst/>
@@ -2419,7 +2152,7 @@
         </p:nvSpPr>
         <p:spPr>
           <a:xfrm>
-            <a:off x="5440680" y="2715768"/>
+            <a:off x="5193792" y="2715768"/>
             <a:ext cx="3246120" cy="658368"/>
           </a:xfrm>
           <a:prstGeom prst="roundRect">
@@ -2428,7 +2161,7 @@
             </a:avLst>
           </a:prstGeom>
           <a:solidFill>
-            <a:srgbClr val="F7F8FA"/>
+            <a:srgbClr val="F8FAFC"/>
           </a:solidFill>
           <a:ln w="9525">
             <a:solidFill>
@@ -2446,7 +2179,7 @@
         </p:nvSpPr>
         <p:spPr>
           <a:xfrm>
-            <a:off x="5550408" y="2715768"/>
+            <a:off x="5303520" y="2715768"/>
             <a:ext cx="685800" cy="658368"/>
           </a:xfrm>
           <a:prstGeom prst="rect">
@@ -2485,7 +2218,7 @@
         </p:nvSpPr>
         <p:spPr>
           <a:xfrm>
-            <a:off x="6281928" y="2715768"/>
+            <a:off x="6035040" y="2715768"/>
             <a:ext cx="2286000" cy="658368"/>
           </a:xfrm>
           <a:prstGeom prst="rect">
@@ -2524,8 +2257,8 @@
         </p:nvSpPr>
         <p:spPr>
           <a:xfrm>
-            <a:off x="8686800" y="3044952"/>
-            <a:ext cx="228600" cy="0"/>
+            <a:off x="8439912" y="3044952"/>
+            <a:ext cx="256032" cy="0"/>
           </a:xfrm>
           <a:prstGeom prst="line">
             <a:avLst/>
@@ -2547,7 +2280,7 @@
         </p:nvSpPr>
         <p:spPr>
           <a:xfrm>
-            <a:off x="8915400" y="2715768"/>
+            <a:off x="8695944" y="2715768"/>
             <a:ext cx="3246120" cy="658368"/>
           </a:xfrm>
           <a:prstGeom prst="roundRect">
@@ -2556,7 +2289,7 @@
             </a:avLst>
           </a:prstGeom>
           <a:solidFill>
-            <a:srgbClr val="F7F8FA"/>
+            <a:srgbClr val="F8FAFC"/>
           </a:solidFill>
           <a:ln w="9525">
             <a:solidFill>
@@ -2574,7 +2307,7 @@
         </p:nvSpPr>
         <p:spPr>
           <a:xfrm>
-            <a:off x="9025128" y="2715768"/>
+            <a:off x="8805672" y="2715768"/>
             <a:ext cx="685800" cy="658368"/>
           </a:xfrm>
           <a:prstGeom prst="rect">
@@ -2613,7 +2346,7 @@
         </p:nvSpPr>
         <p:spPr>
           <a:xfrm>
-            <a:off x="9756648" y="2715768"/>
+            <a:off x="9537192" y="2715768"/>
             <a:ext cx="2286000" cy="658368"/>
           </a:xfrm>
           <a:prstGeom prst="rect">
@@ -2652,8 +2385,8 @@
         </p:nvSpPr>
         <p:spPr>
           <a:xfrm>
-            <a:off x="320040" y="3511296"/>
-            <a:ext cx="1508760" cy="658368"/>
+            <a:off x="228600" y="3511296"/>
+            <a:ext cx="1325880" cy="658368"/>
           </a:xfrm>
           <a:prstGeom prst="rect">
             <a:avLst/>
@@ -2671,7 +2404,7 @@
             <a:r>
               <a:rPr lang="en-US" sz="1100" b="1" dirty="0">
                 <a:solidFill>
-                  <a:srgbClr val="1A2430"/>
+                  <a:srgbClr val="3A8A62"/>
                 </a:solidFill>
                 <a:latin typeface="Garamond" pitchFamily="34" charset="0"/>
                 <a:ea typeface="Garamond" pitchFamily="34" charset="-122"/>
@@ -2691,7 +2424,7 @@
         </p:nvSpPr>
         <p:spPr>
           <a:xfrm>
-            <a:off x="1965960" y="3511296"/>
+            <a:off x="1691640" y="3511296"/>
             <a:ext cx="3246120" cy="658368"/>
           </a:xfrm>
           <a:prstGeom prst="roundRect">
@@ -2700,7 +2433,7 @@
             </a:avLst>
           </a:prstGeom>
           <a:solidFill>
-            <a:srgbClr val="F7F8FA"/>
+            <a:srgbClr val="F8FBF9"/>
           </a:solidFill>
           <a:ln w="9525">
             <a:solidFill>
@@ -2718,7 +2451,7 @@
         </p:nvSpPr>
         <p:spPr>
           <a:xfrm>
-            <a:off x="2075688" y="3511296"/>
+            <a:off x="1801368" y="3511296"/>
             <a:ext cx="685800" cy="658368"/>
           </a:xfrm>
           <a:prstGeom prst="rect">
@@ -2737,7 +2470,7 @@
             <a:r>
               <a:rPr lang="en-US" sz="1500" b="1" dirty="0">
                 <a:solidFill>
-                  <a:srgbClr val="00549F"/>
+                  <a:srgbClr val="3A8A62"/>
                 </a:solidFill>
                 <a:latin typeface="Garamond" pitchFamily="34" charset="0"/>
                 <a:ea typeface="Garamond" pitchFamily="34" charset="-122"/>
@@ -2757,7 +2490,7 @@
         </p:nvSpPr>
         <p:spPr>
           <a:xfrm>
-            <a:off x="2807208" y="3511296"/>
+            <a:off x="2532888" y="3511296"/>
             <a:ext cx="2286000" cy="658368"/>
           </a:xfrm>
           <a:prstGeom prst="rect">
@@ -2796,8 +2529,8 @@
         </p:nvSpPr>
         <p:spPr>
           <a:xfrm>
-            <a:off x="5212080" y="3840480"/>
-            <a:ext cx="228600" cy="0"/>
+            <a:off x="4937760" y="3840480"/>
+            <a:ext cx="256032" cy="0"/>
           </a:xfrm>
           <a:prstGeom prst="line">
             <a:avLst/>
@@ -2819,7 +2552,7 @@
         </p:nvSpPr>
         <p:spPr>
           <a:xfrm>
-            <a:off x="5440680" y="3511296"/>
+            <a:off x="5193792" y="3511296"/>
             <a:ext cx="3246120" cy="658368"/>
           </a:xfrm>
           <a:prstGeom prst="roundRect">
@@ -2828,7 +2561,7 @@
             </a:avLst>
           </a:prstGeom>
           <a:solidFill>
-            <a:srgbClr val="F7F8FA"/>
+            <a:srgbClr val="F8FBF9"/>
           </a:solidFill>
           <a:ln w="9525">
             <a:solidFill>
@@ -2846,7 +2579,7 @@
         </p:nvSpPr>
         <p:spPr>
           <a:xfrm>
-            <a:off x="5550408" y="3511296"/>
+            <a:off x="5303520" y="3511296"/>
             <a:ext cx="685800" cy="658368"/>
           </a:xfrm>
           <a:prstGeom prst="rect">
@@ -2865,7 +2598,7 @@
             <a:r>
               <a:rPr lang="en-US" sz="1500" b="1" dirty="0">
                 <a:solidFill>
-                  <a:srgbClr val="00549F"/>
+                  <a:srgbClr val="3A8A62"/>
                 </a:solidFill>
                 <a:latin typeface="Garamond" pitchFamily="34" charset="0"/>
                 <a:ea typeface="Garamond" pitchFamily="34" charset="-122"/>
@@ -2885,7 +2618,7 @@
         </p:nvSpPr>
         <p:spPr>
           <a:xfrm>
-            <a:off x="6281928" y="3511296"/>
+            <a:off x="6035040" y="3511296"/>
             <a:ext cx="2286000" cy="658368"/>
           </a:xfrm>
           <a:prstGeom prst="rect">
@@ -2924,8 +2657,8 @@
         </p:nvSpPr>
         <p:spPr>
           <a:xfrm>
-            <a:off x="8686800" y="3840480"/>
-            <a:ext cx="228600" cy="0"/>
+            <a:off x="8439912" y="3840480"/>
+            <a:ext cx="256032" cy="0"/>
           </a:xfrm>
           <a:prstGeom prst="line">
             <a:avLst/>
@@ -2947,7 +2680,7 @@
         </p:nvSpPr>
         <p:spPr>
           <a:xfrm>
-            <a:off x="8915400" y="3511296"/>
+            <a:off x="8695944" y="3511296"/>
             <a:ext cx="3246120" cy="658368"/>
           </a:xfrm>
           <a:prstGeom prst="roundRect">
@@ -2956,7 +2689,7 @@
             </a:avLst>
           </a:prstGeom>
           <a:solidFill>
-            <a:srgbClr val="F7F8FA"/>
+            <a:srgbClr val="F8FBF9"/>
           </a:solidFill>
           <a:ln w="9525">
             <a:solidFill>
@@ -2974,7 +2707,7 @@
         </p:nvSpPr>
         <p:spPr>
           <a:xfrm>
-            <a:off x="9025128" y="3511296"/>
+            <a:off x="8805672" y="3511296"/>
             <a:ext cx="685800" cy="658368"/>
           </a:xfrm>
           <a:prstGeom prst="rect">
@@ -2993,7 +2726,7 @@
             <a:r>
               <a:rPr lang="en-US" sz="1500" b="1" dirty="0">
                 <a:solidFill>
-                  <a:srgbClr val="00549F"/>
+                  <a:srgbClr val="3A8A62"/>
                 </a:solidFill>
                 <a:latin typeface="Garamond" pitchFamily="34" charset="0"/>
                 <a:ea typeface="Garamond" pitchFamily="34" charset="-122"/>
@@ -3013,7 +2746,7 @@
         </p:nvSpPr>
         <p:spPr>
           <a:xfrm>
-            <a:off x="9756648" y="3511296"/>
+            <a:off x="9537192" y="3511296"/>
             <a:ext cx="2286000" cy="658368"/>
           </a:xfrm>
           <a:prstGeom prst="rect">
@@ -3052,8 +2785,8 @@
         </p:nvSpPr>
         <p:spPr>
           <a:xfrm>
-            <a:off x="320040" y="4306824"/>
-            <a:ext cx="1508760" cy="658368"/>
+            <a:off x="228600" y="4306824"/>
+            <a:ext cx="1325880" cy="658368"/>
           </a:xfrm>
           <a:prstGeom prst="rect">
             <a:avLst/>
@@ -3071,7 +2804,7 @@
             <a:r>
               <a:rPr lang="en-US" sz="1100" b="1" dirty="0">
                 <a:solidFill>
-                  <a:srgbClr val="1A2430"/>
+                  <a:srgbClr val="B5443C"/>
                 </a:solidFill>
                 <a:latin typeface="Garamond" pitchFamily="34" charset="0"/>
                 <a:ea typeface="Garamond" pitchFamily="34" charset="-122"/>
@@ -3088,7 +2821,7 @@
             <a:r>
               <a:rPr lang="en-US" sz="1100" b="1" dirty="0">
                 <a:solidFill>
-                  <a:srgbClr val="1A2430"/>
+                  <a:srgbClr val="B5443C"/>
                 </a:solidFill>
                 <a:latin typeface="Garamond" pitchFamily="34" charset="0"/>
                 <a:ea typeface="Garamond" pitchFamily="34" charset="-122"/>
@@ -3108,7 +2841,7 @@
         </p:nvSpPr>
         <p:spPr>
           <a:xfrm>
-            <a:off x="1965960" y="4306824"/>
+            <a:off x="1691640" y="4306824"/>
             <a:ext cx="3246120" cy="658368"/>
           </a:xfrm>
           <a:prstGeom prst="roundRect">
@@ -3117,7 +2850,7 @@
             </a:avLst>
           </a:prstGeom>
           <a:solidFill>
-            <a:srgbClr val="F7F8FA"/>
+            <a:srgbClr val="FBF8F8"/>
           </a:solidFill>
           <a:ln w="9525">
             <a:solidFill>
@@ -3135,7 +2868,7 @@
         </p:nvSpPr>
         <p:spPr>
           <a:xfrm>
-            <a:off x="2075688" y="4306824"/>
+            <a:off x="1801368" y="4306824"/>
             <a:ext cx="685800" cy="658368"/>
           </a:xfrm>
           <a:prstGeom prst="rect">
@@ -3154,7 +2887,7 @@
             <a:r>
               <a:rPr lang="en-US" sz="1500" b="1" dirty="0">
                 <a:solidFill>
-                  <a:srgbClr val="00549F"/>
+                  <a:srgbClr val="B5443C"/>
                 </a:solidFill>
                 <a:latin typeface="Garamond" pitchFamily="34" charset="0"/>
                 <a:ea typeface="Garamond" pitchFamily="34" charset="-122"/>
@@ -3174,7 +2907,7 @@
         </p:nvSpPr>
         <p:spPr>
           <a:xfrm>
-            <a:off x="2807208" y="4306824"/>
+            <a:off x="2532888" y="4306824"/>
             <a:ext cx="2286000" cy="658368"/>
           </a:xfrm>
           <a:prstGeom prst="rect">
@@ -3213,8 +2946,8 @@
         </p:nvSpPr>
         <p:spPr>
           <a:xfrm>
-            <a:off x="5212080" y="4636008"/>
-            <a:ext cx="228600" cy="0"/>
+            <a:off x="4937760" y="4636008"/>
+            <a:ext cx="256032" cy="0"/>
           </a:xfrm>
           <a:prstGeom prst="line">
             <a:avLst/>
@@ -3236,7 +2969,7 @@
         </p:nvSpPr>
         <p:spPr>
           <a:xfrm>
-            <a:off x="5440680" y="4306824"/>
+            <a:off x="5193792" y="4306824"/>
             <a:ext cx="3246120" cy="658368"/>
           </a:xfrm>
           <a:prstGeom prst="roundRect">
@@ -3245,7 +2978,7 @@
             </a:avLst>
           </a:prstGeom>
           <a:solidFill>
-            <a:srgbClr val="F7F8FA"/>
+            <a:srgbClr val="FBF8F8"/>
           </a:solidFill>
           <a:ln w="9525">
             <a:solidFill>
@@ -3263,7 +2996,7 @@
         </p:nvSpPr>
         <p:spPr>
           <a:xfrm>
-            <a:off x="5550408" y="4306824"/>
+            <a:off x="5303520" y="4306824"/>
             <a:ext cx="685800" cy="658368"/>
           </a:xfrm>
           <a:prstGeom prst="rect">
@@ -3282,7 +3015,7 @@
             <a:r>
               <a:rPr lang="en-US" sz="1500" b="1" dirty="0">
                 <a:solidFill>
-                  <a:srgbClr val="00549F"/>
+                  <a:srgbClr val="B5443C"/>
                 </a:solidFill>
                 <a:latin typeface="Garamond" pitchFamily="34" charset="0"/>
                 <a:ea typeface="Garamond" pitchFamily="34" charset="-122"/>
@@ -3302,7 +3035,7 @@
         </p:nvSpPr>
         <p:spPr>
           <a:xfrm>
-            <a:off x="6281928" y="4306824"/>
+            <a:off x="6035040" y="4306824"/>
             <a:ext cx="2286000" cy="658368"/>
           </a:xfrm>
           <a:prstGeom prst="rect">
@@ -3341,8 +3074,8 @@
         </p:nvSpPr>
         <p:spPr>
           <a:xfrm>
-            <a:off x="8686800" y="4636008"/>
-            <a:ext cx="228600" cy="0"/>
+            <a:off x="8439912" y="4636008"/>
+            <a:ext cx="256032" cy="0"/>
           </a:xfrm>
           <a:prstGeom prst="line">
             <a:avLst/>
@@ -3364,7 +3097,7 @@
         </p:nvSpPr>
         <p:spPr>
           <a:xfrm>
-            <a:off x="8915400" y="4306824"/>
+            <a:off x="8695944" y="4306824"/>
             <a:ext cx="3246120" cy="658368"/>
           </a:xfrm>
           <a:prstGeom prst="roundRect">
@@ -3373,7 +3106,7 @@
             </a:avLst>
           </a:prstGeom>
           <a:solidFill>
-            <a:srgbClr val="F7F8FA"/>
+            <a:srgbClr val="FBF8F8"/>
           </a:solidFill>
           <a:ln w="9525">
             <a:solidFill>
@@ -3391,7 +3124,7 @@
         </p:nvSpPr>
         <p:spPr>
           <a:xfrm>
-            <a:off x="9025128" y="4306824"/>
+            <a:off x="8805672" y="4306824"/>
             <a:ext cx="685800" cy="658368"/>
           </a:xfrm>
           <a:prstGeom prst="rect">
@@ -3410,7 +3143,7 @@
             <a:r>
               <a:rPr lang="en-US" sz="1500" b="1" dirty="0">
                 <a:solidFill>
-                  <a:srgbClr val="00549F"/>
+                  <a:srgbClr val="B5443C"/>
                 </a:solidFill>
                 <a:latin typeface="Garamond" pitchFamily="34" charset="0"/>
                 <a:ea typeface="Garamond" pitchFamily="34" charset="-122"/>
@@ -3430,7 +3163,7 @@
         </p:nvSpPr>
         <p:spPr>
           <a:xfrm>
-            <a:off x="9756648" y="4306824"/>
+            <a:off x="9537192" y="4306824"/>
             <a:ext cx="2286000" cy="658368"/>
           </a:xfrm>
           <a:prstGeom prst="rect">
@@ -3469,8 +3202,8 @@
         </p:nvSpPr>
         <p:spPr>
           <a:xfrm>
-            <a:off x="320040" y="5102352"/>
-            <a:ext cx="1508760" cy="658368"/>
+            <a:off x="228600" y="5102352"/>
+            <a:ext cx="1325880" cy="658368"/>
           </a:xfrm>
           <a:prstGeom prst="rect">
             <a:avLst/>
@@ -3488,7 +3221,7 @@
             <a:r>
               <a:rPr lang="en-US" sz="1100" b="1" dirty="0">
                 <a:solidFill>
-                  <a:srgbClr val="1A2430"/>
+                  <a:srgbClr val="5E6672"/>
                 </a:solidFill>
                 <a:latin typeface="Garamond" pitchFamily="34" charset="0"/>
                 <a:ea typeface="Garamond" pitchFamily="34" charset="-122"/>
@@ -3505,7 +3238,7 @@
             <a:r>
               <a:rPr lang="en-US" sz="1100" b="1" dirty="0">
                 <a:solidFill>
-                  <a:srgbClr val="1A2430"/>
+                  <a:srgbClr val="5E6672"/>
                 </a:solidFill>
                 <a:latin typeface="Garamond" pitchFamily="34" charset="0"/>
                 <a:ea typeface="Garamond" pitchFamily="34" charset="-122"/>
@@ -3525,7 +3258,7 @@
         </p:nvSpPr>
         <p:spPr>
           <a:xfrm>
-            <a:off x="1965960" y="5102352"/>
+            <a:off x="1691640" y="5102352"/>
             <a:ext cx="3246120" cy="658368"/>
           </a:xfrm>
           <a:prstGeom prst="roundRect">
@@ -3534,7 +3267,7 @@
             </a:avLst>
           </a:prstGeom>
           <a:solidFill>
-            <a:srgbClr val="F7F8FA"/>
+            <a:srgbClr val="F8F9FA"/>
           </a:solidFill>
           <a:ln w="9525">
             <a:solidFill>
@@ -3552,7 +3285,7 @@
         </p:nvSpPr>
         <p:spPr>
           <a:xfrm>
-            <a:off x="2075688" y="5102352"/>
+            <a:off x="1801368" y="5102352"/>
             <a:ext cx="685800" cy="658368"/>
           </a:xfrm>
           <a:prstGeom prst="rect">
@@ -3571,7 +3304,7 @@
             <a:r>
               <a:rPr lang="en-US" sz="1500" b="1" dirty="0">
                 <a:solidFill>
-                  <a:srgbClr val="00549F"/>
+                  <a:srgbClr val="5E6672"/>
                 </a:solidFill>
                 <a:latin typeface="Garamond" pitchFamily="34" charset="0"/>
                 <a:ea typeface="Garamond" pitchFamily="34" charset="-122"/>
@@ -3591,7 +3324,7 @@
         </p:nvSpPr>
         <p:spPr>
           <a:xfrm>
-            <a:off x="2807208" y="5102352"/>
+            <a:off x="2532888" y="5102352"/>
             <a:ext cx="2286000" cy="658368"/>
           </a:xfrm>
           <a:prstGeom prst="rect">
@@ -3630,8 +3363,8 @@
         </p:nvSpPr>
         <p:spPr>
           <a:xfrm>
-            <a:off x="5212080" y="5431536"/>
-            <a:ext cx="228600" cy="0"/>
+            <a:off x="4937760" y="5431536"/>
+            <a:ext cx="256032" cy="0"/>
           </a:xfrm>
           <a:prstGeom prst="line">
             <a:avLst/>
@@ -3653,7 +3386,7 @@
         </p:nvSpPr>
         <p:spPr>
           <a:xfrm>
-            <a:off x="5440680" y="5102352"/>
+            <a:off x="5193792" y="5102352"/>
             <a:ext cx="3246120" cy="658368"/>
           </a:xfrm>
           <a:prstGeom prst="roundRect">
@@ -3662,7 +3395,7 @@
             </a:avLst>
           </a:prstGeom>
           <a:solidFill>
-            <a:srgbClr val="F7F8FA"/>
+            <a:srgbClr val="F8F9FA"/>
           </a:solidFill>
           <a:ln w="9525">
             <a:solidFill>
@@ -3680,7 +3413,7 @@
         </p:nvSpPr>
         <p:spPr>
           <a:xfrm>
-            <a:off x="5550408" y="5102352"/>
+            <a:off x="5303520" y="5102352"/>
             <a:ext cx="685800" cy="658368"/>
           </a:xfrm>
           <a:prstGeom prst="rect">
@@ -3699,7 +3432,7 @@
             <a:r>
               <a:rPr lang="en-US" sz="1500" b="1" dirty="0">
                 <a:solidFill>
-                  <a:srgbClr val="00549F"/>
+                  <a:srgbClr val="5E6672"/>
                 </a:solidFill>
                 <a:latin typeface="Garamond" pitchFamily="34" charset="0"/>
                 <a:ea typeface="Garamond" pitchFamily="34" charset="-122"/>
@@ -3719,7 +3452,7 @@
         </p:nvSpPr>
         <p:spPr>
           <a:xfrm>
-            <a:off x="6281928" y="5102352"/>
+            <a:off x="6035040" y="5102352"/>
             <a:ext cx="2286000" cy="658368"/>
           </a:xfrm>
           <a:prstGeom prst="rect">
@@ -3758,8 +3491,8 @@
         </p:nvSpPr>
         <p:spPr>
           <a:xfrm>
-            <a:off x="8686800" y="5431536"/>
-            <a:ext cx="228600" cy="0"/>
+            <a:off x="8439912" y="5431536"/>
+            <a:ext cx="256032" cy="0"/>
           </a:xfrm>
           <a:prstGeom prst="line">
             <a:avLst/>
@@ -3781,7 +3514,7 @@
         </p:nvSpPr>
         <p:spPr>
           <a:xfrm>
-            <a:off x="8915400" y="5102352"/>
+            <a:off x="8695944" y="5102352"/>
             <a:ext cx="3246120" cy="658368"/>
           </a:xfrm>
           <a:prstGeom prst="roundRect">
@@ -3790,7 +3523,7 @@
             </a:avLst>
           </a:prstGeom>
           <a:solidFill>
-            <a:srgbClr val="F7F8FA"/>
+            <a:srgbClr val="F8F9FA"/>
           </a:solidFill>
           <a:ln w="9525">
             <a:solidFill>
@@ -3808,7 +3541,7 @@
         </p:nvSpPr>
         <p:spPr>
           <a:xfrm>
-            <a:off x="9025128" y="5102352"/>
+            <a:off x="8805672" y="5102352"/>
             <a:ext cx="685800" cy="658368"/>
           </a:xfrm>
           <a:prstGeom prst="rect">
@@ -3827,7 +3560,7 @@
             <a:r>
               <a:rPr lang="en-US" sz="1500" b="1" dirty="0">
                 <a:solidFill>
-                  <a:srgbClr val="00549F"/>
+                  <a:srgbClr val="5E6672"/>
                 </a:solidFill>
                 <a:latin typeface="Garamond" pitchFamily="34" charset="0"/>
                 <a:ea typeface="Garamond" pitchFamily="34" charset="-122"/>
@@ -3847,7 +3580,7 @@
         </p:nvSpPr>
         <p:spPr>
           <a:xfrm>
-            <a:off x="9756648" y="5102352"/>
+            <a:off x="9537192" y="5102352"/>
             <a:ext cx="2286000" cy="658368"/>
           </a:xfrm>
           <a:prstGeom prst="rect">
@@ -3886,7 +3619,7 @@
         </p:nvSpPr>
         <p:spPr>
           <a:xfrm>
-            <a:off x="5326380" y="1298448"/>
+            <a:off x="5065776" y="1298448"/>
             <a:ext cx="0" cy="4462272"/>
           </a:xfrm>
           <a:prstGeom prst="line">
@@ -3909,7 +3642,7 @@
         </p:nvSpPr>
         <p:spPr>
           <a:xfrm>
-            <a:off x="4503420" y="5779008"/>
+            <a:off x="4242816" y="5779008"/>
             <a:ext cx="1645920" cy="219456"/>
           </a:xfrm>
           <a:prstGeom prst="rect">
@@ -3948,7 +3681,7 @@
         </p:nvSpPr>
         <p:spPr>
           <a:xfrm>
-            <a:off x="8801100" y="1298448"/>
+            <a:off x="8567928" y="1298448"/>
             <a:ext cx="0" cy="4462272"/>
           </a:xfrm>
           <a:prstGeom prst="line">
@@ -3971,7 +3704,7 @@
         </p:nvSpPr>
         <p:spPr>
           <a:xfrm>
-            <a:off x="7978140" y="5779008"/>
+            <a:off x="7744968" y="5779008"/>
             <a:ext cx="1645920" cy="219456"/>
           </a:xfrm>
           <a:prstGeom prst="rect">
@@ -4305,175 +4038,7 @@
       </p:grpSpPr>
       <p:pic>
         <p:nvPicPr>
-          <p:cNvPr id="2" name="Image 0" descr="/tmp/claude-0/-home-user-Alternative-Pathways----Quant/37b5ad96-b2b0-50d1-9e4b-6301ff28b789/scratchpad/u3c_pairs.png">    </p:cNvPr>
-          <p:cNvPicPr>
-            <a:picLocks noChangeAspect="1"/>
-          </p:cNvPicPr>
-          <p:nvPr/>
-        </p:nvPicPr>
-        <p:blipFill>
-          <a:blip r:embed="rId1"/>
-          <a:stretch>
-            <a:fillRect/>
-          </a:stretch>
-        </p:blipFill>
-        <p:spPr>
-          <a:xfrm>
-            <a:off x="0" y="0"/>
-            <a:ext cx="12188952" cy="6858000"/>
-          </a:xfrm>
-          <a:prstGeom prst="rect">
-            <a:avLst/>
-          </a:prstGeom>
-        </p:spPr>
-      </p:pic>
-    </p:spTree>
-  </p:cSld>
-  <p:clrMapOvr>
-    <a:masterClrMapping/>
-  </p:clrMapOvr>
-</p:sld>
-</file>
-
-<file path=ppt/slides/slide6.xml><?xml version="1.0" encoding="utf-8"?>
-<p:sld xmlns:a="http://schemas.openxmlformats.org/drawingml/2006/main" xmlns:r="http://schemas.openxmlformats.org/officeDocument/2006/relationships" xmlns:p="http://schemas.openxmlformats.org/presentationml/2006/main">
-  <p:cSld name="Slide 6">
-    <p:bg>
-      <p:bgPr>
-        <a:solidFill>
-          <a:srgbClr val="FFFFFF"/>
-        </a:solidFill>
-      </p:bgPr>
-    </p:bg>
-    <p:spTree>
-      <p:nvGrpSpPr>
-        <p:cNvPr id="1" name=""/>
-        <p:cNvGrpSpPr/>
-        <p:nvPr/>
-      </p:nvGrpSpPr>
-      <p:grpSpPr>
-        <a:xfrm>
-          <a:off x="0" y="0"/>
-          <a:ext cx="0" cy="0"/>
-          <a:chOff x="0" y="0"/>
-          <a:chExt cx="0" cy="0"/>
-        </a:xfrm>
-      </p:grpSpPr>
-      <p:pic>
-        <p:nvPicPr>
           <p:cNvPr id="2" name="Image 0" descr="/tmp/claude-0/-home-user-Alternative-Pathways----Quant/37b5ad96-b2b0-50d1-9e4b-6301ff28b789/scratchpad/u4_twodefs.png">    </p:cNvPr>
-          <p:cNvPicPr>
-            <a:picLocks noChangeAspect="1"/>
-          </p:cNvPicPr>
-          <p:nvPr/>
-        </p:nvPicPr>
-        <p:blipFill>
-          <a:blip r:embed="rId1"/>
-          <a:stretch>
-            <a:fillRect/>
-          </a:stretch>
-        </p:blipFill>
-        <p:spPr>
-          <a:xfrm>
-            <a:off x="0" y="0"/>
-            <a:ext cx="12188952" cy="6858000"/>
-          </a:xfrm>
-          <a:prstGeom prst="rect">
-            <a:avLst/>
-          </a:prstGeom>
-        </p:spPr>
-      </p:pic>
-    </p:spTree>
-  </p:cSld>
-  <p:clrMapOvr>
-    <a:masterClrMapping/>
-  </p:clrMapOvr>
-</p:sld>
-</file>
-
-<file path=ppt/slides/slide7.xml><?xml version="1.0" encoding="utf-8"?>
-<p:sld xmlns:a="http://schemas.openxmlformats.org/drawingml/2006/main" xmlns:r="http://schemas.openxmlformats.org/officeDocument/2006/relationships" xmlns:p="http://schemas.openxmlformats.org/presentationml/2006/main">
-  <p:cSld name="Slide 7">
-    <p:bg>
-      <p:bgPr>
-        <a:solidFill>
-          <a:srgbClr val="FFFFFF"/>
-        </a:solidFill>
-      </p:bgPr>
-    </p:bg>
-    <p:spTree>
-      <p:nvGrpSpPr>
-        <p:cNvPr id="1" name=""/>
-        <p:cNvGrpSpPr/>
-        <p:nvPr/>
-      </p:nvGrpSpPr>
-      <p:grpSpPr>
-        <a:xfrm>
-          <a:off x="0" y="0"/>
-          <a:ext cx="0" cy="0"/>
-          <a:chOff x="0" y="0"/>
-          <a:chExt cx="0" cy="0"/>
-        </a:xfrm>
-      </p:grpSpPr>
-      <p:pic>
-        <p:nvPicPr>
-          <p:cNvPr id="2" name="Image 0" descr="/tmp/claude-0/-home-user-Alternative-Pathways----Quant/37b5ad96-b2b0-50d1-9e4b-6301ff28b789/scratchpad/u5_bridge.png">    </p:cNvPr>
-          <p:cNvPicPr>
-            <a:picLocks noChangeAspect="1"/>
-          </p:cNvPicPr>
-          <p:nvPr/>
-        </p:nvPicPr>
-        <p:blipFill>
-          <a:blip r:embed="rId1"/>
-          <a:stretch>
-            <a:fillRect/>
-          </a:stretch>
-        </p:blipFill>
-        <p:spPr>
-          <a:xfrm>
-            <a:off x="0" y="0"/>
-            <a:ext cx="12188952" cy="6858000"/>
-          </a:xfrm>
-          <a:prstGeom prst="rect">
-            <a:avLst/>
-          </a:prstGeom>
-        </p:spPr>
-      </p:pic>
-    </p:spTree>
-  </p:cSld>
-  <p:clrMapOvr>
-    <a:masterClrMapping/>
-  </p:clrMapOvr>
-</p:sld>
-</file>
-
-<file path=ppt/slides/slide8.xml><?xml version="1.0" encoding="utf-8"?>
-<p:sld xmlns:a="http://schemas.openxmlformats.org/drawingml/2006/main" xmlns:r="http://schemas.openxmlformats.org/officeDocument/2006/relationships" xmlns:p="http://schemas.openxmlformats.org/presentationml/2006/main">
-  <p:cSld name="Slide 8">
-    <p:bg>
-      <p:bgPr>
-        <a:solidFill>
-          <a:srgbClr val="FFFFFF"/>
-        </a:solidFill>
-      </p:bgPr>
-    </p:bg>
-    <p:spTree>
-      <p:nvGrpSpPr>
-        <p:cNvPr id="1" name=""/>
-        <p:cNvGrpSpPr/>
-        <p:nvPr/>
-      </p:nvGrpSpPr>
-      <p:grpSpPr>
-        <a:xfrm>
-          <a:off x="0" y="0"/>
-          <a:ext cx="0" cy="0"/>
-          <a:chOff x="0" y="0"/>
-          <a:chExt cx="0" cy="0"/>
-        </a:xfrm>
-      </p:grpSpPr>
-      <p:pic>
-        <p:nvPicPr>
-          <p:cNvPr id="2" name="Image 0" descr="/tmp/claude-0/-home-user-Alternative-Pathways----Quant/37b5ad96-b2b0-50d1-9e4b-6301ff28b789/scratchpad/u6_whymarch.png">    </p:cNvPr>
           <p:cNvPicPr>
             <a:picLocks noChangeAspect="1"/>
           </p:cNvPicPr>

</xml_diff>

<commit_message>
Codes slide: no subtitle, navy/burgundy 3+2 grouping, centered footnote
Co-Authored-By: Claude Fable 5 <noreply@anthropic.com>
Claude-Session: https://claude.ai/code/session_01DNzQPDcr3zfLTraMHUHqUn
</commit_message>
<xml_diff>
--- a/report/figures_deck/tech_slides_v3.pptx
+++ b/report/figures_deck/tech_slides_v3.pptx
@@ -1239,7 +1239,7 @@
         </p:nvSpPr>
         <p:spPr>
           <a:xfrm>
-            <a:off x="502920" y="292608"/>
+            <a:off x="502920" y="310896"/>
             <a:ext cx="11155680" cy="502920"/>
           </a:xfrm>
           <a:prstGeom prst="rect">
@@ -1278,24 +1278,63 @@
         </p:nvSpPr>
         <p:spPr>
           <a:xfrm>
-            <a:off x="502920" y="822960"/>
-            <a:ext cx="11155680" cy="320040"/>
-          </a:xfrm>
-          <a:prstGeom prst="rect">
-            <a:avLst/>
-          </a:prstGeom>
-          <a:noFill/>
-          <a:ln/>
-        </p:spPr>
-        <p:txBody>
-          <a:bodyPr wrap="square" lIns="0" tIns="0" rIns="0" bIns="0" rtlCol="0" anchor="ctr"/>
-          <a:lstStyle/>
-          <a:p>
-            <a:pPr indent="0" marL="0">
-              <a:buNone/>
-            </a:pPr>
-            <a:r>
-              <a:rPr lang="en-US" sz="1250" i="1" dirty="0">
+            <a:off x="1691640" y="1024128"/>
+            <a:ext cx="3246120" cy="274320"/>
+          </a:xfrm>
+          <a:prstGeom prst="rect">
+            <a:avLst/>
+          </a:prstGeom>
+          <a:noFill/>
+          <a:ln/>
+        </p:spPr>
+        <p:txBody>
+          <a:bodyPr wrap="square" lIns="0" tIns="0" rIns="0" bIns="0" rtlCol="0" anchor="ctr"/>
+          <a:lstStyle/>
+          <a:p>
+            <a:pPr algn="ctr" indent="0" marL="0">
+              <a:buNone/>
+            </a:pPr>
+            <a:r>
+              <a:rPr lang="en-US" sz="1300" b="1" dirty="0">
+                <a:solidFill>
+                  <a:srgbClr val="1A2430"/>
+                </a:solidFill>
+                <a:latin typeface="Garamond" pitchFamily="34" charset="0"/>
+                <a:ea typeface="Garamond" pitchFamily="34" charset="-122"/>
+                <a:cs typeface="Garamond" pitchFamily="34" charset="-120"/>
+              </a:rPr>
+              <a:t>Surveys 1998–2002</a:t>
+            </a:r>
+            <a:endParaRPr lang="en-US" sz="1300" dirty="0"/>
+          </a:p>
+        </p:txBody>
+      </p:sp>
+      <p:sp>
+        <p:nvSpPr>
+          <p:cNvPr id="4" name="Text 2"/>
+          <p:cNvSpPr/>
+          <p:nvPr/>
+        </p:nvSpPr>
+        <p:spPr>
+          <a:xfrm>
+            <a:off x="1691640" y="1280160"/>
+            <a:ext cx="3246120" cy="274320"/>
+          </a:xfrm>
+          <a:prstGeom prst="rect">
+            <a:avLst/>
+          </a:prstGeom>
+          <a:noFill/>
+          <a:ln/>
+        </p:spPr>
+        <p:txBody>
+          <a:bodyPr wrap="square" lIns="0" tIns="0" rIns="0" bIns="0" rtlCol="0" anchor="ctr"/>
+          <a:lstStyle/>
+          <a:p>
+            <a:pPr algn="ctr" indent="0" marL="0">
+              <a:buNone/>
+            </a:pPr>
+            <a:r>
+              <a:rPr lang="en-US" sz="900" i="1" dirty="0">
                 <a:solidFill>
                   <a:srgbClr val="6B7480"/>
                 </a:solidFill>
@@ -1303,21 +1342,21 @@
                 <a:ea typeface="Garamond" pitchFamily="34" charset="-122"/>
                 <a:cs typeface="Garamond" pitchFamily="34" charset="-120"/>
               </a:rPr>
-              <a:t>By the Census occupation code — the code the Census Bureau assigns to the occupation of the longest job held last year (CPS ASEC)</a:t>
-            </a:r>
-            <a:endParaRPr lang="en-US" sz="1250" dirty="0"/>
-          </a:p>
-        </p:txBody>
-      </p:sp>
-      <p:sp>
-        <p:nvSpPr>
-          <p:cNvPr id="4" name="Text 2"/>
-          <p:cNvSpPr/>
-          <p:nvPr/>
-        </p:nvSpPr>
-        <p:spPr>
-          <a:xfrm>
-            <a:off x="1691640" y="1298448"/>
+              <a:t>Census occupation classification of 1990</a:t>
+            </a:r>
+            <a:endParaRPr lang="en-US" sz="900" dirty="0"/>
+          </a:p>
+        </p:txBody>
+      </p:sp>
+      <p:sp>
+        <p:nvSpPr>
+          <p:cNvPr id="5" name="Text 3"/>
+          <p:cNvSpPr/>
+          <p:nvPr/>
+        </p:nvSpPr>
+        <p:spPr>
+          <a:xfrm>
+            <a:off x="5193792" y="1024128"/>
             <a:ext cx="3246120" cy="274320"/>
           </a:xfrm>
           <a:prstGeom prst="rect">
@@ -1342,7 +1381,7 @@
                 <a:ea typeface="Garamond" pitchFamily="34" charset="-122"/>
                 <a:cs typeface="Garamond" pitchFamily="34" charset="-120"/>
               </a:rPr>
-              <a:t>Surveys 1998–2002</a:t>
+              <a:t>Surveys 2003–2019</a:t>
             </a:r>
             <a:endParaRPr lang="en-US" sz="1300" dirty="0"/>
           </a:p>
@@ -1350,13 +1389,13 @@
       </p:sp>
       <p:sp>
         <p:nvSpPr>
-          <p:cNvPr id="5" name="Text 3"/>
-          <p:cNvSpPr/>
-          <p:nvPr/>
-        </p:nvSpPr>
-        <p:spPr>
-          <a:xfrm>
-            <a:off x="1691640" y="1554480"/>
+          <p:cNvPr id="6" name="Text 4"/>
+          <p:cNvSpPr/>
+          <p:nvPr/>
+        </p:nvSpPr>
+        <p:spPr>
+          <a:xfrm>
+            <a:off x="5193792" y="1280160"/>
             <a:ext cx="3246120" cy="274320"/>
           </a:xfrm>
           <a:prstGeom prst="rect">
@@ -1381,7 +1420,7 @@
                 <a:ea typeface="Garamond" pitchFamily="34" charset="-122"/>
                 <a:cs typeface="Garamond" pitchFamily="34" charset="-120"/>
               </a:rPr>
-              <a:t>Census occupation classification of 1990</a:t>
+              <a:t>Census occupation classification of 2002/2010 (SOC)</a:t>
             </a:r>
             <a:endParaRPr lang="en-US" sz="900" dirty="0"/>
           </a:p>
@@ -1389,13 +1428,13 @@
       </p:sp>
       <p:sp>
         <p:nvSpPr>
-          <p:cNvPr id="6" name="Text 4"/>
-          <p:cNvSpPr/>
-          <p:nvPr/>
-        </p:nvSpPr>
-        <p:spPr>
-          <a:xfrm>
-            <a:off x="5193792" y="1298448"/>
+          <p:cNvPr id="7" name="Text 5"/>
+          <p:cNvSpPr/>
+          <p:nvPr/>
+        </p:nvSpPr>
+        <p:spPr>
+          <a:xfrm>
+            <a:off x="8695944" y="1024128"/>
             <a:ext cx="3246120" cy="274320"/>
           </a:xfrm>
           <a:prstGeom prst="rect">
@@ -1420,7 +1459,7 @@
                 <a:ea typeface="Garamond" pitchFamily="34" charset="-122"/>
                 <a:cs typeface="Garamond" pitchFamily="34" charset="-120"/>
               </a:rPr>
-              <a:t>Surveys 2003–2019</a:t>
+              <a:t>Surveys 2020–2025</a:t>
             </a:r>
             <a:endParaRPr lang="en-US" sz="1300" dirty="0"/>
           </a:p>
@@ -1428,13 +1467,13 @@
       </p:sp>
       <p:sp>
         <p:nvSpPr>
-          <p:cNvPr id="7" name="Text 5"/>
-          <p:cNvSpPr/>
-          <p:nvPr/>
-        </p:nvSpPr>
-        <p:spPr>
-          <a:xfrm>
-            <a:off x="5193792" y="1554480"/>
+          <p:cNvPr id="8" name="Text 6"/>
+          <p:cNvSpPr/>
+          <p:nvPr/>
+        </p:nvSpPr>
+        <p:spPr>
+          <a:xfrm>
+            <a:off x="8695944" y="1280160"/>
             <a:ext cx="3246120" cy="274320"/>
           </a:xfrm>
           <a:prstGeom prst="rect">
@@ -1459,7 +1498,7 @@
                 <a:ea typeface="Garamond" pitchFamily="34" charset="-122"/>
                 <a:cs typeface="Garamond" pitchFamily="34" charset="-120"/>
               </a:rPr>
-              <a:t>Census occupation classification of 2002/2010 (SOC)</a:t>
+              <a:t>Census occupation classification of 2018</a:t>
             </a:r>
             <a:endParaRPr lang="en-US" sz="900" dirty="0"/>
           </a:p>
@@ -1467,92 +1506,14 @@
       </p:sp>
       <p:sp>
         <p:nvSpPr>
-          <p:cNvPr id="8" name="Text 6"/>
-          <p:cNvSpPr/>
-          <p:nvPr/>
-        </p:nvSpPr>
-        <p:spPr>
-          <a:xfrm>
-            <a:off x="8695944" y="1298448"/>
-            <a:ext cx="3246120" cy="274320"/>
-          </a:xfrm>
-          <a:prstGeom prst="rect">
-            <a:avLst/>
-          </a:prstGeom>
-          <a:noFill/>
-          <a:ln/>
-        </p:spPr>
-        <p:txBody>
-          <a:bodyPr wrap="square" lIns="0" tIns="0" rIns="0" bIns="0" rtlCol="0" anchor="ctr"/>
-          <a:lstStyle/>
-          <a:p>
-            <a:pPr algn="ctr" indent="0" marL="0">
-              <a:buNone/>
-            </a:pPr>
-            <a:r>
-              <a:rPr lang="en-US" sz="1300" b="1" dirty="0">
-                <a:solidFill>
-                  <a:srgbClr val="1A2430"/>
-                </a:solidFill>
-                <a:latin typeface="Garamond" pitchFamily="34" charset="0"/>
-                <a:ea typeface="Garamond" pitchFamily="34" charset="-122"/>
-                <a:cs typeface="Garamond" pitchFamily="34" charset="-120"/>
-              </a:rPr>
-              <a:t>Surveys 2020–2025</a:t>
-            </a:r>
-            <a:endParaRPr lang="en-US" sz="1300" dirty="0"/>
-          </a:p>
-        </p:txBody>
-      </p:sp>
-      <p:sp>
-        <p:nvSpPr>
           <p:cNvPr id="9" name="Text 7"/>
           <p:cNvSpPr/>
           <p:nvPr/>
         </p:nvSpPr>
         <p:spPr>
           <a:xfrm>
-            <a:off x="8695944" y="1554480"/>
-            <a:ext cx="3246120" cy="274320"/>
-          </a:xfrm>
-          <a:prstGeom prst="rect">
-            <a:avLst/>
-          </a:prstGeom>
-          <a:noFill/>
-          <a:ln/>
-        </p:spPr>
-        <p:txBody>
-          <a:bodyPr wrap="square" lIns="0" tIns="0" rIns="0" bIns="0" rtlCol="0" anchor="ctr"/>
-          <a:lstStyle/>
-          <a:p>
-            <a:pPr algn="ctr" indent="0" marL="0">
-              <a:buNone/>
-            </a:pPr>
-            <a:r>
-              <a:rPr lang="en-US" sz="900" i="1" dirty="0">
-                <a:solidFill>
-                  <a:srgbClr val="6B7480"/>
-                </a:solidFill>
-                <a:latin typeface="Garamond" pitchFamily="34" charset="0"/>
-                <a:ea typeface="Garamond" pitchFamily="34" charset="-122"/>
-                <a:cs typeface="Garamond" pitchFamily="34" charset="-120"/>
-              </a:rPr>
-              <a:t>Census occupation classification of 2018</a:t>
-            </a:r>
-            <a:endParaRPr lang="en-US" sz="900" dirty="0"/>
-          </a:p>
-        </p:txBody>
-      </p:sp>
-      <p:sp>
-        <p:nvSpPr>
-          <p:cNvPr id="10" name="Text 8"/>
-          <p:cNvSpPr/>
-          <p:nvPr/>
-        </p:nvSpPr>
-        <p:spPr>
-          <a:xfrm>
-            <a:off x="228600" y="1920240"/>
-            <a:ext cx="1325880" cy="658368"/>
+            <a:off x="228600" y="1664208"/>
+            <a:ext cx="1325880" cy="685800"/>
           </a:xfrm>
           <a:prstGeom prst="rect">
             <a:avLst/>
@@ -1570,7 +1531,7 @@
             <a:r>
               <a:rPr lang="en-US" sz="1100" b="1" dirty="0">
                 <a:solidFill>
-                  <a:srgbClr val="C08A17"/>
+                  <a:srgbClr val="1F4E79"/>
                 </a:solidFill>
                 <a:latin typeface="Garamond" pitchFamily="34" charset="0"/>
                 <a:ea typeface="Garamond" pitchFamily="34" charset="-122"/>
@@ -1587,7 +1548,7 @@
             <a:r>
               <a:rPr lang="en-US" sz="1100" b="1" dirty="0">
                 <a:solidFill>
-                  <a:srgbClr val="C08A17"/>
+                  <a:srgbClr val="1F4E79"/>
                 </a:solidFill>
                 <a:latin typeface="Garamond" pitchFamily="34" charset="0"/>
                 <a:ea typeface="Garamond" pitchFamily="34" charset="-122"/>
@@ -1601,26 +1562,26 @@
       </p:sp>
       <p:sp>
         <p:nvSpPr>
-          <p:cNvPr id="11" name="Shape 9"/>
-          <p:cNvSpPr/>
-          <p:nvPr/>
-        </p:nvSpPr>
-        <p:spPr>
-          <a:xfrm>
-            <a:off x="1691640" y="1920240"/>
-            <a:ext cx="3246120" cy="658368"/>
+          <p:cNvPr id="10" name="Shape 8"/>
+          <p:cNvSpPr/>
+          <p:nvPr/>
+        </p:nvSpPr>
+        <p:spPr>
+          <a:xfrm>
+            <a:off x="1691640" y="1664208"/>
+            <a:ext cx="3246120" cy="685800"/>
           </a:xfrm>
           <a:prstGeom prst="roundRect">
             <a:avLst>
-              <a:gd name="adj" fmla="val 9722"/>
+              <a:gd name="adj" fmla="val 9333"/>
             </a:avLst>
           </a:prstGeom>
           <a:solidFill>
-            <a:srgbClr val="FBFBF8"/>
+            <a:srgbClr val="EBF1F8"/>
           </a:solidFill>
-          <a:ln w="9525">
+          <a:ln w="15240">
             <a:solidFill>
-              <a:srgbClr val="C9CFD6"/>
+              <a:srgbClr val="1F4E79"/>
             </a:solidFill>
             <a:prstDash val="solid"/>
           </a:ln>
@@ -1628,14 +1589,53 @@
       </p:sp>
       <p:sp>
         <p:nvSpPr>
+          <p:cNvPr id="11" name="Text 9"/>
+          <p:cNvSpPr/>
+          <p:nvPr/>
+        </p:nvSpPr>
+        <p:spPr>
+          <a:xfrm>
+            <a:off x="1801368" y="1664208"/>
+            <a:ext cx="685800" cy="685800"/>
+          </a:xfrm>
+          <a:prstGeom prst="rect">
+            <a:avLst/>
+          </a:prstGeom>
+          <a:noFill/>
+          <a:ln/>
+        </p:spPr>
+        <p:txBody>
+          <a:bodyPr wrap="square" lIns="0" tIns="0" rIns="0" bIns="0" rtlCol="0" anchor="ctr"/>
+          <a:lstStyle/>
+          <a:p>
+            <a:pPr indent="0" marL="0">
+              <a:buNone/>
+            </a:pPr>
+            <a:r>
+              <a:rPr lang="en-US" sz="1600" b="1" dirty="0">
+                <a:solidFill>
+                  <a:srgbClr val="1F4E79"/>
+                </a:solidFill>
+                <a:latin typeface="Garamond" pitchFamily="34" charset="0"/>
+                <a:ea typeface="Garamond" pitchFamily="34" charset="-122"/>
+                <a:cs typeface="Garamond" pitchFamily="34" charset="-120"/>
+              </a:rPr>
+              <a:t>155</a:t>
+            </a:r>
+            <a:endParaRPr lang="en-US" sz="1600" dirty="0"/>
+          </a:p>
+        </p:txBody>
+      </p:sp>
+      <p:sp>
+        <p:nvSpPr>
           <p:cNvPr id="12" name="Text 10"/>
           <p:cNvSpPr/>
           <p:nvPr/>
         </p:nvSpPr>
         <p:spPr>
           <a:xfrm>
-            <a:off x="1801368" y="1920240"/>
-            <a:ext cx="685800" cy="658368"/>
+            <a:off x="2532888" y="1664208"/>
+            <a:ext cx="2286000" cy="685800"/>
           </a:xfrm>
           <a:prstGeom prst="rect">
             <a:avLst/>
@@ -1651,46 +1651,7 @@
               <a:buNone/>
             </a:pPr>
             <a:r>
-              <a:rPr lang="en-US" sz="1500" b="1" dirty="0">
-                <a:solidFill>
-                  <a:srgbClr val="C08A17"/>
-                </a:solidFill>
-                <a:latin typeface="Garamond" pitchFamily="34" charset="0"/>
-                <a:ea typeface="Garamond" pitchFamily="34" charset="-122"/>
-                <a:cs typeface="Garamond" pitchFamily="34" charset="-120"/>
-              </a:rPr>
-              <a:t>155</a:t>
-            </a:r>
-            <a:endParaRPr lang="en-US" sz="1500" dirty="0"/>
-          </a:p>
-        </p:txBody>
-      </p:sp>
-      <p:sp>
-        <p:nvSpPr>
-          <p:cNvPr id="13" name="Text 11"/>
-          <p:cNvSpPr/>
-          <p:nvPr/>
-        </p:nvSpPr>
-        <p:spPr>
-          <a:xfrm>
-            <a:off x="2532888" y="1920240"/>
-            <a:ext cx="2286000" cy="658368"/>
-          </a:xfrm>
-          <a:prstGeom prst="rect">
-            <a:avLst/>
-          </a:prstGeom>
-          <a:noFill/>
-          <a:ln/>
-        </p:spPr>
-        <p:txBody>
-          <a:bodyPr wrap="square" lIns="0" tIns="0" rIns="0" bIns="0" rtlCol="0" anchor="ctr"/>
-          <a:lstStyle/>
-          <a:p>
-            <a:pPr indent="0" marL="0">
-              <a:buNone/>
-            </a:pPr>
-            <a:r>
-              <a:rPr lang="en-US" sz="950" dirty="0">
+              <a:rPr lang="en-US" sz="1000" dirty="0">
                 <a:solidFill>
                   <a:srgbClr val="1A2430"/>
                 </a:solidFill>
@@ -1700,28 +1661,28 @@
               </a:rPr>
               <a:t>Teachers, prekindergarten and kindergarten</a:t>
             </a:r>
-            <a:endParaRPr lang="en-US" sz="950" dirty="0"/>
-          </a:p>
-        </p:txBody>
-      </p:sp>
-      <p:sp>
-        <p:nvSpPr>
-          <p:cNvPr id="14" name="Shape 12"/>
-          <p:cNvSpPr/>
-          <p:nvPr/>
-        </p:nvSpPr>
-        <p:spPr>
-          <a:xfrm>
-            <a:off x="4937760" y="2249424"/>
+            <a:endParaRPr lang="en-US" sz="1000" dirty="0"/>
+          </a:p>
+        </p:txBody>
+      </p:sp>
+      <p:sp>
+        <p:nvSpPr>
+          <p:cNvPr id="13" name="Shape 11"/>
+          <p:cNvSpPr/>
+          <p:nvPr/>
+        </p:nvSpPr>
+        <p:spPr>
+          <a:xfrm>
+            <a:off x="4937760" y="2007108"/>
             <a:ext cx="256032" cy="0"/>
           </a:xfrm>
           <a:prstGeom prst="line">
             <a:avLst/>
           </a:prstGeom>
           <a:noFill/>
-          <a:ln w="9525">
+          <a:ln w="12700">
             <a:solidFill>
-              <a:srgbClr val="C9CFD6"/>
+              <a:srgbClr val="1F4E79"/>
             </a:solidFill>
             <a:prstDash val="solid"/>
           </a:ln>
@@ -1729,26 +1690,26 @@
       </p:sp>
       <p:sp>
         <p:nvSpPr>
-          <p:cNvPr id="15" name="Shape 13"/>
-          <p:cNvSpPr/>
-          <p:nvPr/>
-        </p:nvSpPr>
-        <p:spPr>
-          <a:xfrm>
-            <a:off x="5193792" y="1920240"/>
-            <a:ext cx="3246120" cy="658368"/>
+          <p:cNvPr id="14" name="Shape 12"/>
+          <p:cNvSpPr/>
+          <p:nvPr/>
+        </p:nvSpPr>
+        <p:spPr>
+          <a:xfrm>
+            <a:off x="5193792" y="1664208"/>
+            <a:ext cx="3246120" cy="685800"/>
           </a:xfrm>
           <a:prstGeom prst="roundRect">
             <a:avLst>
-              <a:gd name="adj" fmla="val 9722"/>
+              <a:gd name="adj" fmla="val 9333"/>
             </a:avLst>
           </a:prstGeom>
           <a:solidFill>
-            <a:srgbClr val="FBFBF8"/>
+            <a:srgbClr val="EBF1F8"/>
           </a:solidFill>
-          <a:ln w="9525">
+          <a:ln w="15240">
             <a:solidFill>
-              <a:srgbClr val="C9CFD6"/>
+              <a:srgbClr val="1F4E79"/>
             </a:solidFill>
             <a:prstDash val="solid"/>
           </a:ln>
@@ -1756,14 +1717,53 @@
       </p:sp>
       <p:sp>
         <p:nvSpPr>
+          <p:cNvPr id="15" name="Text 13"/>
+          <p:cNvSpPr/>
+          <p:nvPr/>
+        </p:nvSpPr>
+        <p:spPr>
+          <a:xfrm>
+            <a:off x="5303520" y="1664208"/>
+            <a:ext cx="685800" cy="685800"/>
+          </a:xfrm>
+          <a:prstGeom prst="rect">
+            <a:avLst/>
+          </a:prstGeom>
+          <a:noFill/>
+          <a:ln/>
+        </p:spPr>
+        <p:txBody>
+          <a:bodyPr wrap="square" lIns="0" tIns="0" rIns="0" bIns="0" rtlCol="0" anchor="ctr"/>
+          <a:lstStyle/>
+          <a:p>
+            <a:pPr indent="0" marL="0">
+              <a:buNone/>
+            </a:pPr>
+            <a:r>
+              <a:rPr lang="en-US" sz="1600" b="1" dirty="0">
+                <a:solidFill>
+                  <a:srgbClr val="1F4E79"/>
+                </a:solidFill>
+                <a:latin typeface="Garamond" pitchFamily="34" charset="0"/>
+                <a:ea typeface="Garamond" pitchFamily="34" charset="-122"/>
+                <a:cs typeface="Garamond" pitchFamily="34" charset="-120"/>
+              </a:rPr>
+              <a:t>2300</a:t>
+            </a:r>
+            <a:endParaRPr lang="en-US" sz="1600" dirty="0"/>
+          </a:p>
+        </p:txBody>
+      </p:sp>
+      <p:sp>
+        <p:nvSpPr>
           <p:cNvPr id="16" name="Text 14"/>
           <p:cNvSpPr/>
           <p:nvPr/>
         </p:nvSpPr>
         <p:spPr>
           <a:xfrm>
-            <a:off x="5303520" y="1920240"/>
-            <a:ext cx="685800" cy="658368"/>
+            <a:off x="6035040" y="1664208"/>
+            <a:ext cx="2286000" cy="685800"/>
           </a:xfrm>
           <a:prstGeom prst="rect">
             <a:avLst/>
@@ -1779,46 +1779,7 @@
               <a:buNone/>
             </a:pPr>
             <a:r>
-              <a:rPr lang="en-US" sz="1500" b="1" dirty="0">
-                <a:solidFill>
-                  <a:srgbClr val="C08A17"/>
-                </a:solidFill>
-                <a:latin typeface="Garamond" pitchFamily="34" charset="0"/>
-                <a:ea typeface="Garamond" pitchFamily="34" charset="-122"/>
-                <a:cs typeface="Garamond" pitchFamily="34" charset="-120"/>
-              </a:rPr>
-              <a:t>2300</a:t>
-            </a:r>
-            <a:endParaRPr lang="en-US" sz="1500" dirty="0"/>
-          </a:p>
-        </p:txBody>
-      </p:sp>
-      <p:sp>
-        <p:nvSpPr>
-          <p:cNvPr id="17" name="Text 15"/>
-          <p:cNvSpPr/>
-          <p:nvPr/>
-        </p:nvSpPr>
-        <p:spPr>
-          <a:xfrm>
-            <a:off x="6035040" y="1920240"/>
-            <a:ext cx="2286000" cy="658368"/>
-          </a:xfrm>
-          <a:prstGeom prst="rect">
-            <a:avLst/>
-          </a:prstGeom>
-          <a:noFill/>
-          <a:ln/>
-        </p:spPr>
-        <p:txBody>
-          <a:bodyPr wrap="square" lIns="0" tIns="0" rIns="0" bIns="0" rtlCol="0" anchor="ctr"/>
-          <a:lstStyle/>
-          <a:p>
-            <a:pPr indent="0" marL="0">
-              <a:buNone/>
-            </a:pPr>
-            <a:r>
-              <a:rPr lang="en-US" sz="950" dirty="0">
+              <a:rPr lang="en-US" sz="1000" dirty="0">
                 <a:solidFill>
                   <a:srgbClr val="1A2430"/>
                 </a:solidFill>
@@ -1828,28 +1789,28 @@
               </a:rPr>
               <a:t>Preschool and kindergarten teachers</a:t>
             </a:r>
-            <a:endParaRPr lang="en-US" sz="950" dirty="0"/>
-          </a:p>
-        </p:txBody>
-      </p:sp>
-      <p:sp>
-        <p:nvSpPr>
-          <p:cNvPr id="18" name="Shape 16"/>
-          <p:cNvSpPr/>
-          <p:nvPr/>
-        </p:nvSpPr>
-        <p:spPr>
-          <a:xfrm>
-            <a:off x="8439912" y="2249424"/>
+            <a:endParaRPr lang="en-US" sz="1000" dirty="0"/>
+          </a:p>
+        </p:txBody>
+      </p:sp>
+      <p:sp>
+        <p:nvSpPr>
+          <p:cNvPr id="17" name="Shape 15"/>
+          <p:cNvSpPr/>
+          <p:nvPr/>
+        </p:nvSpPr>
+        <p:spPr>
+          <a:xfrm>
+            <a:off x="8439912" y="2007108"/>
             <a:ext cx="256032" cy="0"/>
           </a:xfrm>
           <a:prstGeom prst="line">
             <a:avLst/>
           </a:prstGeom>
           <a:noFill/>
-          <a:ln w="9525">
+          <a:ln w="12700">
             <a:solidFill>
-              <a:srgbClr val="C9CFD6"/>
+              <a:srgbClr val="1F4E79"/>
             </a:solidFill>
             <a:prstDash val="solid"/>
           </a:ln>
@@ -1857,26 +1818,26 @@
       </p:sp>
       <p:sp>
         <p:nvSpPr>
-          <p:cNvPr id="19" name="Shape 17"/>
-          <p:cNvSpPr/>
-          <p:nvPr/>
-        </p:nvSpPr>
-        <p:spPr>
-          <a:xfrm>
-            <a:off x="8695944" y="1920240"/>
-            <a:ext cx="3246120" cy="658368"/>
+          <p:cNvPr id="18" name="Shape 16"/>
+          <p:cNvSpPr/>
+          <p:nvPr/>
+        </p:nvSpPr>
+        <p:spPr>
+          <a:xfrm>
+            <a:off x="8695944" y="1664208"/>
+            <a:ext cx="3246120" cy="685800"/>
           </a:xfrm>
           <a:prstGeom prst="roundRect">
             <a:avLst>
-              <a:gd name="adj" fmla="val 9722"/>
+              <a:gd name="adj" fmla="val 9333"/>
             </a:avLst>
           </a:prstGeom>
           <a:solidFill>
-            <a:srgbClr val="FBFBF8"/>
+            <a:srgbClr val="EBF1F8"/>
           </a:solidFill>
-          <a:ln w="9525">
+          <a:ln w="15240">
             <a:solidFill>
-              <a:srgbClr val="C9CFD6"/>
+              <a:srgbClr val="1F4E79"/>
             </a:solidFill>
             <a:prstDash val="solid"/>
           </a:ln>
@@ -1884,14 +1845,53 @@
       </p:sp>
       <p:sp>
         <p:nvSpPr>
+          <p:cNvPr id="19" name="Text 17"/>
+          <p:cNvSpPr/>
+          <p:nvPr/>
+        </p:nvSpPr>
+        <p:spPr>
+          <a:xfrm>
+            <a:off x="8805672" y="1664208"/>
+            <a:ext cx="685800" cy="685800"/>
+          </a:xfrm>
+          <a:prstGeom prst="rect">
+            <a:avLst/>
+          </a:prstGeom>
+          <a:noFill/>
+          <a:ln/>
+        </p:spPr>
+        <p:txBody>
+          <a:bodyPr wrap="square" lIns="0" tIns="0" rIns="0" bIns="0" rtlCol="0" anchor="ctr"/>
+          <a:lstStyle/>
+          <a:p>
+            <a:pPr indent="0" marL="0">
+              <a:buNone/>
+            </a:pPr>
+            <a:r>
+              <a:rPr lang="en-US" sz="1600" b="1" dirty="0">
+                <a:solidFill>
+                  <a:srgbClr val="1F4E79"/>
+                </a:solidFill>
+                <a:latin typeface="Garamond" pitchFamily="34" charset="0"/>
+                <a:ea typeface="Garamond" pitchFamily="34" charset="-122"/>
+                <a:cs typeface="Garamond" pitchFamily="34" charset="-120"/>
+              </a:rPr>
+              <a:t>2300</a:t>
+            </a:r>
+            <a:endParaRPr lang="en-US" sz="1600" dirty="0"/>
+          </a:p>
+        </p:txBody>
+      </p:sp>
+      <p:sp>
+        <p:nvSpPr>
           <p:cNvPr id="20" name="Text 18"/>
           <p:cNvSpPr/>
           <p:nvPr/>
         </p:nvSpPr>
         <p:spPr>
           <a:xfrm>
-            <a:off x="8805672" y="1920240"/>
-            <a:ext cx="685800" cy="658368"/>
+            <a:off x="9537192" y="1664208"/>
+            <a:ext cx="2286000" cy="685800"/>
           </a:xfrm>
           <a:prstGeom prst="rect">
             <a:avLst/>
@@ -1907,17 +1907,17 @@
               <a:buNone/>
             </a:pPr>
             <a:r>
-              <a:rPr lang="en-US" sz="1500" b="1" dirty="0">
-                <a:solidFill>
-                  <a:srgbClr val="C08A17"/>
-                </a:solidFill>
-                <a:latin typeface="Garamond" pitchFamily="34" charset="0"/>
-                <a:ea typeface="Garamond" pitchFamily="34" charset="-122"/>
-                <a:cs typeface="Garamond" pitchFamily="34" charset="-120"/>
-              </a:rPr>
-              <a:t>2300</a:t>
-            </a:r>
-            <a:endParaRPr lang="en-US" sz="1500" dirty="0"/>
+              <a:rPr lang="en-US" sz="1000" dirty="0">
+                <a:solidFill>
+                  <a:srgbClr val="1A2430"/>
+                </a:solidFill>
+                <a:latin typeface="Garamond" pitchFamily="34" charset="0"/>
+                <a:ea typeface="Garamond" pitchFamily="34" charset="-122"/>
+                <a:cs typeface="Garamond" pitchFamily="34" charset="-120"/>
+              </a:rPr>
+              <a:t>Preschool and kindergarten teachers</a:t>
+            </a:r>
+            <a:endParaRPr lang="en-US" sz="1000" dirty="0"/>
           </a:p>
         </p:txBody>
       </p:sp>
@@ -1929,47 +1929,8 @@
         </p:nvSpPr>
         <p:spPr>
           <a:xfrm>
-            <a:off x="9537192" y="1920240"/>
-            <a:ext cx="2286000" cy="658368"/>
-          </a:xfrm>
-          <a:prstGeom prst="rect">
-            <a:avLst/>
-          </a:prstGeom>
-          <a:noFill/>
-          <a:ln/>
-        </p:spPr>
-        <p:txBody>
-          <a:bodyPr wrap="square" lIns="0" tIns="0" rIns="0" bIns="0" rtlCol="0" anchor="ctr"/>
-          <a:lstStyle/>
-          <a:p>
-            <a:pPr indent="0" marL="0">
-              <a:buNone/>
-            </a:pPr>
-            <a:r>
-              <a:rPr lang="en-US" sz="950" dirty="0">
-                <a:solidFill>
-                  <a:srgbClr val="1A2430"/>
-                </a:solidFill>
-                <a:latin typeface="Garamond" pitchFamily="34" charset="0"/>
-                <a:ea typeface="Garamond" pitchFamily="34" charset="-122"/>
-                <a:cs typeface="Garamond" pitchFamily="34" charset="-120"/>
-              </a:rPr>
-              <a:t>Preschool and kindergarten teachers</a:t>
-            </a:r>
-            <a:endParaRPr lang="en-US" sz="950" dirty="0"/>
-          </a:p>
-        </p:txBody>
-      </p:sp>
-      <p:sp>
-        <p:nvSpPr>
-          <p:cNvPr id="22" name="Text 20"/>
-          <p:cNvSpPr/>
-          <p:nvPr/>
-        </p:nvSpPr>
-        <p:spPr>
-          <a:xfrm>
-            <a:off x="228600" y="2715768"/>
-            <a:ext cx="1325880" cy="658368"/>
+            <a:off x="228600" y="2505456"/>
+            <a:ext cx="1325880" cy="685800"/>
           </a:xfrm>
           <a:prstGeom prst="rect">
             <a:avLst/>
@@ -1987,7 +1948,7 @@
             <a:r>
               <a:rPr lang="en-US" sz="1100" b="1" dirty="0">
                 <a:solidFill>
-                  <a:srgbClr val="00549F"/>
+                  <a:srgbClr val="1F4E79"/>
                 </a:solidFill>
                 <a:latin typeface="Garamond" pitchFamily="34" charset="0"/>
                 <a:ea typeface="Garamond" pitchFamily="34" charset="-122"/>
@@ -2004,7 +1965,7 @@
             <a:r>
               <a:rPr lang="en-US" sz="1100" b="1" dirty="0">
                 <a:solidFill>
-                  <a:srgbClr val="00549F"/>
+                  <a:srgbClr val="1F4E79"/>
                 </a:solidFill>
                 <a:latin typeface="Garamond" pitchFamily="34" charset="0"/>
                 <a:ea typeface="Garamond" pitchFamily="34" charset="-122"/>
@@ -2018,26 +1979,26 @@
       </p:sp>
       <p:sp>
         <p:nvSpPr>
-          <p:cNvPr id="23" name="Shape 21"/>
-          <p:cNvSpPr/>
-          <p:nvPr/>
-        </p:nvSpPr>
-        <p:spPr>
-          <a:xfrm>
-            <a:off x="1691640" y="2715768"/>
-            <a:ext cx="3246120" cy="658368"/>
+          <p:cNvPr id="22" name="Shape 20"/>
+          <p:cNvSpPr/>
+          <p:nvPr/>
+        </p:nvSpPr>
+        <p:spPr>
+          <a:xfrm>
+            <a:off x="1691640" y="2505456"/>
+            <a:ext cx="3246120" cy="685800"/>
           </a:xfrm>
           <a:prstGeom prst="roundRect">
             <a:avLst>
-              <a:gd name="adj" fmla="val 9722"/>
+              <a:gd name="adj" fmla="val 9333"/>
             </a:avLst>
           </a:prstGeom>
           <a:solidFill>
-            <a:srgbClr val="F8FAFC"/>
+            <a:srgbClr val="EBF1F8"/>
           </a:solidFill>
-          <a:ln w="9525">
+          <a:ln w="15240">
             <a:solidFill>
-              <a:srgbClr val="C9CFD6"/>
+              <a:srgbClr val="1F4E79"/>
             </a:solidFill>
             <a:prstDash val="solid"/>
           </a:ln>
@@ -2045,14 +2006,53 @@
       </p:sp>
       <p:sp>
         <p:nvSpPr>
+          <p:cNvPr id="23" name="Text 21"/>
+          <p:cNvSpPr/>
+          <p:nvPr/>
+        </p:nvSpPr>
+        <p:spPr>
+          <a:xfrm>
+            <a:off x="1801368" y="2505456"/>
+            <a:ext cx="685800" cy="685800"/>
+          </a:xfrm>
+          <a:prstGeom prst="rect">
+            <a:avLst/>
+          </a:prstGeom>
+          <a:noFill/>
+          <a:ln/>
+        </p:spPr>
+        <p:txBody>
+          <a:bodyPr wrap="square" lIns="0" tIns="0" rIns="0" bIns="0" rtlCol="0" anchor="ctr"/>
+          <a:lstStyle/>
+          <a:p>
+            <a:pPr indent="0" marL="0">
+              <a:buNone/>
+            </a:pPr>
+            <a:r>
+              <a:rPr lang="en-US" sz="1600" b="1" dirty="0">
+                <a:solidFill>
+                  <a:srgbClr val="1F4E79"/>
+                </a:solidFill>
+                <a:latin typeface="Garamond" pitchFamily="34" charset="0"/>
+                <a:ea typeface="Garamond" pitchFamily="34" charset="-122"/>
+                <a:cs typeface="Garamond" pitchFamily="34" charset="-120"/>
+              </a:rPr>
+              <a:t>156</a:t>
+            </a:r>
+            <a:endParaRPr lang="en-US" sz="1600" dirty="0"/>
+          </a:p>
+        </p:txBody>
+      </p:sp>
+      <p:sp>
+        <p:nvSpPr>
           <p:cNvPr id="24" name="Text 22"/>
           <p:cNvSpPr/>
           <p:nvPr/>
         </p:nvSpPr>
         <p:spPr>
           <a:xfrm>
-            <a:off x="1801368" y="2715768"/>
-            <a:ext cx="685800" cy="658368"/>
+            <a:off x="2532888" y="2505456"/>
+            <a:ext cx="2286000" cy="685800"/>
           </a:xfrm>
           <a:prstGeom prst="rect">
             <a:avLst/>
@@ -2068,46 +2068,7 @@
               <a:buNone/>
             </a:pPr>
             <a:r>
-              <a:rPr lang="en-US" sz="1500" b="1" dirty="0">
-                <a:solidFill>
-                  <a:srgbClr val="00549F"/>
-                </a:solidFill>
-                <a:latin typeface="Garamond" pitchFamily="34" charset="0"/>
-                <a:ea typeface="Garamond" pitchFamily="34" charset="-122"/>
-                <a:cs typeface="Garamond" pitchFamily="34" charset="-120"/>
-              </a:rPr>
-              <a:t>156</a:t>
-            </a:r>
-            <a:endParaRPr lang="en-US" sz="1500" dirty="0"/>
-          </a:p>
-        </p:txBody>
-      </p:sp>
-      <p:sp>
-        <p:nvSpPr>
-          <p:cNvPr id="25" name="Text 23"/>
-          <p:cNvSpPr/>
-          <p:nvPr/>
-        </p:nvSpPr>
-        <p:spPr>
-          <a:xfrm>
-            <a:off x="2532888" y="2715768"/>
-            <a:ext cx="2286000" cy="658368"/>
-          </a:xfrm>
-          <a:prstGeom prst="rect">
-            <a:avLst/>
-          </a:prstGeom>
-          <a:noFill/>
-          <a:ln/>
-        </p:spPr>
-        <p:txBody>
-          <a:bodyPr wrap="square" lIns="0" tIns="0" rIns="0" bIns="0" rtlCol="0" anchor="ctr"/>
-          <a:lstStyle/>
-          <a:p>
-            <a:pPr indent="0" marL="0">
-              <a:buNone/>
-            </a:pPr>
-            <a:r>
-              <a:rPr lang="en-US" sz="950" dirty="0">
+              <a:rPr lang="en-US" sz="1000" dirty="0">
                 <a:solidFill>
                   <a:srgbClr val="1A2430"/>
                 </a:solidFill>
@@ -2117,28 +2078,28 @@
               </a:rPr>
               <a:t>Teachers, elementary school †</a:t>
             </a:r>
-            <a:endParaRPr lang="en-US" sz="950" dirty="0"/>
-          </a:p>
-        </p:txBody>
-      </p:sp>
-      <p:sp>
-        <p:nvSpPr>
-          <p:cNvPr id="26" name="Shape 24"/>
-          <p:cNvSpPr/>
-          <p:nvPr/>
-        </p:nvSpPr>
-        <p:spPr>
-          <a:xfrm>
-            <a:off x="4937760" y="3044952"/>
+            <a:endParaRPr lang="en-US" sz="1000" dirty="0"/>
+          </a:p>
+        </p:txBody>
+      </p:sp>
+      <p:sp>
+        <p:nvSpPr>
+          <p:cNvPr id="25" name="Shape 23"/>
+          <p:cNvSpPr/>
+          <p:nvPr/>
+        </p:nvSpPr>
+        <p:spPr>
+          <a:xfrm>
+            <a:off x="4937760" y="2848356"/>
             <a:ext cx="256032" cy="0"/>
           </a:xfrm>
           <a:prstGeom prst="line">
             <a:avLst/>
           </a:prstGeom>
           <a:noFill/>
-          <a:ln w="9525">
+          <a:ln w="12700">
             <a:solidFill>
-              <a:srgbClr val="C9CFD6"/>
+              <a:srgbClr val="1F4E79"/>
             </a:solidFill>
             <a:prstDash val="solid"/>
           </a:ln>
@@ -2146,26 +2107,26 @@
       </p:sp>
       <p:sp>
         <p:nvSpPr>
-          <p:cNvPr id="27" name="Shape 25"/>
-          <p:cNvSpPr/>
-          <p:nvPr/>
-        </p:nvSpPr>
-        <p:spPr>
-          <a:xfrm>
-            <a:off x="5193792" y="2715768"/>
-            <a:ext cx="3246120" cy="658368"/>
+          <p:cNvPr id="26" name="Shape 24"/>
+          <p:cNvSpPr/>
+          <p:nvPr/>
+        </p:nvSpPr>
+        <p:spPr>
+          <a:xfrm>
+            <a:off x="5193792" y="2505456"/>
+            <a:ext cx="3246120" cy="685800"/>
           </a:xfrm>
           <a:prstGeom prst="roundRect">
             <a:avLst>
-              <a:gd name="adj" fmla="val 9722"/>
+              <a:gd name="adj" fmla="val 9333"/>
             </a:avLst>
           </a:prstGeom>
           <a:solidFill>
-            <a:srgbClr val="F8FAFC"/>
+            <a:srgbClr val="EBF1F8"/>
           </a:solidFill>
-          <a:ln w="9525">
+          <a:ln w="15240">
             <a:solidFill>
-              <a:srgbClr val="C9CFD6"/>
+              <a:srgbClr val="1F4E79"/>
             </a:solidFill>
             <a:prstDash val="solid"/>
           </a:ln>
@@ -2173,14 +2134,53 @@
       </p:sp>
       <p:sp>
         <p:nvSpPr>
+          <p:cNvPr id="27" name="Text 25"/>
+          <p:cNvSpPr/>
+          <p:nvPr/>
+        </p:nvSpPr>
+        <p:spPr>
+          <a:xfrm>
+            <a:off x="5303520" y="2505456"/>
+            <a:ext cx="685800" cy="685800"/>
+          </a:xfrm>
+          <a:prstGeom prst="rect">
+            <a:avLst/>
+          </a:prstGeom>
+          <a:noFill/>
+          <a:ln/>
+        </p:spPr>
+        <p:txBody>
+          <a:bodyPr wrap="square" lIns="0" tIns="0" rIns="0" bIns="0" rtlCol="0" anchor="ctr"/>
+          <a:lstStyle/>
+          <a:p>
+            <a:pPr indent="0" marL="0">
+              <a:buNone/>
+            </a:pPr>
+            <a:r>
+              <a:rPr lang="en-US" sz="1600" b="1" dirty="0">
+                <a:solidFill>
+                  <a:srgbClr val="1F4E79"/>
+                </a:solidFill>
+                <a:latin typeface="Garamond" pitchFamily="34" charset="0"/>
+                <a:ea typeface="Garamond" pitchFamily="34" charset="-122"/>
+                <a:cs typeface="Garamond" pitchFamily="34" charset="-120"/>
+              </a:rPr>
+              <a:t>2310</a:t>
+            </a:r>
+            <a:endParaRPr lang="en-US" sz="1600" dirty="0"/>
+          </a:p>
+        </p:txBody>
+      </p:sp>
+      <p:sp>
+        <p:nvSpPr>
           <p:cNvPr id="28" name="Text 26"/>
           <p:cNvSpPr/>
           <p:nvPr/>
         </p:nvSpPr>
         <p:spPr>
           <a:xfrm>
-            <a:off x="5303520" y="2715768"/>
-            <a:ext cx="685800" cy="658368"/>
+            <a:off x="6035040" y="2505456"/>
+            <a:ext cx="2286000" cy="685800"/>
           </a:xfrm>
           <a:prstGeom prst="rect">
             <a:avLst/>
@@ -2196,46 +2196,7 @@
               <a:buNone/>
             </a:pPr>
             <a:r>
-              <a:rPr lang="en-US" sz="1500" b="1" dirty="0">
-                <a:solidFill>
-                  <a:srgbClr val="00549F"/>
-                </a:solidFill>
-                <a:latin typeface="Garamond" pitchFamily="34" charset="0"/>
-                <a:ea typeface="Garamond" pitchFamily="34" charset="-122"/>
-                <a:cs typeface="Garamond" pitchFamily="34" charset="-120"/>
-              </a:rPr>
-              <a:t>2310</a:t>
-            </a:r>
-            <a:endParaRPr lang="en-US" sz="1500" dirty="0"/>
-          </a:p>
-        </p:txBody>
-      </p:sp>
-      <p:sp>
-        <p:nvSpPr>
-          <p:cNvPr id="29" name="Text 27"/>
-          <p:cNvSpPr/>
-          <p:nvPr/>
-        </p:nvSpPr>
-        <p:spPr>
-          <a:xfrm>
-            <a:off x="6035040" y="2715768"/>
-            <a:ext cx="2286000" cy="658368"/>
-          </a:xfrm>
-          <a:prstGeom prst="rect">
-            <a:avLst/>
-          </a:prstGeom>
-          <a:noFill/>
-          <a:ln/>
-        </p:spPr>
-        <p:txBody>
-          <a:bodyPr wrap="square" lIns="0" tIns="0" rIns="0" bIns="0" rtlCol="0" anchor="ctr"/>
-          <a:lstStyle/>
-          <a:p>
-            <a:pPr indent="0" marL="0">
-              <a:buNone/>
-            </a:pPr>
-            <a:r>
-              <a:rPr lang="en-US" sz="950" dirty="0">
+              <a:rPr lang="en-US" sz="1000" dirty="0">
                 <a:solidFill>
                   <a:srgbClr val="1A2430"/>
                 </a:solidFill>
@@ -2245,28 +2206,28 @@
               </a:rPr>
               <a:t>Elementary and middle school teachers</a:t>
             </a:r>
-            <a:endParaRPr lang="en-US" sz="950" dirty="0"/>
-          </a:p>
-        </p:txBody>
-      </p:sp>
-      <p:sp>
-        <p:nvSpPr>
-          <p:cNvPr id="30" name="Shape 28"/>
-          <p:cNvSpPr/>
-          <p:nvPr/>
-        </p:nvSpPr>
-        <p:spPr>
-          <a:xfrm>
-            <a:off x="8439912" y="3044952"/>
+            <a:endParaRPr lang="en-US" sz="1000" dirty="0"/>
+          </a:p>
+        </p:txBody>
+      </p:sp>
+      <p:sp>
+        <p:nvSpPr>
+          <p:cNvPr id="29" name="Shape 27"/>
+          <p:cNvSpPr/>
+          <p:nvPr/>
+        </p:nvSpPr>
+        <p:spPr>
+          <a:xfrm>
+            <a:off x="8439912" y="2848356"/>
             <a:ext cx="256032" cy="0"/>
           </a:xfrm>
           <a:prstGeom prst="line">
             <a:avLst/>
           </a:prstGeom>
           <a:noFill/>
-          <a:ln w="9525">
+          <a:ln w="12700">
             <a:solidFill>
-              <a:srgbClr val="C9CFD6"/>
+              <a:srgbClr val="1F4E79"/>
             </a:solidFill>
             <a:prstDash val="solid"/>
           </a:ln>
@@ -2274,26 +2235,26 @@
       </p:sp>
       <p:sp>
         <p:nvSpPr>
-          <p:cNvPr id="31" name="Shape 29"/>
-          <p:cNvSpPr/>
-          <p:nvPr/>
-        </p:nvSpPr>
-        <p:spPr>
-          <a:xfrm>
-            <a:off x="8695944" y="2715768"/>
-            <a:ext cx="3246120" cy="658368"/>
+          <p:cNvPr id="30" name="Shape 28"/>
+          <p:cNvSpPr/>
+          <p:nvPr/>
+        </p:nvSpPr>
+        <p:spPr>
+          <a:xfrm>
+            <a:off x="8695944" y="2505456"/>
+            <a:ext cx="3246120" cy="685800"/>
           </a:xfrm>
           <a:prstGeom prst="roundRect">
             <a:avLst>
-              <a:gd name="adj" fmla="val 9722"/>
+              <a:gd name="adj" fmla="val 9333"/>
             </a:avLst>
           </a:prstGeom>
           <a:solidFill>
-            <a:srgbClr val="F8FAFC"/>
+            <a:srgbClr val="EBF1F8"/>
           </a:solidFill>
-          <a:ln w="9525">
+          <a:ln w="15240">
             <a:solidFill>
-              <a:srgbClr val="C9CFD6"/>
+              <a:srgbClr val="1F4E79"/>
             </a:solidFill>
             <a:prstDash val="solid"/>
           </a:ln>
@@ -2301,14 +2262,53 @@
       </p:sp>
       <p:sp>
         <p:nvSpPr>
+          <p:cNvPr id="31" name="Text 29"/>
+          <p:cNvSpPr/>
+          <p:nvPr/>
+        </p:nvSpPr>
+        <p:spPr>
+          <a:xfrm>
+            <a:off x="8805672" y="2505456"/>
+            <a:ext cx="685800" cy="685800"/>
+          </a:xfrm>
+          <a:prstGeom prst="rect">
+            <a:avLst/>
+          </a:prstGeom>
+          <a:noFill/>
+          <a:ln/>
+        </p:spPr>
+        <p:txBody>
+          <a:bodyPr wrap="square" lIns="0" tIns="0" rIns="0" bIns="0" rtlCol="0" anchor="ctr"/>
+          <a:lstStyle/>
+          <a:p>
+            <a:pPr indent="0" marL="0">
+              <a:buNone/>
+            </a:pPr>
+            <a:r>
+              <a:rPr lang="en-US" sz="1600" b="1" dirty="0">
+                <a:solidFill>
+                  <a:srgbClr val="1F4E79"/>
+                </a:solidFill>
+                <a:latin typeface="Garamond" pitchFamily="34" charset="0"/>
+                <a:ea typeface="Garamond" pitchFamily="34" charset="-122"/>
+                <a:cs typeface="Garamond" pitchFamily="34" charset="-120"/>
+              </a:rPr>
+              <a:t>2310</a:t>
+            </a:r>
+            <a:endParaRPr lang="en-US" sz="1600" dirty="0"/>
+          </a:p>
+        </p:txBody>
+      </p:sp>
+      <p:sp>
+        <p:nvSpPr>
           <p:cNvPr id="32" name="Text 30"/>
           <p:cNvSpPr/>
           <p:nvPr/>
         </p:nvSpPr>
         <p:spPr>
           <a:xfrm>
-            <a:off x="8805672" y="2715768"/>
-            <a:ext cx="685800" cy="658368"/>
+            <a:off x="9537192" y="2505456"/>
+            <a:ext cx="2286000" cy="685800"/>
           </a:xfrm>
           <a:prstGeom prst="rect">
             <a:avLst/>
@@ -2324,17 +2324,17 @@
               <a:buNone/>
             </a:pPr>
             <a:r>
-              <a:rPr lang="en-US" sz="1500" b="1" dirty="0">
-                <a:solidFill>
-                  <a:srgbClr val="00549F"/>
-                </a:solidFill>
-                <a:latin typeface="Garamond" pitchFamily="34" charset="0"/>
-                <a:ea typeface="Garamond" pitchFamily="34" charset="-122"/>
-                <a:cs typeface="Garamond" pitchFamily="34" charset="-120"/>
-              </a:rPr>
-              <a:t>2310</a:t>
-            </a:r>
-            <a:endParaRPr lang="en-US" sz="1500" dirty="0"/>
+              <a:rPr lang="en-US" sz="1000" dirty="0">
+                <a:solidFill>
+                  <a:srgbClr val="1A2430"/>
+                </a:solidFill>
+                <a:latin typeface="Garamond" pitchFamily="34" charset="0"/>
+                <a:ea typeface="Garamond" pitchFamily="34" charset="-122"/>
+                <a:cs typeface="Garamond" pitchFamily="34" charset="-120"/>
+              </a:rPr>
+              <a:t>Elementary and middle school teachers</a:t>
+            </a:r>
+            <a:endParaRPr lang="en-US" sz="1000" dirty="0"/>
           </a:p>
         </p:txBody>
       </p:sp>
@@ -2346,47 +2346,8 @@
         </p:nvSpPr>
         <p:spPr>
           <a:xfrm>
-            <a:off x="9537192" y="2715768"/>
-            <a:ext cx="2286000" cy="658368"/>
-          </a:xfrm>
-          <a:prstGeom prst="rect">
-            <a:avLst/>
-          </a:prstGeom>
-          <a:noFill/>
-          <a:ln/>
-        </p:spPr>
-        <p:txBody>
-          <a:bodyPr wrap="square" lIns="0" tIns="0" rIns="0" bIns="0" rtlCol="0" anchor="ctr"/>
-          <a:lstStyle/>
-          <a:p>
-            <a:pPr indent="0" marL="0">
-              <a:buNone/>
-            </a:pPr>
-            <a:r>
-              <a:rPr lang="en-US" sz="950" dirty="0">
-                <a:solidFill>
-                  <a:srgbClr val="1A2430"/>
-                </a:solidFill>
-                <a:latin typeface="Garamond" pitchFamily="34" charset="0"/>
-                <a:ea typeface="Garamond" pitchFamily="34" charset="-122"/>
-                <a:cs typeface="Garamond" pitchFamily="34" charset="-120"/>
-              </a:rPr>
-              <a:t>Elementary and middle school teachers</a:t>
-            </a:r>
-            <a:endParaRPr lang="en-US" sz="950" dirty="0"/>
-          </a:p>
-        </p:txBody>
-      </p:sp>
-      <p:sp>
-        <p:nvSpPr>
-          <p:cNvPr id="34" name="Text 32"/>
-          <p:cNvSpPr/>
-          <p:nvPr/>
-        </p:nvSpPr>
-        <p:spPr>
-          <a:xfrm>
-            <a:off x="228600" y="3511296"/>
-            <a:ext cx="1325880" cy="658368"/>
+            <a:off x="228600" y="3346704"/>
+            <a:ext cx="1325880" cy="685800"/>
           </a:xfrm>
           <a:prstGeom prst="rect">
             <a:avLst/>
@@ -2404,7 +2365,7 @@
             <a:r>
               <a:rPr lang="en-US" sz="1100" b="1" dirty="0">
                 <a:solidFill>
-                  <a:srgbClr val="3A8A62"/>
+                  <a:srgbClr val="1F4E79"/>
                 </a:solidFill>
                 <a:latin typeface="Garamond" pitchFamily="34" charset="0"/>
                 <a:ea typeface="Garamond" pitchFamily="34" charset="-122"/>
@@ -2418,26 +2379,26 @@
       </p:sp>
       <p:sp>
         <p:nvSpPr>
-          <p:cNvPr id="35" name="Shape 33"/>
-          <p:cNvSpPr/>
-          <p:nvPr/>
-        </p:nvSpPr>
-        <p:spPr>
-          <a:xfrm>
-            <a:off x="1691640" y="3511296"/>
-            <a:ext cx="3246120" cy="658368"/>
+          <p:cNvPr id="34" name="Shape 32"/>
+          <p:cNvSpPr/>
+          <p:nvPr/>
+        </p:nvSpPr>
+        <p:spPr>
+          <a:xfrm>
+            <a:off x="1691640" y="3346704"/>
+            <a:ext cx="3246120" cy="685800"/>
           </a:xfrm>
           <a:prstGeom prst="roundRect">
             <a:avLst>
-              <a:gd name="adj" fmla="val 9722"/>
+              <a:gd name="adj" fmla="val 9333"/>
             </a:avLst>
           </a:prstGeom>
           <a:solidFill>
-            <a:srgbClr val="F8FBF9"/>
+            <a:srgbClr val="EBF1F8"/>
           </a:solidFill>
-          <a:ln w="9525">
+          <a:ln w="15240">
             <a:solidFill>
-              <a:srgbClr val="C9CFD6"/>
+              <a:srgbClr val="1F4E79"/>
             </a:solidFill>
             <a:prstDash val="solid"/>
           </a:ln>
@@ -2445,14 +2406,53 @@
       </p:sp>
       <p:sp>
         <p:nvSpPr>
+          <p:cNvPr id="35" name="Text 33"/>
+          <p:cNvSpPr/>
+          <p:nvPr/>
+        </p:nvSpPr>
+        <p:spPr>
+          <a:xfrm>
+            <a:off x="1801368" y="3346704"/>
+            <a:ext cx="685800" cy="685800"/>
+          </a:xfrm>
+          <a:prstGeom prst="rect">
+            <a:avLst/>
+          </a:prstGeom>
+          <a:noFill/>
+          <a:ln/>
+        </p:spPr>
+        <p:txBody>
+          <a:bodyPr wrap="square" lIns="0" tIns="0" rIns="0" bIns="0" rtlCol="0" anchor="ctr"/>
+          <a:lstStyle/>
+          <a:p>
+            <a:pPr indent="0" marL="0">
+              <a:buNone/>
+            </a:pPr>
+            <a:r>
+              <a:rPr lang="en-US" sz="1600" b="1" dirty="0">
+                <a:solidFill>
+                  <a:srgbClr val="1F4E79"/>
+                </a:solidFill>
+                <a:latin typeface="Garamond" pitchFamily="34" charset="0"/>
+                <a:ea typeface="Garamond" pitchFamily="34" charset="-122"/>
+                <a:cs typeface="Garamond" pitchFamily="34" charset="-120"/>
+              </a:rPr>
+              <a:t>157</a:t>
+            </a:r>
+            <a:endParaRPr lang="en-US" sz="1600" dirty="0"/>
+          </a:p>
+        </p:txBody>
+      </p:sp>
+      <p:sp>
+        <p:nvSpPr>
           <p:cNvPr id="36" name="Text 34"/>
           <p:cNvSpPr/>
           <p:nvPr/>
         </p:nvSpPr>
         <p:spPr>
           <a:xfrm>
-            <a:off x="1801368" y="3511296"/>
-            <a:ext cx="685800" cy="658368"/>
+            <a:off x="2532888" y="3346704"/>
+            <a:ext cx="2286000" cy="685800"/>
           </a:xfrm>
           <a:prstGeom prst="rect">
             <a:avLst/>
@@ -2468,46 +2468,7 @@
               <a:buNone/>
             </a:pPr>
             <a:r>
-              <a:rPr lang="en-US" sz="1500" b="1" dirty="0">
-                <a:solidFill>
-                  <a:srgbClr val="3A8A62"/>
-                </a:solidFill>
-                <a:latin typeface="Garamond" pitchFamily="34" charset="0"/>
-                <a:ea typeface="Garamond" pitchFamily="34" charset="-122"/>
-                <a:cs typeface="Garamond" pitchFamily="34" charset="-120"/>
-              </a:rPr>
-              <a:t>157</a:t>
-            </a:r>
-            <a:endParaRPr lang="en-US" sz="1500" dirty="0"/>
-          </a:p>
-        </p:txBody>
-      </p:sp>
-      <p:sp>
-        <p:nvSpPr>
-          <p:cNvPr id="37" name="Text 35"/>
-          <p:cNvSpPr/>
-          <p:nvPr/>
-        </p:nvSpPr>
-        <p:spPr>
-          <a:xfrm>
-            <a:off x="2532888" y="3511296"/>
-            <a:ext cx="2286000" cy="658368"/>
-          </a:xfrm>
-          <a:prstGeom prst="rect">
-            <a:avLst/>
-          </a:prstGeom>
-          <a:noFill/>
-          <a:ln/>
-        </p:spPr>
-        <p:txBody>
-          <a:bodyPr wrap="square" lIns="0" tIns="0" rIns="0" bIns="0" rtlCol="0" anchor="ctr"/>
-          <a:lstStyle/>
-          <a:p>
-            <a:pPr indent="0" marL="0">
-              <a:buNone/>
-            </a:pPr>
-            <a:r>
-              <a:rPr lang="en-US" sz="950" dirty="0">
+              <a:rPr lang="en-US" sz="1000" dirty="0">
                 <a:solidFill>
                   <a:srgbClr val="1A2430"/>
                 </a:solidFill>
@@ -2517,28 +2478,28 @@
               </a:rPr>
               <a:t>Teachers, secondary school †</a:t>
             </a:r>
-            <a:endParaRPr lang="en-US" sz="950" dirty="0"/>
-          </a:p>
-        </p:txBody>
-      </p:sp>
-      <p:sp>
-        <p:nvSpPr>
-          <p:cNvPr id="38" name="Shape 36"/>
-          <p:cNvSpPr/>
-          <p:nvPr/>
-        </p:nvSpPr>
-        <p:spPr>
-          <a:xfrm>
-            <a:off x="4937760" y="3840480"/>
+            <a:endParaRPr lang="en-US" sz="1000" dirty="0"/>
+          </a:p>
+        </p:txBody>
+      </p:sp>
+      <p:sp>
+        <p:nvSpPr>
+          <p:cNvPr id="37" name="Shape 35"/>
+          <p:cNvSpPr/>
+          <p:nvPr/>
+        </p:nvSpPr>
+        <p:spPr>
+          <a:xfrm>
+            <a:off x="4937760" y="3689604"/>
             <a:ext cx="256032" cy="0"/>
           </a:xfrm>
           <a:prstGeom prst="line">
             <a:avLst/>
           </a:prstGeom>
           <a:noFill/>
-          <a:ln w="9525">
+          <a:ln w="12700">
             <a:solidFill>
-              <a:srgbClr val="C9CFD6"/>
+              <a:srgbClr val="1F4E79"/>
             </a:solidFill>
             <a:prstDash val="solid"/>
           </a:ln>
@@ -2546,26 +2507,26 @@
       </p:sp>
       <p:sp>
         <p:nvSpPr>
-          <p:cNvPr id="39" name="Shape 37"/>
-          <p:cNvSpPr/>
-          <p:nvPr/>
-        </p:nvSpPr>
-        <p:spPr>
-          <a:xfrm>
-            <a:off x="5193792" y="3511296"/>
-            <a:ext cx="3246120" cy="658368"/>
+          <p:cNvPr id="38" name="Shape 36"/>
+          <p:cNvSpPr/>
+          <p:nvPr/>
+        </p:nvSpPr>
+        <p:spPr>
+          <a:xfrm>
+            <a:off x="5193792" y="3346704"/>
+            <a:ext cx="3246120" cy="685800"/>
           </a:xfrm>
           <a:prstGeom prst="roundRect">
             <a:avLst>
-              <a:gd name="adj" fmla="val 9722"/>
+              <a:gd name="adj" fmla="val 9333"/>
             </a:avLst>
           </a:prstGeom>
           <a:solidFill>
-            <a:srgbClr val="F8FBF9"/>
+            <a:srgbClr val="EBF1F8"/>
           </a:solidFill>
-          <a:ln w="9525">
+          <a:ln w="15240">
             <a:solidFill>
-              <a:srgbClr val="C9CFD6"/>
+              <a:srgbClr val="1F4E79"/>
             </a:solidFill>
             <a:prstDash val="solid"/>
           </a:ln>
@@ -2573,14 +2534,53 @@
       </p:sp>
       <p:sp>
         <p:nvSpPr>
+          <p:cNvPr id="39" name="Text 37"/>
+          <p:cNvSpPr/>
+          <p:nvPr/>
+        </p:nvSpPr>
+        <p:spPr>
+          <a:xfrm>
+            <a:off x="5303520" y="3346704"/>
+            <a:ext cx="685800" cy="685800"/>
+          </a:xfrm>
+          <a:prstGeom prst="rect">
+            <a:avLst/>
+          </a:prstGeom>
+          <a:noFill/>
+          <a:ln/>
+        </p:spPr>
+        <p:txBody>
+          <a:bodyPr wrap="square" lIns="0" tIns="0" rIns="0" bIns="0" rtlCol="0" anchor="ctr"/>
+          <a:lstStyle/>
+          <a:p>
+            <a:pPr indent="0" marL="0">
+              <a:buNone/>
+            </a:pPr>
+            <a:r>
+              <a:rPr lang="en-US" sz="1600" b="1" dirty="0">
+                <a:solidFill>
+                  <a:srgbClr val="1F4E79"/>
+                </a:solidFill>
+                <a:latin typeface="Garamond" pitchFamily="34" charset="0"/>
+                <a:ea typeface="Garamond" pitchFamily="34" charset="-122"/>
+                <a:cs typeface="Garamond" pitchFamily="34" charset="-120"/>
+              </a:rPr>
+              <a:t>2320</a:t>
+            </a:r>
+            <a:endParaRPr lang="en-US" sz="1600" dirty="0"/>
+          </a:p>
+        </p:txBody>
+      </p:sp>
+      <p:sp>
+        <p:nvSpPr>
           <p:cNvPr id="40" name="Text 38"/>
           <p:cNvSpPr/>
           <p:nvPr/>
         </p:nvSpPr>
         <p:spPr>
           <a:xfrm>
-            <a:off x="5303520" y="3511296"/>
-            <a:ext cx="685800" cy="658368"/>
+            <a:off x="6035040" y="3346704"/>
+            <a:ext cx="2286000" cy="685800"/>
           </a:xfrm>
           <a:prstGeom prst="rect">
             <a:avLst/>
@@ -2596,46 +2596,7 @@
               <a:buNone/>
             </a:pPr>
             <a:r>
-              <a:rPr lang="en-US" sz="1500" b="1" dirty="0">
-                <a:solidFill>
-                  <a:srgbClr val="3A8A62"/>
-                </a:solidFill>
-                <a:latin typeface="Garamond" pitchFamily="34" charset="0"/>
-                <a:ea typeface="Garamond" pitchFamily="34" charset="-122"/>
-                <a:cs typeface="Garamond" pitchFamily="34" charset="-120"/>
-              </a:rPr>
-              <a:t>2320</a:t>
-            </a:r>
-            <a:endParaRPr lang="en-US" sz="1500" dirty="0"/>
-          </a:p>
-        </p:txBody>
-      </p:sp>
-      <p:sp>
-        <p:nvSpPr>
-          <p:cNvPr id="41" name="Text 39"/>
-          <p:cNvSpPr/>
-          <p:nvPr/>
-        </p:nvSpPr>
-        <p:spPr>
-          <a:xfrm>
-            <a:off x="6035040" y="3511296"/>
-            <a:ext cx="2286000" cy="658368"/>
-          </a:xfrm>
-          <a:prstGeom prst="rect">
-            <a:avLst/>
-          </a:prstGeom>
-          <a:noFill/>
-          <a:ln/>
-        </p:spPr>
-        <p:txBody>
-          <a:bodyPr wrap="square" lIns="0" tIns="0" rIns="0" bIns="0" rtlCol="0" anchor="ctr"/>
-          <a:lstStyle/>
-          <a:p>
-            <a:pPr indent="0" marL="0">
-              <a:buNone/>
-            </a:pPr>
-            <a:r>
-              <a:rPr lang="en-US" sz="950" dirty="0">
+              <a:rPr lang="en-US" sz="1000" dirty="0">
                 <a:solidFill>
                   <a:srgbClr val="1A2430"/>
                 </a:solidFill>
@@ -2645,28 +2606,28 @@
               </a:rPr>
               <a:t>Secondary school teachers</a:t>
             </a:r>
-            <a:endParaRPr lang="en-US" sz="950" dirty="0"/>
-          </a:p>
-        </p:txBody>
-      </p:sp>
-      <p:sp>
-        <p:nvSpPr>
-          <p:cNvPr id="42" name="Shape 40"/>
-          <p:cNvSpPr/>
-          <p:nvPr/>
-        </p:nvSpPr>
-        <p:spPr>
-          <a:xfrm>
-            <a:off x="8439912" y="3840480"/>
+            <a:endParaRPr lang="en-US" sz="1000" dirty="0"/>
+          </a:p>
+        </p:txBody>
+      </p:sp>
+      <p:sp>
+        <p:nvSpPr>
+          <p:cNvPr id="41" name="Shape 39"/>
+          <p:cNvSpPr/>
+          <p:nvPr/>
+        </p:nvSpPr>
+        <p:spPr>
+          <a:xfrm>
+            <a:off x="8439912" y="3689604"/>
             <a:ext cx="256032" cy="0"/>
           </a:xfrm>
           <a:prstGeom prst="line">
             <a:avLst/>
           </a:prstGeom>
           <a:noFill/>
-          <a:ln w="9525">
+          <a:ln w="12700">
             <a:solidFill>
-              <a:srgbClr val="C9CFD6"/>
+              <a:srgbClr val="1F4E79"/>
             </a:solidFill>
             <a:prstDash val="solid"/>
           </a:ln>
@@ -2674,26 +2635,26 @@
       </p:sp>
       <p:sp>
         <p:nvSpPr>
-          <p:cNvPr id="43" name="Shape 41"/>
-          <p:cNvSpPr/>
-          <p:nvPr/>
-        </p:nvSpPr>
-        <p:spPr>
-          <a:xfrm>
-            <a:off x="8695944" y="3511296"/>
-            <a:ext cx="3246120" cy="658368"/>
+          <p:cNvPr id="42" name="Shape 40"/>
+          <p:cNvSpPr/>
+          <p:nvPr/>
+        </p:nvSpPr>
+        <p:spPr>
+          <a:xfrm>
+            <a:off x="8695944" y="3346704"/>
+            <a:ext cx="3246120" cy="685800"/>
           </a:xfrm>
           <a:prstGeom prst="roundRect">
             <a:avLst>
-              <a:gd name="adj" fmla="val 9722"/>
+              <a:gd name="adj" fmla="val 9333"/>
             </a:avLst>
           </a:prstGeom>
           <a:solidFill>
-            <a:srgbClr val="F8FBF9"/>
+            <a:srgbClr val="EBF1F8"/>
           </a:solidFill>
-          <a:ln w="9525">
+          <a:ln w="15240">
             <a:solidFill>
-              <a:srgbClr val="C9CFD6"/>
+              <a:srgbClr val="1F4E79"/>
             </a:solidFill>
             <a:prstDash val="solid"/>
           </a:ln>
@@ -2701,14 +2662,53 @@
       </p:sp>
       <p:sp>
         <p:nvSpPr>
+          <p:cNvPr id="43" name="Text 41"/>
+          <p:cNvSpPr/>
+          <p:nvPr/>
+        </p:nvSpPr>
+        <p:spPr>
+          <a:xfrm>
+            <a:off x="8805672" y="3346704"/>
+            <a:ext cx="685800" cy="685800"/>
+          </a:xfrm>
+          <a:prstGeom prst="rect">
+            <a:avLst/>
+          </a:prstGeom>
+          <a:noFill/>
+          <a:ln/>
+        </p:spPr>
+        <p:txBody>
+          <a:bodyPr wrap="square" lIns="0" tIns="0" rIns="0" bIns="0" rtlCol="0" anchor="ctr"/>
+          <a:lstStyle/>
+          <a:p>
+            <a:pPr indent="0" marL="0">
+              <a:buNone/>
+            </a:pPr>
+            <a:r>
+              <a:rPr lang="en-US" sz="1600" b="1" dirty="0">
+                <a:solidFill>
+                  <a:srgbClr val="1F4E79"/>
+                </a:solidFill>
+                <a:latin typeface="Garamond" pitchFamily="34" charset="0"/>
+                <a:ea typeface="Garamond" pitchFamily="34" charset="-122"/>
+                <a:cs typeface="Garamond" pitchFamily="34" charset="-120"/>
+              </a:rPr>
+              <a:t>2320</a:t>
+            </a:r>
+            <a:endParaRPr lang="en-US" sz="1600" dirty="0"/>
+          </a:p>
+        </p:txBody>
+      </p:sp>
+      <p:sp>
+        <p:nvSpPr>
           <p:cNvPr id="44" name="Text 42"/>
           <p:cNvSpPr/>
           <p:nvPr/>
         </p:nvSpPr>
         <p:spPr>
           <a:xfrm>
-            <a:off x="8805672" y="3511296"/>
-            <a:ext cx="685800" cy="658368"/>
+            <a:off x="9537192" y="3346704"/>
+            <a:ext cx="2286000" cy="685800"/>
           </a:xfrm>
           <a:prstGeom prst="rect">
             <a:avLst/>
@@ -2724,17 +2724,17 @@
               <a:buNone/>
             </a:pPr>
             <a:r>
-              <a:rPr lang="en-US" sz="1500" b="1" dirty="0">
-                <a:solidFill>
-                  <a:srgbClr val="3A8A62"/>
-                </a:solidFill>
-                <a:latin typeface="Garamond" pitchFamily="34" charset="0"/>
-                <a:ea typeface="Garamond" pitchFamily="34" charset="-122"/>
-                <a:cs typeface="Garamond" pitchFamily="34" charset="-120"/>
-              </a:rPr>
-              <a:t>2320</a:t>
-            </a:r>
-            <a:endParaRPr lang="en-US" sz="1500" dirty="0"/>
+              <a:rPr lang="en-US" sz="1000" dirty="0">
+                <a:solidFill>
+                  <a:srgbClr val="1A2430"/>
+                </a:solidFill>
+                <a:latin typeface="Garamond" pitchFamily="34" charset="0"/>
+                <a:ea typeface="Garamond" pitchFamily="34" charset="-122"/>
+                <a:cs typeface="Garamond" pitchFamily="34" charset="-120"/>
+              </a:rPr>
+              <a:t>Secondary school teachers</a:t>
+            </a:r>
+            <a:endParaRPr lang="en-US" sz="1000" dirty="0"/>
           </a:p>
         </p:txBody>
       </p:sp>
@@ -2746,47 +2746,8 @@
         </p:nvSpPr>
         <p:spPr>
           <a:xfrm>
-            <a:off x="9537192" y="3511296"/>
-            <a:ext cx="2286000" cy="658368"/>
-          </a:xfrm>
-          <a:prstGeom prst="rect">
-            <a:avLst/>
-          </a:prstGeom>
-          <a:noFill/>
-          <a:ln/>
-        </p:spPr>
-        <p:txBody>
-          <a:bodyPr wrap="square" lIns="0" tIns="0" rIns="0" bIns="0" rtlCol="0" anchor="ctr"/>
-          <a:lstStyle/>
-          <a:p>
-            <a:pPr indent="0" marL="0">
-              <a:buNone/>
-            </a:pPr>
-            <a:r>
-              <a:rPr lang="en-US" sz="950" dirty="0">
-                <a:solidFill>
-                  <a:srgbClr val="1A2430"/>
-                </a:solidFill>
-                <a:latin typeface="Garamond" pitchFamily="34" charset="0"/>
-                <a:ea typeface="Garamond" pitchFamily="34" charset="-122"/>
-                <a:cs typeface="Garamond" pitchFamily="34" charset="-120"/>
-              </a:rPr>
-              <a:t>Secondary school teachers</a:t>
-            </a:r>
-            <a:endParaRPr lang="en-US" sz="950" dirty="0"/>
-          </a:p>
-        </p:txBody>
-      </p:sp>
-      <p:sp>
-        <p:nvSpPr>
-          <p:cNvPr id="46" name="Text 44"/>
-          <p:cNvSpPr/>
-          <p:nvPr/>
-        </p:nvSpPr>
-        <p:spPr>
-          <a:xfrm>
-            <a:off x="228600" y="4306824"/>
-            <a:ext cx="1325880" cy="658368"/>
+            <a:off x="228600" y="4187952"/>
+            <a:ext cx="1325880" cy="685800"/>
           </a:xfrm>
           <a:prstGeom prst="rect">
             <a:avLst/>
@@ -2804,7 +2765,7 @@
             <a:r>
               <a:rPr lang="en-US" sz="1100" b="1" dirty="0">
                 <a:solidFill>
-                  <a:srgbClr val="B5443C"/>
+                  <a:srgbClr val="7E2F2A"/>
                 </a:solidFill>
                 <a:latin typeface="Garamond" pitchFamily="34" charset="0"/>
                 <a:ea typeface="Garamond" pitchFamily="34" charset="-122"/>
@@ -2821,7 +2782,7 @@
             <a:r>
               <a:rPr lang="en-US" sz="1100" b="1" dirty="0">
                 <a:solidFill>
-                  <a:srgbClr val="B5443C"/>
+                  <a:srgbClr val="7E2F2A"/>
                 </a:solidFill>
                 <a:latin typeface="Garamond" pitchFamily="34" charset="0"/>
                 <a:ea typeface="Garamond" pitchFamily="34" charset="-122"/>
@@ -2835,26 +2796,26 @@
       </p:sp>
       <p:sp>
         <p:nvSpPr>
-          <p:cNvPr id="47" name="Shape 45"/>
-          <p:cNvSpPr/>
-          <p:nvPr/>
-        </p:nvSpPr>
-        <p:spPr>
-          <a:xfrm>
-            <a:off x="1691640" y="4306824"/>
-            <a:ext cx="3246120" cy="658368"/>
+          <p:cNvPr id="46" name="Shape 44"/>
+          <p:cNvSpPr/>
+          <p:nvPr/>
+        </p:nvSpPr>
+        <p:spPr>
+          <a:xfrm>
+            <a:off x="1691640" y="4187952"/>
+            <a:ext cx="3246120" cy="685800"/>
           </a:xfrm>
           <a:prstGeom prst="roundRect">
             <a:avLst>
-              <a:gd name="adj" fmla="val 9722"/>
+              <a:gd name="adj" fmla="val 9333"/>
             </a:avLst>
           </a:prstGeom>
           <a:solidFill>
-            <a:srgbClr val="FBF8F8"/>
+            <a:srgbClr val="F6EDEC"/>
           </a:solidFill>
-          <a:ln w="9525">
+          <a:ln w="15240">
             <a:solidFill>
-              <a:srgbClr val="C9CFD6"/>
+              <a:srgbClr val="7E2F2A"/>
             </a:solidFill>
             <a:prstDash val="solid"/>
           </a:ln>
@@ -2862,14 +2823,53 @@
       </p:sp>
       <p:sp>
         <p:nvSpPr>
+          <p:cNvPr id="47" name="Text 45"/>
+          <p:cNvSpPr/>
+          <p:nvPr/>
+        </p:nvSpPr>
+        <p:spPr>
+          <a:xfrm>
+            <a:off x="1801368" y="4187952"/>
+            <a:ext cx="685800" cy="685800"/>
+          </a:xfrm>
+          <a:prstGeom prst="rect">
+            <a:avLst/>
+          </a:prstGeom>
+          <a:noFill/>
+          <a:ln/>
+        </p:spPr>
+        <p:txBody>
+          <a:bodyPr wrap="square" lIns="0" tIns="0" rIns="0" bIns="0" rtlCol="0" anchor="ctr"/>
+          <a:lstStyle/>
+          <a:p>
+            <a:pPr indent="0" marL="0">
+              <a:buNone/>
+            </a:pPr>
+            <a:r>
+              <a:rPr lang="en-US" sz="1600" b="1" dirty="0">
+                <a:solidFill>
+                  <a:srgbClr val="7E2F2A"/>
+                </a:solidFill>
+                <a:latin typeface="Garamond" pitchFamily="34" charset="0"/>
+                <a:ea typeface="Garamond" pitchFamily="34" charset="-122"/>
+                <a:cs typeface="Garamond" pitchFamily="34" charset="-120"/>
+              </a:rPr>
+              <a:t>158</a:t>
+            </a:r>
+            <a:endParaRPr lang="en-US" sz="1600" dirty="0"/>
+          </a:p>
+        </p:txBody>
+      </p:sp>
+      <p:sp>
+        <p:nvSpPr>
           <p:cNvPr id="48" name="Text 46"/>
           <p:cNvSpPr/>
           <p:nvPr/>
         </p:nvSpPr>
         <p:spPr>
           <a:xfrm>
-            <a:off x="1801368" y="4306824"/>
-            <a:ext cx="685800" cy="658368"/>
+            <a:off x="2532888" y="4187952"/>
+            <a:ext cx="2286000" cy="685800"/>
           </a:xfrm>
           <a:prstGeom prst="rect">
             <a:avLst/>
@@ -2885,46 +2885,7 @@
               <a:buNone/>
             </a:pPr>
             <a:r>
-              <a:rPr lang="en-US" sz="1500" b="1" dirty="0">
-                <a:solidFill>
-                  <a:srgbClr val="B5443C"/>
-                </a:solidFill>
-                <a:latin typeface="Garamond" pitchFamily="34" charset="0"/>
-                <a:ea typeface="Garamond" pitchFamily="34" charset="-122"/>
-                <a:cs typeface="Garamond" pitchFamily="34" charset="-120"/>
-              </a:rPr>
-              <a:t>158</a:t>
-            </a:r>
-            <a:endParaRPr lang="en-US" sz="1500" dirty="0"/>
-          </a:p>
-        </p:txBody>
-      </p:sp>
-      <p:sp>
-        <p:nvSpPr>
-          <p:cNvPr id="49" name="Text 47"/>
-          <p:cNvSpPr/>
-          <p:nvPr/>
-        </p:nvSpPr>
-        <p:spPr>
-          <a:xfrm>
-            <a:off x="2532888" y="4306824"/>
-            <a:ext cx="2286000" cy="658368"/>
-          </a:xfrm>
-          <a:prstGeom prst="rect">
-            <a:avLst/>
-          </a:prstGeom>
-          <a:noFill/>
-          <a:ln/>
-        </p:spPr>
-        <p:txBody>
-          <a:bodyPr wrap="square" lIns="0" tIns="0" rIns="0" bIns="0" rtlCol="0" anchor="ctr"/>
-          <a:lstStyle/>
-          <a:p>
-            <a:pPr indent="0" marL="0">
-              <a:buNone/>
-            </a:pPr>
-            <a:r>
-              <a:rPr lang="en-US" sz="950" dirty="0">
+              <a:rPr lang="en-US" sz="1000" dirty="0">
                 <a:solidFill>
                   <a:srgbClr val="1A2430"/>
                 </a:solidFill>
@@ -2934,28 +2895,28 @@
               </a:rPr>
               <a:t>Teachers, special education</a:t>
             </a:r>
-            <a:endParaRPr lang="en-US" sz="950" dirty="0"/>
-          </a:p>
-        </p:txBody>
-      </p:sp>
-      <p:sp>
-        <p:nvSpPr>
-          <p:cNvPr id="50" name="Shape 48"/>
-          <p:cNvSpPr/>
-          <p:nvPr/>
-        </p:nvSpPr>
-        <p:spPr>
-          <a:xfrm>
-            <a:off x="4937760" y="4636008"/>
+            <a:endParaRPr lang="en-US" sz="1000" dirty="0"/>
+          </a:p>
+        </p:txBody>
+      </p:sp>
+      <p:sp>
+        <p:nvSpPr>
+          <p:cNvPr id="49" name="Shape 47"/>
+          <p:cNvSpPr/>
+          <p:nvPr/>
+        </p:nvSpPr>
+        <p:spPr>
+          <a:xfrm>
+            <a:off x="4937760" y="4530852"/>
             <a:ext cx="256032" cy="0"/>
           </a:xfrm>
           <a:prstGeom prst="line">
             <a:avLst/>
           </a:prstGeom>
           <a:noFill/>
-          <a:ln w="9525">
+          <a:ln w="12700">
             <a:solidFill>
-              <a:srgbClr val="C9CFD6"/>
+              <a:srgbClr val="7E2F2A"/>
             </a:solidFill>
             <a:prstDash val="solid"/>
           </a:ln>
@@ -2963,26 +2924,26 @@
       </p:sp>
       <p:sp>
         <p:nvSpPr>
-          <p:cNvPr id="51" name="Shape 49"/>
-          <p:cNvSpPr/>
-          <p:nvPr/>
-        </p:nvSpPr>
-        <p:spPr>
-          <a:xfrm>
-            <a:off x="5193792" y="4306824"/>
-            <a:ext cx="3246120" cy="658368"/>
+          <p:cNvPr id="50" name="Shape 48"/>
+          <p:cNvSpPr/>
+          <p:nvPr/>
+        </p:nvSpPr>
+        <p:spPr>
+          <a:xfrm>
+            <a:off x="5193792" y="4187952"/>
+            <a:ext cx="3246120" cy="685800"/>
           </a:xfrm>
           <a:prstGeom prst="roundRect">
             <a:avLst>
-              <a:gd name="adj" fmla="val 9722"/>
+              <a:gd name="adj" fmla="val 9333"/>
             </a:avLst>
           </a:prstGeom>
           <a:solidFill>
-            <a:srgbClr val="FBF8F8"/>
+            <a:srgbClr val="F6EDEC"/>
           </a:solidFill>
-          <a:ln w="9525">
+          <a:ln w="15240">
             <a:solidFill>
-              <a:srgbClr val="C9CFD6"/>
+              <a:srgbClr val="7E2F2A"/>
             </a:solidFill>
             <a:prstDash val="solid"/>
           </a:ln>
@@ -2990,14 +2951,53 @@
       </p:sp>
       <p:sp>
         <p:nvSpPr>
+          <p:cNvPr id="51" name="Text 49"/>
+          <p:cNvSpPr/>
+          <p:nvPr/>
+        </p:nvSpPr>
+        <p:spPr>
+          <a:xfrm>
+            <a:off x="5303520" y="4187952"/>
+            <a:ext cx="685800" cy="685800"/>
+          </a:xfrm>
+          <a:prstGeom prst="rect">
+            <a:avLst/>
+          </a:prstGeom>
+          <a:noFill/>
+          <a:ln/>
+        </p:spPr>
+        <p:txBody>
+          <a:bodyPr wrap="square" lIns="0" tIns="0" rIns="0" bIns="0" rtlCol="0" anchor="ctr"/>
+          <a:lstStyle/>
+          <a:p>
+            <a:pPr indent="0" marL="0">
+              <a:buNone/>
+            </a:pPr>
+            <a:r>
+              <a:rPr lang="en-US" sz="1600" b="1" dirty="0">
+                <a:solidFill>
+                  <a:srgbClr val="7E2F2A"/>
+                </a:solidFill>
+                <a:latin typeface="Garamond" pitchFamily="34" charset="0"/>
+                <a:ea typeface="Garamond" pitchFamily="34" charset="-122"/>
+                <a:cs typeface="Garamond" pitchFamily="34" charset="-120"/>
+              </a:rPr>
+              <a:t>2330</a:t>
+            </a:r>
+            <a:endParaRPr lang="en-US" sz="1600" dirty="0"/>
+          </a:p>
+        </p:txBody>
+      </p:sp>
+      <p:sp>
+        <p:nvSpPr>
           <p:cNvPr id="52" name="Text 50"/>
           <p:cNvSpPr/>
           <p:nvPr/>
         </p:nvSpPr>
         <p:spPr>
           <a:xfrm>
-            <a:off x="5303520" y="4306824"/>
-            <a:ext cx="685800" cy="658368"/>
+            <a:off x="6035040" y="4187952"/>
+            <a:ext cx="2286000" cy="685800"/>
           </a:xfrm>
           <a:prstGeom prst="rect">
             <a:avLst/>
@@ -3013,46 +3013,7 @@
               <a:buNone/>
             </a:pPr>
             <a:r>
-              <a:rPr lang="en-US" sz="1500" b="1" dirty="0">
-                <a:solidFill>
-                  <a:srgbClr val="B5443C"/>
-                </a:solidFill>
-                <a:latin typeface="Garamond" pitchFamily="34" charset="0"/>
-                <a:ea typeface="Garamond" pitchFamily="34" charset="-122"/>
-                <a:cs typeface="Garamond" pitchFamily="34" charset="-120"/>
-              </a:rPr>
-              <a:t>2330</a:t>
-            </a:r>
-            <a:endParaRPr lang="en-US" sz="1500" dirty="0"/>
-          </a:p>
-        </p:txBody>
-      </p:sp>
-      <p:sp>
-        <p:nvSpPr>
-          <p:cNvPr id="53" name="Text 51"/>
-          <p:cNvSpPr/>
-          <p:nvPr/>
-        </p:nvSpPr>
-        <p:spPr>
-          <a:xfrm>
-            <a:off x="6035040" y="4306824"/>
-            <a:ext cx="2286000" cy="658368"/>
-          </a:xfrm>
-          <a:prstGeom prst="rect">
-            <a:avLst/>
-          </a:prstGeom>
-          <a:noFill/>
-          <a:ln/>
-        </p:spPr>
-        <p:txBody>
-          <a:bodyPr wrap="square" lIns="0" tIns="0" rIns="0" bIns="0" rtlCol="0" anchor="ctr"/>
-          <a:lstStyle/>
-          <a:p>
-            <a:pPr indent="0" marL="0">
-              <a:buNone/>
-            </a:pPr>
-            <a:r>
-              <a:rPr lang="en-US" sz="950" dirty="0">
+              <a:rPr lang="en-US" sz="1000" dirty="0">
                 <a:solidFill>
                   <a:srgbClr val="1A2430"/>
                 </a:solidFill>
@@ -3062,28 +3023,28 @@
               </a:rPr>
               <a:t>Special education teachers</a:t>
             </a:r>
-            <a:endParaRPr lang="en-US" sz="950" dirty="0"/>
-          </a:p>
-        </p:txBody>
-      </p:sp>
-      <p:sp>
-        <p:nvSpPr>
-          <p:cNvPr id="54" name="Shape 52"/>
-          <p:cNvSpPr/>
-          <p:nvPr/>
-        </p:nvSpPr>
-        <p:spPr>
-          <a:xfrm>
-            <a:off x="8439912" y="4636008"/>
+            <a:endParaRPr lang="en-US" sz="1000" dirty="0"/>
+          </a:p>
+        </p:txBody>
+      </p:sp>
+      <p:sp>
+        <p:nvSpPr>
+          <p:cNvPr id="53" name="Shape 51"/>
+          <p:cNvSpPr/>
+          <p:nvPr/>
+        </p:nvSpPr>
+        <p:spPr>
+          <a:xfrm>
+            <a:off x="8439912" y="4530852"/>
             <a:ext cx="256032" cy="0"/>
           </a:xfrm>
           <a:prstGeom prst="line">
             <a:avLst/>
           </a:prstGeom>
           <a:noFill/>
-          <a:ln w="9525">
+          <a:ln w="12700">
             <a:solidFill>
-              <a:srgbClr val="C9CFD6"/>
+              <a:srgbClr val="7E2F2A"/>
             </a:solidFill>
             <a:prstDash val="solid"/>
           </a:ln>
@@ -3091,26 +3052,26 @@
       </p:sp>
       <p:sp>
         <p:nvSpPr>
-          <p:cNvPr id="55" name="Shape 53"/>
-          <p:cNvSpPr/>
-          <p:nvPr/>
-        </p:nvSpPr>
-        <p:spPr>
-          <a:xfrm>
-            <a:off x="8695944" y="4306824"/>
-            <a:ext cx="3246120" cy="658368"/>
+          <p:cNvPr id="54" name="Shape 52"/>
+          <p:cNvSpPr/>
+          <p:nvPr/>
+        </p:nvSpPr>
+        <p:spPr>
+          <a:xfrm>
+            <a:off x="8695944" y="4187952"/>
+            <a:ext cx="3246120" cy="685800"/>
           </a:xfrm>
           <a:prstGeom prst="roundRect">
             <a:avLst>
-              <a:gd name="adj" fmla="val 9722"/>
+              <a:gd name="adj" fmla="val 9333"/>
             </a:avLst>
           </a:prstGeom>
           <a:solidFill>
-            <a:srgbClr val="FBF8F8"/>
+            <a:srgbClr val="F6EDEC"/>
           </a:solidFill>
-          <a:ln w="9525">
+          <a:ln w="15240">
             <a:solidFill>
-              <a:srgbClr val="C9CFD6"/>
+              <a:srgbClr val="7E2F2A"/>
             </a:solidFill>
             <a:prstDash val="solid"/>
           </a:ln>
@@ -3118,14 +3079,53 @@
       </p:sp>
       <p:sp>
         <p:nvSpPr>
+          <p:cNvPr id="55" name="Text 53"/>
+          <p:cNvSpPr/>
+          <p:nvPr/>
+        </p:nvSpPr>
+        <p:spPr>
+          <a:xfrm>
+            <a:off x="8805672" y="4187952"/>
+            <a:ext cx="685800" cy="685800"/>
+          </a:xfrm>
+          <a:prstGeom prst="rect">
+            <a:avLst/>
+          </a:prstGeom>
+          <a:noFill/>
+          <a:ln/>
+        </p:spPr>
+        <p:txBody>
+          <a:bodyPr wrap="square" lIns="0" tIns="0" rIns="0" bIns="0" rtlCol="0" anchor="ctr"/>
+          <a:lstStyle/>
+          <a:p>
+            <a:pPr indent="0" marL="0">
+              <a:buNone/>
+            </a:pPr>
+            <a:r>
+              <a:rPr lang="en-US" sz="1600" b="1" dirty="0">
+                <a:solidFill>
+                  <a:srgbClr val="7E2F2A"/>
+                </a:solidFill>
+                <a:latin typeface="Garamond" pitchFamily="34" charset="0"/>
+                <a:ea typeface="Garamond" pitchFamily="34" charset="-122"/>
+                <a:cs typeface="Garamond" pitchFamily="34" charset="-120"/>
+              </a:rPr>
+              <a:t>2330</a:t>
+            </a:r>
+            <a:endParaRPr lang="en-US" sz="1600" dirty="0"/>
+          </a:p>
+        </p:txBody>
+      </p:sp>
+      <p:sp>
+        <p:nvSpPr>
           <p:cNvPr id="56" name="Text 54"/>
           <p:cNvSpPr/>
           <p:nvPr/>
         </p:nvSpPr>
         <p:spPr>
           <a:xfrm>
-            <a:off x="8805672" y="4306824"/>
-            <a:ext cx="685800" cy="658368"/>
+            <a:off x="9537192" y="4187952"/>
+            <a:ext cx="2286000" cy="685800"/>
           </a:xfrm>
           <a:prstGeom prst="rect">
             <a:avLst/>
@@ -3141,17 +3141,17 @@
               <a:buNone/>
             </a:pPr>
             <a:r>
-              <a:rPr lang="en-US" sz="1500" b="1" dirty="0">
-                <a:solidFill>
-                  <a:srgbClr val="B5443C"/>
-                </a:solidFill>
-                <a:latin typeface="Garamond" pitchFamily="34" charset="0"/>
-                <a:ea typeface="Garamond" pitchFamily="34" charset="-122"/>
-                <a:cs typeface="Garamond" pitchFamily="34" charset="-120"/>
-              </a:rPr>
-              <a:t>2330</a:t>
-            </a:r>
-            <a:endParaRPr lang="en-US" sz="1500" dirty="0"/>
+              <a:rPr lang="en-US" sz="1000" dirty="0">
+                <a:solidFill>
+                  <a:srgbClr val="1A2430"/>
+                </a:solidFill>
+                <a:latin typeface="Garamond" pitchFamily="34" charset="0"/>
+                <a:ea typeface="Garamond" pitchFamily="34" charset="-122"/>
+                <a:cs typeface="Garamond" pitchFamily="34" charset="-120"/>
+              </a:rPr>
+              <a:t>Special education teachers</a:t>
+            </a:r>
+            <a:endParaRPr lang="en-US" sz="1000" dirty="0"/>
           </a:p>
         </p:txBody>
       </p:sp>
@@ -3163,47 +3163,8 @@
         </p:nvSpPr>
         <p:spPr>
           <a:xfrm>
-            <a:off x="9537192" y="4306824"/>
-            <a:ext cx="2286000" cy="658368"/>
-          </a:xfrm>
-          <a:prstGeom prst="rect">
-            <a:avLst/>
-          </a:prstGeom>
-          <a:noFill/>
-          <a:ln/>
-        </p:spPr>
-        <p:txBody>
-          <a:bodyPr wrap="square" lIns="0" tIns="0" rIns="0" bIns="0" rtlCol="0" anchor="ctr"/>
-          <a:lstStyle/>
-          <a:p>
-            <a:pPr indent="0" marL="0">
-              <a:buNone/>
-            </a:pPr>
-            <a:r>
-              <a:rPr lang="en-US" sz="950" dirty="0">
-                <a:solidFill>
-                  <a:srgbClr val="1A2430"/>
-                </a:solidFill>
-                <a:latin typeface="Garamond" pitchFamily="34" charset="0"/>
-                <a:ea typeface="Garamond" pitchFamily="34" charset="-122"/>
-                <a:cs typeface="Garamond" pitchFamily="34" charset="-120"/>
-              </a:rPr>
-              <a:t>Special education teachers</a:t>
-            </a:r>
-            <a:endParaRPr lang="en-US" sz="950" dirty="0"/>
-          </a:p>
-        </p:txBody>
-      </p:sp>
-      <p:sp>
-        <p:nvSpPr>
-          <p:cNvPr id="58" name="Text 56"/>
-          <p:cNvSpPr/>
-          <p:nvPr/>
-        </p:nvSpPr>
-        <p:spPr>
-          <a:xfrm>
-            <a:off x="228600" y="5102352"/>
-            <a:ext cx="1325880" cy="658368"/>
+            <a:off x="228600" y="5029200"/>
+            <a:ext cx="1325880" cy="685800"/>
           </a:xfrm>
           <a:prstGeom prst="rect">
             <a:avLst/>
@@ -3221,7 +3182,7 @@
             <a:r>
               <a:rPr lang="en-US" sz="1100" b="1" dirty="0">
                 <a:solidFill>
-                  <a:srgbClr val="5E6672"/>
+                  <a:srgbClr val="7E2F2A"/>
                 </a:solidFill>
                 <a:latin typeface="Garamond" pitchFamily="34" charset="0"/>
                 <a:ea typeface="Garamond" pitchFamily="34" charset="-122"/>
@@ -3238,7 +3199,7 @@
             <a:r>
               <a:rPr lang="en-US" sz="1100" b="1" dirty="0">
                 <a:solidFill>
-                  <a:srgbClr val="5E6672"/>
+                  <a:srgbClr val="7E2F2A"/>
                 </a:solidFill>
                 <a:latin typeface="Garamond" pitchFamily="34" charset="0"/>
                 <a:ea typeface="Garamond" pitchFamily="34" charset="-122"/>
@@ -3252,26 +3213,26 @@
       </p:sp>
       <p:sp>
         <p:nvSpPr>
-          <p:cNvPr id="59" name="Shape 57"/>
-          <p:cNvSpPr/>
-          <p:nvPr/>
-        </p:nvSpPr>
-        <p:spPr>
-          <a:xfrm>
-            <a:off x="1691640" y="5102352"/>
-            <a:ext cx="3246120" cy="658368"/>
+          <p:cNvPr id="58" name="Shape 56"/>
+          <p:cNvSpPr/>
+          <p:nvPr/>
+        </p:nvSpPr>
+        <p:spPr>
+          <a:xfrm>
+            <a:off x="1691640" y="5029200"/>
+            <a:ext cx="3246120" cy="685800"/>
           </a:xfrm>
           <a:prstGeom prst="roundRect">
             <a:avLst>
-              <a:gd name="adj" fmla="val 9722"/>
+              <a:gd name="adj" fmla="val 9333"/>
             </a:avLst>
           </a:prstGeom>
           <a:solidFill>
-            <a:srgbClr val="F8F9FA"/>
+            <a:srgbClr val="F6EDEC"/>
           </a:solidFill>
-          <a:ln w="9525">
+          <a:ln w="15240">
             <a:solidFill>
-              <a:srgbClr val="C9CFD6"/>
+              <a:srgbClr val="7E2F2A"/>
             </a:solidFill>
             <a:prstDash val="solid"/>
           </a:ln>
@@ -3279,14 +3240,53 @@
       </p:sp>
       <p:sp>
         <p:nvSpPr>
+          <p:cNvPr id="59" name="Text 57"/>
+          <p:cNvSpPr/>
+          <p:nvPr/>
+        </p:nvSpPr>
+        <p:spPr>
+          <a:xfrm>
+            <a:off x="1801368" y="5029200"/>
+            <a:ext cx="685800" cy="685800"/>
+          </a:xfrm>
+          <a:prstGeom prst="rect">
+            <a:avLst/>
+          </a:prstGeom>
+          <a:noFill/>
+          <a:ln/>
+        </p:spPr>
+        <p:txBody>
+          <a:bodyPr wrap="square" lIns="0" tIns="0" rIns="0" bIns="0" rtlCol="0" anchor="ctr"/>
+          <a:lstStyle/>
+          <a:p>
+            <a:pPr indent="0" marL="0">
+              <a:buNone/>
+            </a:pPr>
+            <a:r>
+              <a:rPr lang="en-US" sz="1600" b="1" dirty="0">
+                <a:solidFill>
+                  <a:srgbClr val="7E2F2A"/>
+                </a:solidFill>
+                <a:latin typeface="Garamond" pitchFamily="34" charset="0"/>
+                <a:ea typeface="Garamond" pitchFamily="34" charset="-122"/>
+                <a:cs typeface="Garamond" pitchFamily="34" charset="-120"/>
+              </a:rPr>
+              <a:t>159</a:t>
+            </a:r>
+            <a:endParaRPr lang="en-US" sz="1600" dirty="0"/>
+          </a:p>
+        </p:txBody>
+      </p:sp>
+      <p:sp>
+        <p:nvSpPr>
           <p:cNvPr id="60" name="Text 58"/>
           <p:cNvSpPr/>
           <p:nvPr/>
         </p:nvSpPr>
         <p:spPr>
           <a:xfrm>
-            <a:off x="1801368" y="5102352"/>
-            <a:ext cx="685800" cy="658368"/>
+            <a:off x="2532888" y="5029200"/>
+            <a:ext cx="2286000" cy="685800"/>
           </a:xfrm>
           <a:prstGeom prst="rect">
             <a:avLst/>
@@ -3302,46 +3302,7 @@
               <a:buNone/>
             </a:pPr>
             <a:r>
-              <a:rPr lang="en-US" sz="1500" b="1" dirty="0">
-                <a:solidFill>
-                  <a:srgbClr val="5E6672"/>
-                </a:solidFill>
-                <a:latin typeface="Garamond" pitchFamily="34" charset="0"/>
-                <a:ea typeface="Garamond" pitchFamily="34" charset="-122"/>
-                <a:cs typeface="Garamond" pitchFamily="34" charset="-120"/>
-              </a:rPr>
-              <a:t>159</a:t>
-            </a:r>
-            <a:endParaRPr lang="en-US" sz="1500" dirty="0"/>
-          </a:p>
-        </p:txBody>
-      </p:sp>
-      <p:sp>
-        <p:nvSpPr>
-          <p:cNvPr id="61" name="Text 59"/>
-          <p:cNvSpPr/>
-          <p:nvPr/>
-        </p:nvSpPr>
-        <p:spPr>
-          <a:xfrm>
-            <a:off x="2532888" y="5102352"/>
-            <a:ext cx="2286000" cy="658368"/>
-          </a:xfrm>
-          <a:prstGeom prst="rect">
-            <a:avLst/>
-          </a:prstGeom>
-          <a:noFill/>
-          <a:ln/>
-        </p:spPr>
-        <p:txBody>
-          <a:bodyPr wrap="square" lIns="0" tIns="0" rIns="0" bIns="0" rtlCol="0" anchor="ctr"/>
-          <a:lstStyle/>
-          <a:p>
-            <a:pPr indent="0" marL="0">
-              <a:buNone/>
-            </a:pPr>
-            <a:r>
-              <a:rPr lang="en-US" sz="950" dirty="0">
+              <a:rPr lang="en-US" sz="1000" dirty="0">
                 <a:solidFill>
                   <a:srgbClr val="1A2430"/>
                 </a:solidFill>
@@ -3351,28 +3312,28 @@
               </a:rPr>
               <a:t>Teachers, n.e.c. (not elsewhere classified)</a:t>
             </a:r>
-            <a:endParaRPr lang="en-US" sz="950" dirty="0"/>
-          </a:p>
-        </p:txBody>
-      </p:sp>
-      <p:sp>
-        <p:nvSpPr>
-          <p:cNvPr id="62" name="Shape 60"/>
-          <p:cNvSpPr/>
-          <p:nvPr/>
-        </p:nvSpPr>
-        <p:spPr>
-          <a:xfrm>
-            <a:off x="4937760" y="5431536"/>
+            <a:endParaRPr lang="en-US" sz="1000" dirty="0"/>
+          </a:p>
+        </p:txBody>
+      </p:sp>
+      <p:sp>
+        <p:nvSpPr>
+          <p:cNvPr id="61" name="Shape 59"/>
+          <p:cNvSpPr/>
+          <p:nvPr/>
+        </p:nvSpPr>
+        <p:spPr>
+          <a:xfrm>
+            <a:off x="4937760" y="5372100"/>
             <a:ext cx="256032" cy="0"/>
           </a:xfrm>
           <a:prstGeom prst="line">
             <a:avLst/>
           </a:prstGeom>
           <a:noFill/>
-          <a:ln w="9525">
+          <a:ln w="12700">
             <a:solidFill>
-              <a:srgbClr val="C9CFD6"/>
+              <a:srgbClr val="7E2F2A"/>
             </a:solidFill>
             <a:prstDash val="solid"/>
           </a:ln>
@@ -3380,26 +3341,26 @@
       </p:sp>
       <p:sp>
         <p:nvSpPr>
-          <p:cNvPr id="63" name="Shape 61"/>
-          <p:cNvSpPr/>
-          <p:nvPr/>
-        </p:nvSpPr>
-        <p:spPr>
-          <a:xfrm>
-            <a:off x="5193792" y="5102352"/>
-            <a:ext cx="3246120" cy="658368"/>
+          <p:cNvPr id="62" name="Shape 60"/>
+          <p:cNvSpPr/>
+          <p:nvPr/>
+        </p:nvSpPr>
+        <p:spPr>
+          <a:xfrm>
+            <a:off x="5193792" y="5029200"/>
+            <a:ext cx="3246120" cy="685800"/>
           </a:xfrm>
           <a:prstGeom prst="roundRect">
             <a:avLst>
-              <a:gd name="adj" fmla="val 9722"/>
+              <a:gd name="adj" fmla="val 9333"/>
             </a:avLst>
           </a:prstGeom>
           <a:solidFill>
-            <a:srgbClr val="F8F9FA"/>
+            <a:srgbClr val="F6EDEC"/>
           </a:solidFill>
-          <a:ln w="9525">
+          <a:ln w="15240">
             <a:solidFill>
-              <a:srgbClr val="C9CFD6"/>
+              <a:srgbClr val="7E2F2A"/>
             </a:solidFill>
             <a:prstDash val="solid"/>
           </a:ln>
@@ -3407,14 +3368,53 @@
       </p:sp>
       <p:sp>
         <p:nvSpPr>
+          <p:cNvPr id="63" name="Text 61"/>
+          <p:cNvSpPr/>
+          <p:nvPr/>
+        </p:nvSpPr>
+        <p:spPr>
+          <a:xfrm>
+            <a:off x="5303520" y="5029200"/>
+            <a:ext cx="685800" cy="685800"/>
+          </a:xfrm>
+          <a:prstGeom prst="rect">
+            <a:avLst/>
+          </a:prstGeom>
+          <a:noFill/>
+          <a:ln/>
+        </p:spPr>
+        <p:txBody>
+          <a:bodyPr wrap="square" lIns="0" tIns="0" rIns="0" bIns="0" rtlCol="0" anchor="ctr"/>
+          <a:lstStyle/>
+          <a:p>
+            <a:pPr indent="0" marL="0">
+              <a:buNone/>
+            </a:pPr>
+            <a:r>
+              <a:rPr lang="en-US" sz="1600" b="1" dirty="0">
+                <a:solidFill>
+                  <a:srgbClr val="7E2F2A"/>
+                </a:solidFill>
+                <a:latin typeface="Garamond" pitchFamily="34" charset="0"/>
+                <a:ea typeface="Garamond" pitchFamily="34" charset="-122"/>
+                <a:cs typeface="Garamond" pitchFamily="34" charset="-120"/>
+              </a:rPr>
+              <a:t>2340</a:t>
+            </a:r>
+            <a:endParaRPr lang="en-US" sz="1600" dirty="0"/>
+          </a:p>
+        </p:txBody>
+      </p:sp>
+      <p:sp>
+        <p:nvSpPr>
           <p:cNvPr id="64" name="Text 62"/>
           <p:cNvSpPr/>
           <p:nvPr/>
         </p:nvSpPr>
         <p:spPr>
           <a:xfrm>
-            <a:off x="5303520" y="5102352"/>
-            <a:ext cx="685800" cy="658368"/>
+            <a:off x="6035040" y="5029200"/>
+            <a:ext cx="2286000" cy="685800"/>
           </a:xfrm>
           <a:prstGeom prst="rect">
             <a:avLst/>
@@ -3430,46 +3430,7 @@
               <a:buNone/>
             </a:pPr>
             <a:r>
-              <a:rPr lang="en-US" sz="1500" b="1" dirty="0">
-                <a:solidFill>
-                  <a:srgbClr val="5E6672"/>
-                </a:solidFill>
-                <a:latin typeface="Garamond" pitchFamily="34" charset="0"/>
-                <a:ea typeface="Garamond" pitchFamily="34" charset="-122"/>
-                <a:cs typeface="Garamond" pitchFamily="34" charset="-120"/>
-              </a:rPr>
-              <a:t>2340</a:t>
-            </a:r>
-            <a:endParaRPr lang="en-US" sz="1500" dirty="0"/>
-          </a:p>
-        </p:txBody>
-      </p:sp>
-      <p:sp>
-        <p:nvSpPr>
-          <p:cNvPr id="65" name="Text 63"/>
-          <p:cNvSpPr/>
-          <p:nvPr/>
-        </p:nvSpPr>
-        <p:spPr>
-          <a:xfrm>
-            <a:off x="6035040" y="5102352"/>
-            <a:ext cx="2286000" cy="658368"/>
-          </a:xfrm>
-          <a:prstGeom prst="rect">
-            <a:avLst/>
-          </a:prstGeom>
-          <a:noFill/>
-          <a:ln/>
-        </p:spPr>
-        <p:txBody>
-          <a:bodyPr wrap="square" lIns="0" tIns="0" rIns="0" bIns="0" rtlCol="0" anchor="ctr"/>
-          <a:lstStyle/>
-          <a:p>
-            <a:pPr indent="0" marL="0">
-              <a:buNone/>
-            </a:pPr>
-            <a:r>
-              <a:rPr lang="en-US" sz="950" dirty="0">
+              <a:rPr lang="en-US" sz="1000" dirty="0">
                 <a:solidFill>
                   <a:srgbClr val="1A2430"/>
                 </a:solidFill>
@@ -3479,28 +3440,28 @@
               </a:rPr>
               <a:t>Other teachers and instructors</a:t>
             </a:r>
-            <a:endParaRPr lang="en-US" sz="950" dirty="0"/>
-          </a:p>
-        </p:txBody>
-      </p:sp>
-      <p:sp>
-        <p:nvSpPr>
-          <p:cNvPr id="66" name="Shape 64"/>
-          <p:cNvSpPr/>
-          <p:nvPr/>
-        </p:nvSpPr>
-        <p:spPr>
-          <a:xfrm>
-            <a:off x="8439912" y="5431536"/>
+            <a:endParaRPr lang="en-US" sz="1000" dirty="0"/>
+          </a:p>
+        </p:txBody>
+      </p:sp>
+      <p:sp>
+        <p:nvSpPr>
+          <p:cNvPr id="65" name="Shape 63"/>
+          <p:cNvSpPr/>
+          <p:nvPr/>
+        </p:nvSpPr>
+        <p:spPr>
+          <a:xfrm>
+            <a:off x="8439912" y="5372100"/>
             <a:ext cx="256032" cy="0"/>
           </a:xfrm>
           <a:prstGeom prst="line">
             <a:avLst/>
           </a:prstGeom>
           <a:noFill/>
-          <a:ln w="9525">
+          <a:ln w="12700">
             <a:solidFill>
-              <a:srgbClr val="C9CFD6"/>
+              <a:srgbClr val="7E2F2A"/>
             </a:solidFill>
             <a:prstDash val="solid"/>
           </a:ln>
@@ -3508,26 +3469,26 @@
       </p:sp>
       <p:sp>
         <p:nvSpPr>
-          <p:cNvPr id="67" name="Shape 65"/>
-          <p:cNvSpPr/>
-          <p:nvPr/>
-        </p:nvSpPr>
-        <p:spPr>
-          <a:xfrm>
-            <a:off x="8695944" y="5102352"/>
-            <a:ext cx="3246120" cy="658368"/>
+          <p:cNvPr id="66" name="Shape 64"/>
+          <p:cNvSpPr/>
+          <p:nvPr/>
+        </p:nvSpPr>
+        <p:spPr>
+          <a:xfrm>
+            <a:off x="8695944" y="5029200"/>
+            <a:ext cx="3246120" cy="685800"/>
           </a:xfrm>
           <a:prstGeom prst="roundRect">
             <a:avLst>
-              <a:gd name="adj" fmla="val 9722"/>
+              <a:gd name="adj" fmla="val 9333"/>
             </a:avLst>
           </a:prstGeom>
           <a:solidFill>
-            <a:srgbClr val="F8F9FA"/>
+            <a:srgbClr val="F6EDEC"/>
           </a:solidFill>
-          <a:ln w="9525">
+          <a:ln w="15240">
             <a:solidFill>
-              <a:srgbClr val="C9CFD6"/>
+              <a:srgbClr val="7E2F2A"/>
             </a:solidFill>
             <a:prstDash val="solid"/>
           </a:ln>
@@ -3535,14 +3496,53 @@
       </p:sp>
       <p:sp>
         <p:nvSpPr>
+          <p:cNvPr id="67" name="Text 65"/>
+          <p:cNvSpPr/>
+          <p:nvPr/>
+        </p:nvSpPr>
+        <p:spPr>
+          <a:xfrm>
+            <a:off x="8805672" y="5029200"/>
+            <a:ext cx="685800" cy="685800"/>
+          </a:xfrm>
+          <a:prstGeom prst="rect">
+            <a:avLst/>
+          </a:prstGeom>
+          <a:noFill/>
+          <a:ln/>
+        </p:spPr>
+        <p:txBody>
+          <a:bodyPr wrap="square" lIns="0" tIns="0" rIns="0" bIns="0" rtlCol="0" anchor="ctr"/>
+          <a:lstStyle/>
+          <a:p>
+            <a:pPr indent="0" marL="0">
+              <a:buNone/>
+            </a:pPr>
+            <a:r>
+              <a:rPr lang="en-US" sz="1600" b="1" dirty="0">
+                <a:solidFill>
+                  <a:srgbClr val="7E2F2A"/>
+                </a:solidFill>
+                <a:latin typeface="Garamond" pitchFamily="34" charset="0"/>
+                <a:ea typeface="Garamond" pitchFamily="34" charset="-122"/>
+                <a:cs typeface="Garamond" pitchFamily="34" charset="-120"/>
+              </a:rPr>
+              <a:t>2360</a:t>
+            </a:r>
+            <a:endParaRPr lang="en-US" sz="1600" dirty="0"/>
+          </a:p>
+        </p:txBody>
+      </p:sp>
+      <p:sp>
+        <p:nvSpPr>
           <p:cNvPr id="68" name="Text 66"/>
           <p:cNvSpPr/>
           <p:nvPr/>
         </p:nvSpPr>
         <p:spPr>
           <a:xfrm>
-            <a:off x="8805672" y="5102352"/>
-            <a:ext cx="685800" cy="658368"/>
+            <a:off x="9537192" y="5029200"/>
+            <a:ext cx="2286000" cy="685800"/>
           </a:xfrm>
           <a:prstGeom prst="rect">
             <a:avLst/>
@@ -3558,46 +3558,7 @@
               <a:buNone/>
             </a:pPr>
             <a:r>
-              <a:rPr lang="en-US" sz="1500" b="1" dirty="0">
-                <a:solidFill>
-                  <a:srgbClr val="5E6672"/>
-                </a:solidFill>
-                <a:latin typeface="Garamond" pitchFamily="34" charset="0"/>
-                <a:ea typeface="Garamond" pitchFamily="34" charset="-122"/>
-                <a:cs typeface="Garamond" pitchFamily="34" charset="-120"/>
-              </a:rPr>
-              <a:t>2360</a:t>
-            </a:r>
-            <a:endParaRPr lang="en-US" sz="1500" dirty="0"/>
-          </a:p>
-        </p:txBody>
-      </p:sp>
-      <p:sp>
-        <p:nvSpPr>
-          <p:cNvPr id="69" name="Text 67"/>
-          <p:cNvSpPr/>
-          <p:nvPr/>
-        </p:nvSpPr>
-        <p:spPr>
-          <a:xfrm>
-            <a:off x="9537192" y="5102352"/>
-            <a:ext cx="2286000" cy="658368"/>
-          </a:xfrm>
-          <a:prstGeom prst="rect">
-            <a:avLst/>
-          </a:prstGeom>
-          <a:noFill/>
-          <a:ln/>
-        </p:spPr>
-        <p:txBody>
-          <a:bodyPr wrap="square" lIns="0" tIns="0" rIns="0" bIns="0" rtlCol="0" anchor="ctr"/>
-          <a:lstStyle/>
-          <a:p>
-            <a:pPr indent="0" marL="0">
-              <a:buNone/>
-            </a:pPr>
-            <a:r>
-              <a:rPr lang="en-US" sz="950" dirty="0">
+              <a:rPr lang="en-US" sz="1000" dirty="0">
                 <a:solidFill>
                   <a:srgbClr val="1A2430"/>
                 </a:solidFill>
@@ -3607,20 +3568,20 @@
               </a:rPr>
               <a:t>Other teachers and instructors</a:t>
             </a:r>
-            <a:endParaRPr lang="en-US" sz="950" dirty="0"/>
-          </a:p>
-        </p:txBody>
-      </p:sp>
-      <p:sp>
-        <p:nvSpPr>
-          <p:cNvPr id="70" name="Shape 68"/>
-          <p:cNvSpPr/>
-          <p:nvPr/>
-        </p:nvSpPr>
-        <p:spPr>
-          <a:xfrm>
-            <a:off x="5065776" y="1298448"/>
-            <a:ext cx="0" cy="4462272"/>
+            <a:endParaRPr lang="en-US" sz="1000" dirty="0"/>
+          </a:p>
+        </p:txBody>
+      </p:sp>
+      <p:sp>
+        <p:nvSpPr>
+          <p:cNvPr id="69" name="Shape 67"/>
+          <p:cNvSpPr/>
+          <p:nvPr/>
+        </p:nvSpPr>
+        <p:spPr>
+          <a:xfrm>
+            <a:off x="5065776" y="1024128"/>
+            <a:ext cx="0" cy="4690872"/>
           </a:xfrm>
           <a:prstGeom prst="line">
             <a:avLst/>
@@ -3636,13 +3597,13 @@
       </p:sp>
       <p:sp>
         <p:nvSpPr>
-          <p:cNvPr id="71" name="Text 69"/>
-          <p:cNvSpPr/>
-          <p:nvPr/>
-        </p:nvSpPr>
-        <p:spPr>
-          <a:xfrm>
-            <a:off x="4242816" y="5779008"/>
+          <p:cNvPr id="70" name="Text 68"/>
+          <p:cNvSpPr/>
+          <p:nvPr/>
+        </p:nvSpPr>
+        <p:spPr>
+          <a:xfrm>
+            <a:off x="4242816" y="5733288"/>
             <a:ext cx="1645920" cy="219456"/>
           </a:xfrm>
           <a:prstGeom prst="rect">
@@ -3675,14 +3636,14 @@
       </p:sp>
       <p:sp>
         <p:nvSpPr>
-          <p:cNvPr id="72" name="Shape 70"/>
-          <p:cNvSpPr/>
-          <p:nvPr/>
-        </p:nvSpPr>
-        <p:spPr>
-          <a:xfrm>
-            <a:off x="8567928" y="1298448"/>
-            <a:ext cx="0" cy="4462272"/>
+          <p:cNvPr id="71" name="Shape 69"/>
+          <p:cNvSpPr/>
+          <p:nvPr/>
+        </p:nvSpPr>
+        <p:spPr>
+          <a:xfrm>
+            <a:off x="8567928" y="1024128"/>
+            <a:ext cx="0" cy="4690872"/>
           </a:xfrm>
           <a:prstGeom prst="line">
             <a:avLst/>
@@ -3698,69 +3659,69 @@
       </p:sp>
       <p:sp>
         <p:nvSpPr>
+          <p:cNvPr id="72" name="Text 70"/>
+          <p:cNvSpPr/>
+          <p:nvPr/>
+        </p:nvSpPr>
+        <p:spPr>
+          <a:xfrm>
+            <a:off x="7744968" y="5733288"/>
+            <a:ext cx="1645920" cy="219456"/>
+          </a:xfrm>
+          <a:prstGeom prst="rect">
+            <a:avLst/>
+          </a:prstGeom>
+          <a:noFill/>
+          <a:ln/>
+        </p:spPr>
+        <p:txBody>
+          <a:bodyPr wrap="square" lIns="0" tIns="0" rIns="0" bIns="0" rtlCol="0" anchor="ctr"/>
+          <a:lstStyle/>
+          <a:p>
+            <a:pPr algn="ctr" indent="0" marL="0">
+              <a:buNone/>
+            </a:pPr>
+            <a:r>
+              <a:rPr lang="en-US" sz="850" dirty="0">
+                <a:solidFill>
+                  <a:srgbClr val="6B7480"/>
+                </a:solidFill>
+                <a:latin typeface="Garamond" pitchFamily="34" charset="0"/>
+                <a:ea typeface="Garamond" pitchFamily="34" charset="-122"/>
+                <a:cs typeface="Garamond" pitchFamily="34" charset="-120"/>
+              </a:rPr>
+              <a:t>2020 reclassification</a:t>
+            </a:r>
+            <a:endParaRPr lang="en-US" sz="850" dirty="0"/>
+          </a:p>
+        </p:txBody>
+      </p:sp>
+      <p:sp>
+        <p:nvSpPr>
           <p:cNvPr id="73" name="Text 71"/>
           <p:cNvSpPr/>
           <p:nvPr/>
         </p:nvSpPr>
         <p:spPr>
           <a:xfrm>
-            <a:off x="7744968" y="5779008"/>
-            <a:ext cx="1645920" cy="219456"/>
-          </a:xfrm>
-          <a:prstGeom prst="rect">
-            <a:avLst/>
-          </a:prstGeom>
-          <a:noFill/>
-          <a:ln/>
-        </p:spPr>
-        <p:txBody>
-          <a:bodyPr wrap="square" lIns="0" tIns="0" rIns="0" bIns="0" rtlCol="0" anchor="ctr"/>
+            <a:off x="1691640" y="6099048"/>
+            <a:ext cx="10250424" cy="777240"/>
+          </a:xfrm>
+          <a:prstGeom prst="rect">
+            <a:avLst/>
+          </a:prstGeom>
+          <a:noFill/>
+          <a:ln/>
+        </p:spPr>
+        <p:txBody>
+          <a:bodyPr wrap="square" lIns="0" tIns="0" rIns="0" bIns="0" rtlCol="0" anchor="t"/>
           <a:lstStyle/>
           <a:p>
             <a:pPr algn="ctr" indent="0" marL="0">
               <a:buNone/>
             </a:pPr>
             <a:r>
-              <a:rPr lang="en-US" sz="850" dirty="0">
-                <a:solidFill>
-                  <a:srgbClr val="6B7480"/>
-                </a:solidFill>
-                <a:latin typeface="Garamond" pitchFamily="34" charset="0"/>
-                <a:ea typeface="Garamond" pitchFamily="34" charset="-122"/>
-                <a:cs typeface="Garamond" pitchFamily="34" charset="-120"/>
-              </a:rPr>
-              <a:t>2020 reclassification</a:t>
-            </a:r>
-            <a:endParaRPr lang="en-US" sz="850" dirty="0"/>
-          </a:p>
-        </p:txBody>
-      </p:sp>
-      <p:sp>
-        <p:nvSpPr>
-          <p:cNvPr id="74" name="Text 72"/>
-          <p:cNvSpPr/>
-          <p:nvPr/>
-        </p:nvSpPr>
-        <p:spPr>
-          <a:xfrm>
-            <a:off x="502920" y="6071616"/>
-            <a:ext cx="11155680" cy="777240"/>
-          </a:xfrm>
-          <a:prstGeom prst="rect">
-            <a:avLst/>
-          </a:prstGeom>
-          <a:noFill/>
-          <a:ln/>
-        </p:spPr>
-        <p:txBody>
-          <a:bodyPr wrap="square" lIns="0" tIns="0" rIns="0" bIns="0" rtlCol="0" anchor="t"/>
-          <a:lstStyle/>
-          <a:p>
-            <a:pPr indent="0" marL="0">
-              <a:buNone/>
-            </a:pPr>
-            <a:r>
-              <a:rPr lang="en-US" sz="1050" b="1" dirty="0">
+              <a:rPr lang="en-US" sz="1100" b="1" dirty="0">
                 <a:solidFill>
                   <a:srgbClr val="1A2430"/>
                 </a:solidFill>
@@ -3768,16 +3729,16 @@
                 <a:ea typeface="Garamond" pitchFamily="34" charset="-122"/>
                 <a:cs typeface="Garamond" pitchFamily="34" charset="-120"/>
               </a:rPr>
-              <a:t>Traceable as a block:  </a:t>
-            </a:r>
-            <a:pPr indent="0" marL="0">
+              <a:t>Traceable as a block: </a:t>
+            </a:r>
+            <a:pPr algn="ctr" indent="0" marL="0">
               <a:spcAft>
-                <a:spcPts val="400"/>
+                <a:spcPts val="500"/>
               </a:spcAft>
               <a:buNone/>
             </a:pPr>
             <a:r>
-              <a:rPr lang="en-US" sz="1050" dirty="0">
+              <a:rPr lang="en-US" sz="1100" dirty="0">
                 <a:solidFill>
                   <a:srgbClr val="1A2430"/>
                 </a:solidFill>
@@ -3787,52 +3748,24 @@
               </a:rPr>
               <a:t>the K–12 teaching group maps one-to-one across the three classifications — every figure uses the union, never a sub-code across regimes.</a:t>
             </a:r>
-            <a:endParaRPr lang="en-US" sz="1050" dirty="0"/>
-          </a:p>
-          <a:p>
-            <a:pPr indent="0" marL="0">
-              <a:buNone/>
-            </a:pPr>
-            <a:r>
-              <a:rPr lang="en-US" sz="950" b="1" dirty="0">
-                <a:solidFill>
-                  <a:srgbClr val="6B7480"/>
-                </a:solidFill>
-                <a:latin typeface="Garamond" pitchFamily="34" charset="0"/>
-                <a:ea typeface="Garamond" pitchFamily="34" charset="-122"/>
-                <a:cs typeface="Garamond" pitchFamily="34" charset="-120"/>
-              </a:rPr>
-              <a:t>† </a:t>
-            </a:r>
-            <a:pPr indent="0" marL="0">
-              <a:buNone/>
-            </a:pPr>
-            <a:r>
-              <a:rPr lang="en-US" sz="950" dirty="0">
-                <a:solidFill>
-                  <a:srgbClr val="6B7480"/>
-                </a:solidFill>
-                <a:latin typeface="Garamond" pitchFamily="34" charset="0"/>
-                <a:ea typeface="Garamond" pitchFamily="34" charset="-122"/>
-                <a:cs typeface="Garamond" pitchFamily="34" charset="-120"/>
-              </a:rPr>
-              <a:t>middle-school teachers sit under elementary or secondary before 2003, with elementary (2310) after.      </a:t>
-            </a:r>
-            <a:pPr indent="0" marL="0">
-              <a:buNone/>
-            </a:pPr>
-            <a:r>
-              <a:rPr lang="en-US" sz="950" dirty="0">
-                <a:solidFill>
-                  <a:srgbClr val="6B7480"/>
-                </a:solidFill>
-                <a:latin typeface="Garamond" pitchFamily="34" charset="0"/>
-                <a:ea typeface="Garamond" pitchFamily="34" charset="-122"/>
-                <a:cs typeface="Garamond" pitchFamily="34" charset="-120"/>
-              </a:rPr>
-              <a:t>Never included: postsecondary (2200s) · tutors (2350) · teaching assistants (2540/2545) · childcare workers (4600) · administrators (0230).</a:t>
-            </a:r>
-            <a:endParaRPr lang="en-US" sz="1050" dirty="0"/>
+            <a:endParaRPr lang="en-US" sz="1100" dirty="0"/>
+          </a:p>
+          <a:p>
+            <a:pPr algn="ctr" indent="0" marL="0">
+              <a:buNone/>
+            </a:pPr>
+            <a:r>
+              <a:rPr lang="en-US" sz="1000" dirty="0">
+                <a:solidFill>
+                  <a:srgbClr val="55606B"/>
+                </a:solidFill>
+                <a:latin typeface="Garamond" pitchFamily="34" charset="0"/>
+                <a:ea typeface="Garamond" pitchFamily="34" charset="-122"/>
+                <a:cs typeface="Garamond" pitchFamily="34" charset="-120"/>
+              </a:rPr>
+              <a:t>† middle-school teachers sit under elementary or secondary before 2003, with elementary (2310) after.  ·  Never included: postsecondary, tutors, teaching assistants, childcare workers, administrators.</a:t>
+            </a:r>
+            <a:endParaRPr lang="en-US" sz="1100" dirty="0"/>
           </a:p>
         </p:txBody>
       </p:sp>

</xml_diff>